<commit_message>
Update W7 materials for retry and lease evidence
</commit_message>
<xml_diff>
--- a/submissions/week07/W07_Team11.pptx
+++ b/submissions/week07/W07_Team11.pptx
@@ -2,24 +2,24 @@
 <file path=ppt/presentation.xml><?xml version="1.0" encoding="utf-8"?>
 <p:presentation xmlns:p="http://schemas.openxmlformats.org/presentationml/2006/main">
   <p:sldMasterIdLst>
-    <p:sldMasterId xmlns:r="http://schemas.openxmlformats.org/officeDocument/2006/relationships" id="2147483648" r:id="Rd519542bf0c84c0a"/>
+    <p:sldMasterId xmlns:r="http://schemas.openxmlformats.org/officeDocument/2006/relationships" id="2147483648" r:id="R7735f6b9bd6349c7"/>
   </p:sldMasterIdLst>
   <p:notesMasterIdLst>
-    <p:notesMasterId xmlns:r="http://schemas.openxmlformats.org/officeDocument/2006/relationships" r:id="R7114196b5f0e45b5"/>
+    <p:notesMasterId xmlns:r="http://schemas.openxmlformats.org/officeDocument/2006/relationships" r:id="R29dd9400c6704fbf"/>
   </p:notesMasterIdLst>
   <p:sldIdLst>
-    <p:sldId xmlns:r="http://schemas.openxmlformats.org/officeDocument/2006/relationships" id="256" r:id="R7e94f36cb0874fec"/>
-    <p:sldId xmlns:r="http://schemas.openxmlformats.org/officeDocument/2006/relationships" id="257" r:id="Rc51b5cfb7e6d4481"/>
-    <p:sldId xmlns:r="http://schemas.openxmlformats.org/officeDocument/2006/relationships" id="258" r:id="Rad716d68d7ce4821"/>
-    <p:sldId xmlns:r="http://schemas.openxmlformats.org/officeDocument/2006/relationships" id="259" r:id="R6e0a05f354a4492e"/>
-    <p:sldId xmlns:r="http://schemas.openxmlformats.org/officeDocument/2006/relationships" id="260" r:id="Rf14fa29034214985"/>
-    <p:sldId xmlns:r="http://schemas.openxmlformats.org/officeDocument/2006/relationships" id="261" r:id="R4785c0a3691c4fb5"/>
-    <p:sldId xmlns:r="http://schemas.openxmlformats.org/officeDocument/2006/relationships" id="262" r:id="Rf7d66751c9b34581"/>
-    <p:sldId xmlns:r="http://schemas.openxmlformats.org/officeDocument/2006/relationships" id="263" r:id="Rdadaa601bc5643ac"/>
-    <p:sldId xmlns:r="http://schemas.openxmlformats.org/officeDocument/2006/relationships" id="264" r:id="R5dbc022bc7f346a5"/>
-    <p:sldId xmlns:r="http://schemas.openxmlformats.org/officeDocument/2006/relationships" id="265" r:id="R51a927498b904fa4"/>
-    <p:sldId xmlns:r="http://schemas.openxmlformats.org/officeDocument/2006/relationships" id="266" r:id="R5c006dfcf75e451e"/>
-    <p:sldId xmlns:r="http://schemas.openxmlformats.org/officeDocument/2006/relationships" id="267" r:id="R331f5f24a1e24d01"/>
+    <p:sldId xmlns:r="http://schemas.openxmlformats.org/officeDocument/2006/relationships" id="256" r:id="R48c36623389b4882"/>
+    <p:sldId xmlns:r="http://schemas.openxmlformats.org/officeDocument/2006/relationships" id="257" r:id="R01a8d2d247fb45b9"/>
+    <p:sldId xmlns:r="http://schemas.openxmlformats.org/officeDocument/2006/relationships" id="258" r:id="Ra76e51e58d3a4221"/>
+    <p:sldId xmlns:r="http://schemas.openxmlformats.org/officeDocument/2006/relationships" id="259" r:id="Ra81dcd80fd5d494d"/>
+    <p:sldId xmlns:r="http://schemas.openxmlformats.org/officeDocument/2006/relationships" id="260" r:id="Rf8a2d6c6a611412a"/>
+    <p:sldId xmlns:r="http://schemas.openxmlformats.org/officeDocument/2006/relationships" id="261" r:id="Rbe1063bbaf6948a5"/>
+    <p:sldId xmlns:r="http://schemas.openxmlformats.org/officeDocument/2006/relationships" id="262" r:id="R950cc68787634392"/>
+    <p:sldId xmlns:r="http://schemas.openxmlformats.org/officeDocument/2006/relationships" id="263" r:id="Rdfb2b801c50e469b"/>
+    <p:sldId xmlns:r="http://schemas.openxmlformats.org/officeDocument/2006/relationships" id="264" r:id="R68c5367ff62d415c"/>
+    <p:sldId xmlns:r="http://schemas.openxmlformats.org/officeDocument/2006/relationships" id="265" r:id="R34bc98cd34814bd1"/>
+    <p:sldId xmlns:r="http://schemas.openxmlformats.org/officeDocument/2006/relationships" id="266" r:id="Ra894f52f15a14075"/>
+    <p:sldId xmlns:r="http://schemas.openxmlformats.org/officeDocument/2006/relationships" id="267" r:id="Rc076a1a7713a48ad"/>
   </p:sldIdLst>
   <p:sldSz cx="12192000" cy="6858000"/>
   <p:notesSz cx="6858000" cy="9144000"/>
@@ -1270,7 +1270,7 @@
           <p:cNvPr id="3" name="Title">
             <a:extLst xmlns:a="http://schemas.openxmlformats.org/drawingml/2006/main">
               <a:ext uri="{FF2B5EF4-FFF2-40B4-BE49-F238E27FC236}">
-                <a16:creationId xmlns:a16="http://schemas.microsoft.com/office/drawing/2014/main" id="{CC8D5F05-DA4F-4C40-9560-1B7DB7956092}"/>
+                <a16:creationId xmlns:a16="http://schemas.microsoft.com/office/drawing/2014/main" id="{509476F3-4C2D-4B45-BED5-631F316A7539}"/>
               </a:ext>
             </a:extLst>
           </p:cNvPr>
@@ -1499,7 +1499,7 @@
           <p:cNvPr id="2" name="Subtitle">
             <a:extLst xmlns:a="http://schemas.openxmlformats.org/drawingml/2006/main">
               <a:ext uri="{FF2B5EF4-FFF2-40B4-BE49-F238E27FC236}">
-                <a16:creationId xmlns:a16="http://schemas.microsoft.com/office/drawing/2014/main" id="{A93D53B0-8BC5-4C52-9345-987C9BA4A72B}"/>
+                <a16:creationId xmlns:a16="http://schemas.microsoft.com/office/drawing/2014/main" id="{09B2B6AF-2D78-4927-91DC-EAFFC110995A}"/>
               </a:ext>
             </a:extLst>
           </p:cNvPr>
@@ -1745,7 +1745,7 @@
           <p:cNvPr id="2" name="Section title">
             <a:extLst xmlns:a="http://schemas.openxmlformats.org/drawingml/2006/main">
               <a:ext uri="{FF2B5EF4-FFF2-40B4-BE49-F238E27FC236}">
-                <a16:creationId xmlns:a16="http://schemas.microsoft.com/office/drawing/2014/main" id="{F05D34BB-AB41-4C9D-8D48-F749FCDF3DE7}"/>
+                <a16:creationId xmlns:a16="http://schemas.microsoft.com/office/drawing/2014/main" id="{D74E381C-22A3-4311-89CF-90E9A342D1F1}"/>
               </a:ext>
             </a:extLst>
           </p:cNvPr>
@@ -1991,7 +1991,7 @@
           <p:cNvPr id="3" name="Title">
             <a:extLst xmlns:a="http://schemas.openxmlformats.org/drawingml/2006/main">
               <a:ext uri="{FF2B5EF4-FFF2-40B4-BE49-F238E27FC236}">
-                <a16:creationId xmlns:a16="http://schemas.microsoft.com/office/drawing/2014/main" id="{F6039CE5-5691-49C2-8F96-0DCC358EB156}"/>
+                <a16:creationId xmlns:a16="http://schemas.microsoft.com/office/drawing/2014/main" id="{ED3D5CAF-332D-4C84-96C9-1A948F74D99B}"/>
               </a:ext>
             </a:extLst>
           </p:cNvPr>
@@ -2220,7 +2220,7 @@
           <p:cNvPr id="2" name="Body">
             <a:extLst xmlns:a="http://schemas.openxmlformats.org/drawingml/2006/main">
               <a:ext uri="{FF2B5EF4-FFF2-40B4-BE49-F238E27FC236}">
-                <a16:creationId xmlns:a16="http://schemas.microsoft.com/office/drawing/2014/main" id="{AE3FDFEA-6446-46F2-9F29-56E00A69F2F6}"/>
+                <a16:creationId xmlns:a16="http://schemas.microsoft.com/office/drawing/2014/main" id="{B01F02DB-3DCF-45B2-8F09-9B43A089E7DB}"/>
               </a:ext>
             </a:extLst>
           </p:cNvPr>
@@ -2466,7 +2466,7 @@
           <p:cNvPr id="4" name="Title">
             <a:extLst xmlns:a="http://schemas.openxmlformats.org/drawingml/2006/main">
               <a:ext uri="{FF2B5EF4-FFF2-40B4-BE49-F238E27FC236}">
-                <a16:creationId xmlns:a16="http://schemas.microsoft.com/office/drawing/2014/main" id="{5A322B8D-51C1-4AC0-958E-59C887E86346}"/>
+                <a16:creationId xmlns:a16="http://schemas.microsoft.com/office/drawing/2014/main" id="{D30EE4DD-C74F-47ED-9863-22F2E9DE84A4}"/>
               </a:ext>
             </a:extLst>
           </p:cNvPr>
@@ -2695,7 +2695,7 @@
           <p:cNvPr id="2" name="Left column">
             <a:extLst xmlns:a="http://schemas.openxmlformats.org/drawingml/2006/main">
               <a:ext uri="{FF2B5EF4-FFF2-40B4-BE49-F238E27FC236}">
-                <a16:creationId xmlns:a16="http://schemas.microsoft.com/office/drawing/2014/main" id="{462FEEC4-E4E7-4F64-8CCC-68F9C4676097}"/>
+                <a16:creationId xmlns:a16="http://schemas.microsoft.com/office/drawing/2014/main" id="{5C280892-B90E-4EC2-8C72-C2EAA105C263}"/>
               </a:ext>
             </a:extLst>
           </p:cNvPr>
@@ -2924,7 +2924,7 @@
           <p:cNvPr id="3" name="Right column">
             <a:extLst xmlns:a="http://schemas.openxmlformats.org/drawingml/2006/main">
               <a:ext uri="{FF2B5EF4-FFF2-40B4-BE49-F238E27FC236}">
-                <a16:creationId xmlns:a16="http://schemas.microsoft.com/office/drawing/2014/main" id="{09C4412B-6025-464E-A387-3AEE298C8F49}"/>
+                <a16:creationId xmlns:a16="http://schemas.microsoft.com/office/drawing/2014/main" id="{08AE3046-1378-4EA8-908E-EE44A4CD5981}"/>
               </a:ext>
             </a:extLst>
           </p:cNvPr>
@@ -3170,7 +3170,7 @@
           <p:cNvPr id="3" name="Title">
             <a:extLst xmlns:a="http://schemas.openxmlformats.org/drawingml/2006/main">
               <a:ext uri="{FF2B5EF4-FFF2-40B4-BE49-F238E27FC236}">
-                <a16:creationId xmlns:a16="http://schemas.microsoft.com/office/drawing/2014/main" id="{549E609C-1325-4EEC-ABDE-292B1D1957DC}"/>
+                <a16:creationId xmlns:a16="http://schemas.microsoft.com/office/drawing/2014/main" id="{4B913D04-E393-4F30-B85C-E50F3672CFFB}"/>
               </a:ext>
             </a:extLst>
           </p:cNvPr>
@@ -3399,7 +3399,7 @@
           <p:cNvPr id="2" name="Left column">
             <a:extLst xmlns:a="http://schemas.openxmlformats.org/drawingml/2006/main">
               <a:ext uri="{FF2B5EF4-FFF2-40B4-BE49-F238E27FC236}">
-                <a16:creationId xmlns:a16="http://schemas.microsoft.com/office/drawing/2014/main" id="{441D226E-988E-4317-9A5F-7DFB7F506E57}"/>
+                <a16:creationId xmlns:a16="http://schemas.microsoft.com/office/drawing/2014/main" id="{6353FB56-B603-4AF4-ADBC-56C01BF3B82E}"/>
               </a:ext>
             </a:extLst>
           </p:cNvPr>
@@ -3666,12 +3666,12 @@
   </p:cSld>
   <p:clrMap bg1="lt1" tx1="dk1" bg2="lt2" tx2="dk2" accent1="accent1" accent2="accent2" accent3="accent3" accent4="accent4" accent5="accent5" accent6="accent6" hlink="hlink" folHlink="folHlink"/>
   <p:sldLayoutIdLst>
-    <p:sldLayoutId xmlns:r="http://schemas.openxmlformats.org/officeDocument/2006/relationships" id="2147483649" r:id="R385e90a6ee2a422a"/>
-    <p:sldLayoutId xmlns:r="http://schemas.openxmlformats.org/officeDocument/2006/relationships" id="2147483650" r:id="Rfe46d313943a4d0b"/>
-    <p:sldLayoutId xmlns:r="http://schemas.openxmlformats.org/officeDocument/2006/relationships" id="2147483651" r:id="Rd43ba752c23a4170"/>
-    <p:sldLayoutId xmlns:r="http://schemas.openxmlformats.org/officeDocument/2006/relationships" id="2147483652" r:id="Rb9a54d567caa40c8"/>
-    <p:sldLayoutId xmlns:r="http://schemas.openxmlformats.org/officeDocument/2006/relationships" id="2147483653" r:id="R526d86f3a593437d"/>
-    <p:sldLayoutId xmlns:r="http://schemas.openxmlformats.org/officeDocument/2006/relationships" id="2147483654" r:id="R8db74fc83d0c4806"/>
+    <p:sldLayoutId xmlns:r="http://schemas.openxmlformats.org/officeDocument/2006/relationships" id="2147483649" r:id="R45afabc2059f4eb6"/>
+    <p:sldLayoutId xmlns:r="http://schemas.openxmlformats.org/officeDocument/2006/relationships" id="2147483650" r:id="R7ef7aeeb055a472d"/>
+    <p:sldLayoutId xmlns:r="http://schemas.openxmlformats.org/officeDocument/2006/relationships" id="2147483651" r:id="R524047b7bb3a48ef"/>
+    <p:sldLayoutId xmlns:r="http://schemas.openxmlformats.org/officeDocument/2006/relationships" id="2147483652" r:id="Rd6cd31216d574590"/>
+    <p:sldLayoutId xmlns:r="http://schemas.openxmlformats.org/officeDocument/2006/relationships" id="2147483653" r:id="Rff70977b545c40e7"/>
+    <p:sldLayoutId xmlns:r="http://schemas.openxmlformats.org/officeDocument/2006/relationships" id="2147483654" r:id="Rc501fd1bd6b64e66"/>
   </p:sldLayoutIdLst>
   <p:txStyles>
     <p:titleStyle>
@@ -4222,7 +4222,7 @@
           <p:cNvPr id="6" name="cover-label">
             <a:extLst xmlns:a="http://schemas.openxmlformats.org/drawingml/2006/main">
               <a:ext uri="{FF2B5EF4-FFF2-40B4-BE49-F238E27FC236}">
-                <a16:creationId xmlns:a16="http://schemas.microsoft.com/office/drawing/2014/main" id="{038909C9-AB46-4184-890D-19099F862944}"/>
+                <a16:creationId xmlns:a16="http://schemas.microsoft.com/office/drawing/2014/main" id="{4E5839E1-55E2-41BF-8923-49963614EA65}"/>
               </a:ext>
             </a:extLst>
           </p:cNvPr>
@@ -4349,7 +4349,7 @@
           <p:cNvPr id="2" name="cover-title">
             <a:extLst xmlns:a="http://schemas.openxmlformats.org/drawingml/2006/main">
               <a:ext uri="{FF2B5EF4-FFF2-40B4-BE49-F238E27FC236}">
-                <a16:creationId xmlns:a16="http://schemas.microsoft.com/office/drawing/2014/main" id="{85FD5A54-1231-41E3-BA03-91BD388254E5}"/>
+                <a16:creationId xmlns:a16="http://schemas.microsoft.com/office/drawing/2014/main" id="{DB6B3C56-BF74-49C4-BB38-B6D2D9FA4F4E}"/>
               </a:ext>
             </a:extLst>
           </p:cNvPr>
@@ -4476,7 +4476,7 @@
           <p:cNvPr id="3" name="cover-subtitle">
             <a:extLst xmlns:a="http://schemas.openxmlformats.org/drawingml/2006/main">
               <a:ext uri="{FF2B5EF4-FFF2-40B4-BE49-F238E27FC236}">
-                <a16:creationId xmlns:a16="http://schemas.microsoft.com/office/drawing/2014/main" id="{9D62FEFA-CAEF-40D2-9FC7-DCAEBC7C9503}"/>
+                <a16:creationId xmlns:a16="http://schemas.microsoft.com/office/drawing/2014/main" id="{8D971F10-C964-4FAA-97A9-D7EE9E2E1D19}"/>
               </a:ext>
             </a:extLst>
           </p:cNvPr>
@@ -4603,7 +4603,7 @@
           <p:cNvPr id="4" name="cover-rule">
             <a:extLst xmlns:a="http://schemas.openxmlformats.org/drawingml/2006/main">
               <a:ext uri="{FF2B5EF4-FFF2-40B4-BE49-F238E27FC236}">
-                <a16:creationId xmlns:a16="http://schemas.microsoft.com/office/drawing/2014/main" id="{39FBEAA2-C358-4BDC-9960-86DD1742F122}"/>
+                <a16:creationId xmlns:a16="http://schemas.microsoft.com/office/drawing/2014/main" id="{D8EED17F-63D8-40F3-81FE-70CD886DD4FA}"/>
               </a:ext>
             </a:extLst>
           </p:cNvPr>
@@ -4634,7 +4634,7 @@
           <p:cNvPr id="5" name="cover-meta">
             <a:extLst xmlns:a="http://schemas.openxmlformats.org/drawingml/2006/main">
               <a:ext uri="{FF2B5EF4-FFF2-40B4-BE49-F238E27FC236}">
-                <a16:creationId xmlns:a16="http://schemas.microsoft.com/office/drawing/2014/main" id="{523B00C4-22DC-4D15-8601-FF1B2F1C018B}"/>
+                <a16:creationId xmlns:a16="http://schemas.microsoft.com/office/drawing/2014/main" id="{AFD819B7-ED0D-4182-9251-397CF0DA4795}"/>
               </a:ext>
             </a:extLst>
           </p:cNvPr>
@@ -4759,7 +4759,7 @@
     </p:spTree>
     <p:extLst>
       <p:ext uri="{BB962C8B-B14F-4D97-AF65-F5344CB8AC3E}">
-        <p14:creationId xmlns:p14="http://schemas.microsoft.com/office/powerpoint/2010/main" val="419138897"/>
+        <p14:creationId xmlns:p14="http://schemas.microsoft.com/office/powerpoint/2010/main" val="641339905"/>
       </p:ext>
     </p:extLst>
   </p:cSld>
@@ -4790,7 +4790,7 @@
           <p:cNvPr id="19" name="eyebrow">
             <a:extLst xmlns:a="http://schemas.openxmlformats.org/drawingml/2006/main">
               <a:ext uri="{FF2B5EF4-FFF2-40B4-BE49-F238E27FC236}">
-                <a16:creationId xmlns:a16="http://schemas.microsoft.com/office/drawing/2014/main" id="{0D82CADB-B7DA-44D5-8E8E-46085E70488C}"/>
+                <a16:creationId xmlns:a16="http://schemas.microsoft.com/office/drawing/2014/main" id="{6ED28E49-3CE8-41B7-A732-511B2EC87C28}"/>
               </a:ext>
             </a:extLst>
           </p:cNvPr>
@@ -4917,7 +4917,7 @@
           <p:cNvPr id="2" name="page">
             <a:extLst xmlns:a="http://schemas.openxmlformats.org/drawingml/2006/main">
               <a:ext uri="{FF2B5EF4-FFF2-40B4-BE49-F238E27FC236}">
-                <a16:creationId xmlns:a16="http://schemas.microsoft.com/office/drawing/2014/main" id="{0E3D38C5-9D74-41A9-A2E8-AE9B84029959}"/>
+                <a16:creationId xmlns:a16="http://schemas.microsoft.com/office/drawing/2014/main" id="{9FD204E9-8045-4960-A8EC-7A8C7CFF3DAA}"/>
               </a:ext>
             </a:extLst>
           </p:cNvPr>
@@ -5044,7 +5044,7 @@
           <p:cNvPr id="3" name="acceptance-rule">
             <a:extLst xmlns:a="http://schemas.openxmlformats.org/drawingml/2006/main">
               <a:ext uri="{FF2B5EF4-FFF2-40B4-BE49-F238E27FC236}">
-                <a16:creationId xmlns:a16="http://schemas.microsoft.com/office/drawing/2014/main" id="{EC946B51-D6E4-443E-9D57-1E65E8070F10}"/>
+                <a16:creationId xmlns:a16="http://schemas.microsoft.com/office/drawing/2014/main" id="{254DDC3E-8A2B-4088-B062-32BB181222CB}"/>
               </a:ext>
             </a:extLst>
           </p:cNvPr>
@@ -5075,7 +5075,7 @@
           <p:cNvPr id="4" name="title">
             <a:extLst xmlns:a="http://schemas.openxmlformats.org/drawingml/2006/main">
               <a:ext uri="{FF2B5EF4-FFF2-40B4-BE49-F238E27FC236}">
-                <a16:creationId xmlns:a16="http://schemas.microsoft.com/office/drawing/2014/main" id="{5C05D14D-CF44-4D93-B2B6-1D9C5F6E3CCE}"/>
+                <a16:creationId xmlns:a16="http://schemas.microsoft.com/office/drawing/2014/main" id="{A3DBE1E2-360A-4081-BE43-FE165485989A}"/>
               </a:ext>
             </a:extLst>
           </p:cNvPr>
@@ -5202,7 +5202,7 @@
           <p:cNvPr id="5" name="evidence-rule-0">
             <a:extLst xmlns:a="http://schemas.openxmlformats.org/drawingml/2006/main">
               <a:ext uri="{FF2B5EF4-FFF2-40B4-BE49-F238E27FC236}">
-                <a16:creationId xmlns:a16="http://schemas.microsoft.com/office/drawing/2014/main" id="{7EA8CA13-EBE3-4267-B320-E4525FA61E3E}"/>
+                <a16:creationId xmlns:a16="http://schemas.microsoft.com/office/drawing/2014/main" id="{70746BE1-BE64-4994-BE6A-89F8F2DC7BD3}"/>
               </a:ext>
             </a:extLst>
           </p:cNvPr>
@@ -5233,7 +5233,7 @@
           <p:cNvPr id="6" name="evidence-number-0">
             <a:extLst xmlns:a="http://schemas.openxmlformats.org/drawingml/2006/main">
               <a:ext uri="{FF2B5EF4-FFF2-40B4-BE49-F238E27FC236}">
-                <a16:creationId xmlns:a16="http://schemas.microsoft.com/office/drawing/2014/main" id="{84FFA443-CE3E-47C0-9B02-1018C76EAC60}"/>
+                <a16:creationId xmlns:a16="http://schemas.microsoft.com/office/drawing/2014/main" id="{EAF6F036-DC04-4AE6-9F35-549809930994}"/>
               </a:ext>
             </a:extLst>
           </p:cNvPr>
@@ -5360,7 +5360,7 @@
           <p:cNvPr id="7" name="evidence-label-0">
             <a:extLst xmlns:a="http://schemas.openxmlformats.org/drawingml/2006/main">
               <a:ext uri="{FF2B5EF4-FFF2-40B4-BE49-F238E27FC236}">
-                <a16:creationId xmlns:a16="http://schemas.microsoft.com/office/drawing/2014/main" id="{EFA22FA4-3FF3-44D3-B3F6-E9D593B0A8EB}"/>
+                <a16:creationId xmlns:a16="http://schemas.microsoft.com/office/drawing/2014/main" id="{0DBBCFA2-D39F-4BDD-B775-833D3D941CB4}"/>
               </a:ext>
             </a:extLst>
           </p:cNvPr>
@@ -5487,7 +5487,7 @@
           <p:cNvPr id="8" name="evidence-rule-1">
             <a:extLst xmlns:a="http://schemas.openxmlformats.org/drawingml/2006/main">
               <a:ext uri="{FF2B5EF4-FFF2-40B4-BE49-F238E27FC236}">
-                <a16:creationId xmlns:a16="http://schemas.microsoft.com/office/drawing/2014/main" id="{CBF0AAB4-9125-4E1A-A89D-BD7A96899519}"/>
+                <a16:creationId xmlns:a16="http://schemas.microsoft.com/office/drawing/2014/main" id="{3C4D899F-5400-4C38-B48E-6597E6C32041}"/>
               </a:ext>
             </a:extLst>
           </p:cNvPr>
@@ -5518,7 +5518,7 @@
           <p:cNvPr id="9" name="evidence-number-1">
             <a:extLst xmlns:a="http://schemas.openxmlformats.org/drawingml/2006/main">
               <a:ext uri="{FF2B5EF4-FFF2-40B4-BE49-F238E27FC236}">
-                <a16:creationId xmlns:a16="http://schemas.microsoft.com/office/drawing/2014/main" id="{0E460EDA-919A-4272-A586-A7AF1E00A636}"/>
+                <a16:creationId xmlns:a16="http://schemas.microsoft.com/office/drawing/2014/main" id="{BAB99003-5B80-4668-BFF3-F85DD69C6D1B}"/>
               </a:ext>
             </a:extLst>
           </p:cNvPr>
@@ -5645,7 +5645,7 @@
           <p:cNvPr id="10" name="evidence-label-1">
             <a:extLst xmlns:a="http://schemas.openxmlformats.org/drawingml/2006/main">
               <a:ext uri="{FF2B5EF4-FFF2-40B4-BE49-F238E27FC236}">
-                <a16:creationId xmlns:a16="http://schemas.microsoft.com/office/drawing/2014/main" id="{CAEE7AF5-8942-419D-8BAB-B167FFB39C2C}"/>
+                <a16:creationId xmlns:a16="http://schemas.microsoft.com/office/drawing/2014/main" id="{44C33BC7-96ED-4C12-B8BA-1E46DFBE56A1}"/>
               </a:ext>
             </a:extLst>
           </p:cNvPr>
@@ -5772,7 +5772,7 @@
           <p:cNvPr id="11" name="evidence-rule-2">
             <a:extLst xmlns:a="http://schemas.openxmlformats.org/drawingml/2006/main">
               <a:ext uri="{FF2B5EF4-FFF2-40B4-BE49-F238E27FC236}">
-                <a16:creationId xmlns:a16="http://schemas.microsoft.com/office/drawing/2014/main" id="{77F58E19-0168-4F69-B8DE-ED1DC9BCF0B9}"/>
+                <a16:creationId xmlns:a16="http://schemas.microsoft.com/office/drawing/2014/main" id="{63D28E90-922B-4A14-8CF6-B09D532EC9D1}"/>
               </a:ext>
             </a:extLst>
           </p:cNvPr>
@@ -5803,7 +5803,7 @@
           <p:cNvPr id="12" name="evidence-number-2">
             <a:extLst xmlns:a="http://schemas.openxmlformats.org/drawingml/2006/main">
               <a:ext uri="{FF2B5EF4-FFF2-40B4-BE49-F238E27FC236}">
-                <a16:creationId xmlns:a16="http://schemas.microsoft.com/office/drawing/2014/main" id="{6D00BC33-1FE5-4A1D-AC32-ADC9A0A3DB3B}"/>
+                <a16:creationId xmlns:a16="http://schemas.microsoft.com/office/drawing/2014/main" id="{5126AD16-EF24-4F46-A166-F11EB69BFB5D}"/>
               </a:ext>
             </a:extLst>
           </p:cNvPr>
@@ -5930,7 +5930,7 @@
           <p:cNvPr id="13" name="evidence-label-2">
             <a:extLst xmlns:a="http://schemas.openxmlformats.org/drawingml/2006/main">
               <a:ext uri="{FF2B5EF4-FFF2-40B4-BE49-F238E27FC236}">
-                <a16:creationId xmlns:a16="http://schemas.microsoft.com/office/drawing/2014/main" id="{F9020A5C-1174-45FE-A152-197B4C928882}"/>
+                <a16:creationId xmlns:a16="http://schemas.microsoft.com/office/drawing/2014/main" id="{918910AA-097F-4FC1-9B6F-A13E586F72B0}"/>
               </a:ext>
             </a:extLst>
           </p:cNvPr>
@@ -6057,7 +6057,7 @@
           <p:cNvPr id="14" name="evidence-rule-3">
             <a:extLst xmlns:a="http://schemas.openxmlformats.org/drawingml/2006/main">
               <a:ext uri="{FF2B5EF4-FFF2-40B4-BE49-F238E27FC236}">
-                <a16:creationId xmlns:a16="http://schemas.microsoft.com/office/drawing/2014/main" id="{9DED48F1-90D9-4659-9924-AA0922E834C3}"/>
+                <a16:creationId xmlns:a16="http://schemas.microsoft.com/office/drawing/2014/main" id="{3ABBE12E-881F-4993-9666-799EAACD9927}"/>
               </a:ext>
             </a:extLst>
           </p:cNvPr>
@@ -6088,7 +6088,7 @@
           <p:cNvPr id="15" name="evidence-number-3">
             <a:extLst xmlns:a="http://schemas.openxmlformats.org/drawingml/2006/main">
               <a:ext uri="{FF2B5EF4-FFF2-40B4-BE49-F238E27FC236}">
-                <a16:creationId xmlns:a16="http://schemas.microsoft.com/office/drawing/2014/main" id="{76A70E7B-2F34-4A42-A487-F6A35C69A01F}"/>
+                <a16:creationId xmlns:a16="http://schemas.microsoft.com/office/drawing/2014/main" id="{6CBAB85C-FDD0-4450-9C25-2EDC794F6F15}"/>
               </a:ext>
             </a:extLst>
           </p:cNvPr>
@@ -6215,7 +6215,7 @@
           <p:cNvPr id="16" name="evidence-label-3">
             <a:extLst xmlns:a="http://schemas.openxmlformats.org/drawingml/2006/main">
               <a:ext uri="{FF2B5EF4-FFF2-40B4-BE49-F238E27FC236}">
-                <a16:creationId xmlns:a16="http://schemas.microsoft.com/office/drawing/2014/main" id="{F63717CE-0058-452A-8424-2F85F0546713}"/>
+                <a16:creationId xmlns:a16="http://schemas.microsoft.com/office/drawing/2014/main" id="{C7FF3A80-E246-4670-9BAF-8668F636C2B0}"/>
               </a:ext>
             </a:extLst>
           </p:cNvPr>
@@ -6342,7 +6342,7 @@
           <p:cNvPr id="17" name="acceptance-passage">
             <a:extLst xmlns:a="http://schemas.openxmlformats.org/drawingml/2006/main">
               <a:ext uri="{FF2B5EF4-FFF2-40B4-BE49-F238E27FC236}">
-                <a16:creationId xmlns:a16="http://schemas.microsoft.com/office/drawing/2014/main" id="{3979929D-CD7A-4579-A8E9-5E598F562506}"/>
+                <a16:creationId xmlns:a16="http://schemas.microsoft.com/office/drawing/2014/main" id="{26EB9C61-B112-40BD-8AE0-CC83D9A1AAED}"/>
               </a:ext>
             </a:extLst>
           </p:cNvPr>
@@ -6469,7 +6469,7 @@
           <p:cNvPr id="18" name="footer">
             <a:extLst xmlns:a="http://schemas.openxmlformats.org/drawingml/2006/main">
               <a:ext uri="{FF2B5EF4-FFF2-40B4-BE49-F238E27FC236}">
-                <a16:creationId xmlns:a16="http://schemas.microsoft.com/office/drawing/2014/main" id="{0FB6B088-EA21-45F8-BA42-B87AC1359959}"/>
+                <a16:creationId xmlns:a16="http://schemas.microsoft.com/office/drawing/2014/main" id="{B8D4409A-E39A-42E9-B149-EAD831DA0451}"/>
               </a:ext>
             </a:extLst>
           </p:cNvPr>
@@ -6594,7 +6594,7 @@
     </p:spTree>
     <p:extLst>
       <p:ext uri="{BB962C8B-B14F-4D97-AF65-F5344CB8AC3E}">
-        <p14:creationId xmlns:p14="http://schemas.microsoft.com/office/powerpoint/2010/main" val="114517070"/>
+        <p14:creationId xmlns:p14="http://schemas.microsoft.com/office/powerpoint/2010/main" val="105476693"/>
       </p:ext>
     </p:extLst>
   </p:cSld>
@@ -6625,7 +6625,7 @@
           <p:cNvPr id="15" name="eyebrow">
             <a:extLst xmlns:a="http://schemas.openxmlformats.org/drawingml/2006/main">
               <a:ext uri="{FF2B5EF4-FFF2-40B4-BE49-F238E27FC236}">
-                <a16:creationId xmlns:a16="http://schemas.microsoft.com/office/drawing/2014/main" id="{9C331F67-5D58-4980-9EBE-9C32898EDDBF}"/>
+                <a16:creationId xmlns:a16="http://schemas.microsoft.com/office/drawing/2014/main" id="{23CF0889-C7AB-451A-B3A0-9E32F4C8DA33}"/>
               </a:ext>
             </a:extLst>
           </p:cNvPr>
@@ -6752,7 +6752,7 @@
           <p:cNvPr id="2" name="page">
             <a:extLst xmlns:a="http://schemas.openxmlformats.org/drawingml/2006/main">
               <a:ext uri="{FF2B5EF4-FFF2-40B4-BE49-F238E27FC236}">
-                <a16:creationId xmlns:a16="http://schemas.microsoft.com/office/drawing/2014/main" id="{6507CCAB-D15B-4221-BFB1-4C91465C1599}"/>
+                <a16:creationId xmlns:a16="http://schemas.microsoft.com/office/drawing/2014/main" id="{D8F579B7-C763-4A9E-9AB9-2F072659B29B}"/>
               </a:ext>
             </a:extLst>
           </p:cNvPr>
@@ -6879,7 +6879,7 @@
           <p:cNvPr id="3" name="limits-rule">
             <a:extLst xmlns:a="http://schemas.openxmlformats.org/drawingml/2006/main">
               <a:ext uri="{FF2B5EF4-FFF2-40B4-BE49-F238E27FC236}">
-                <a16:creationId xmlns:a16="http://schemas.microsoft.com/office/drawing/2014/main" id="{BADAA87D-9213-4425-8FAE-0D6CF0ED016F}"/>
+                <a16:creationId xmlns:a16="http://schemas.microsoft.com/office/drawing/2014/main" id="{B4E9AF85-31C8-401F-8285-D8F3799186E3}"/>
               </a:ext>
             </a:extLst>
           </p:cNvPr>
@@ -6910,7 +6910,7 @@
           <p:cNvPr id="4" name="title">
             <a:extLst xmlns:a="http://schemas.openxmlformats.org/drawingml/2006/main">
               <a:ext uri="{FF2B5EF4-FFF2-40B4-BE49-F238E27FC236}">
-                <a16:creationId xmlns:a16="http://schemas.microsoft.com/office/drawing/2014/main" id="{699C5BE6-FE96-460B-A92B-AA9E7337A635}"/>
+                <a16:creationId xmlns:a16="http://schemas.microsoft.com/office/drawing/2014/main" id="{AF91B098-E850-44E7-970C-CEBB484C91FB}"/>
               </a:ext>
             </a:extLst>
           </p:cNvPr>
@@ -7037,7 +7037,7 @@
           <p:cNvPr id="5" name="limit-rule-0">
             <a:extLst xmlns:a="http://schemas.openxmlformats.org/drawingml/2006/main">
               <a:ext uri="{FF2B5EF4-FFF2-40B4-BE49-F238E27FC236}">
-                <a16:creationId xmlns:a16="http://schemas.microsoft.com/office/drawing/2014/main" id="{501C8814-6855-41A7-967F-929F67B47E2C}"/>
+                <a16:creationId xmlns:a16="http://schemas.microsoft.com/office/drawing/2014/main" id="{D738174E-2D19-4CBF-9192-8DB7CB5FFF6D}"/>
               </a:ext>
             </a:extLst>
           </p:cNvPr>
@@ -7068,7 +7068,7 @@
           <p:cNvPr id="6" name="limit-title-0">
             <a:extLst xmlns:a="http://schemas.openxmlformats.org/drawingml/2006/main">
               <a:ext uri="{FF2B5EF4-FFF2-40B4-BE49-F238E27FC236}">
-                <a16:creationId xmlns:a16="http://schemas.microsoft.com/office/drawing/2014/main" id="{F90A4426-BAEC-486B-830D-A24C3F85C6E1}"/>
+                <a16:creationId xmlns:a16="http://schemas.microsoft.com/office/drawing/2014/main" id="{4C32AFE3-F08F-47CD-A2D9-F32A9878BA80}"/>
               </a:ext>
             </a:extLst>
           </p:cNvPr>
@@ -7195,7 +7195,7 @@
           <p:cNvPr id="7" name="limit-body-0">
             <a:extLst xmlns:a="http://schemas.openxmlformats.org/drawingml/2006/main">
               <a:ext uri="{FF2B5EF4-FFF2-40B4-BE49-F238E27FC236}">
-                <a16:creationId xmlns:a16="http://schemas.microsoft.com/office/drawing/2014/main" id="{E789DCDE-FDE6-4DA0-80EB-7D3DF8656EB3}"/>
+                <a16:creationId xmlns:a16="http://schemas.microsoft.com/office/drawing/2014/main" id="{E37A48A8-CF3A-46A3-95FD-FE01AF513A00}"/>
               </a:ext>
             </a:extLst>
           </p:cNvPr>
@@ -7322,7 +7322,7 @@
           <p:cNvPr id="8" name="limit-rule-1">
             <a:extLst xmlns:a="http://schemas.openxmlformats.org/drawingml/2006/main">
               <a:ext uri="{FF2B5EF4-FFF2-40B4-BE49-F238E27FC236}">
-                <a16:creationId xmlns:a16="http://schemas.microsoft.com/office/drawing/2014/main" id="{27915BBC-C048-4FD7-870A-64BFE59D5755}"/>
+                <a16:creationId xmlns:a16="http://schemas.microsoft.com/office/drawing/2014/main" id="{C3B809C2-D055-420A-A108-5C733059DF39}"/>
               </a:ext>
             </a:extLst>
           </p:cNvPr>
@@ -7353,7 +7353,7 @@
           <p:cNvPr id="9" name="limit-title-1">
             <a:extLst xmlns:a="http://schemas.openxmlformats.org/drawingml/2006/main">
               <a:ext uri="{FF2B5EF4-FFF2-40B4-BE49-F238E27FC236}">
-                <a16:creationId xmlns:a16="http://schemas.microsoft.com/office/drawing/2014/main" id="{43F572AF-C365-4696-9AC5-68B3524D5574}"/>
+                <a16:creationId xmlns:a16="http://schemas.microsoft.com/office/drawing/2014/main" id="{2A38318D-5FD4-4DCC-8A5F-D4182DF9D65A}"/>
               </a:ext>
             </a:extLst>
           </p:cNvPr>
@@ -7480,7 +7480,7 @@
           <p:cNvPr id="10" name="limit-body-1">
             <a:extLst xmlns:a="http://schemas.openxmlformats.org/drawingml/2006/main">
               <a:ext uri="{FF2B5EF4-FFF2-40B4-BE49-F238E27FC236}">
-                <a16:creationId xmlns:a16="http://schemas.microsoft.com/office/drawing/2014/main" id="{0D927079-672F-45C8-B70C-43FD34F8D51E}"/>
+                <a16:creationId xmlns:a16="http://schemas.microsoft.com/office/drawing/2014/main" id="{4872D6CB-9859-4583-86D7-0728FA771DD1}"/>
               </a:ext>
             </a:extLst>
           </p:cNvPr>
@@ -7597,7 +7597,7 @@
                   <a:srgbClr val="45556C"/>
                 </a:solidFill>
               </a:rPr>
-              <a:t>Manual retry exists. Automatic backoff, leases and stale-claim recovery remain open.</a:t>
+              <a:t>Retry, backoff and leases are implemented. Competing-worker load testing remains open.</a:t>
             </a:r>
           </a:p>
         </p:txBody>
@@ -7607,7 +7607,7 @@
           <p:cNvPr id="11" name="limit-rule-2">
             <a:extLst xmlns:a="http://schemas.openxmlformats.org/drawingml/2006/main">
               <a:ext uri="{FF2B5EF4-FFF2-40B4-BE49-F238E27FC236}">
-                <a16:creationId xmlns:a16="http://schemas.microsoft.com/office/drawing/2014/main" id="{DEA0AA24-E34E-439A-9D67-543DD92852C2}"/>
+                <a16:creationId xmlns:a16="http://schemas.microsoft.com/office/drawing/2014/main" id="{8AE9C157-885C-470F-8B8D-0163C4EA6CD1}"/>
               </a:ext>
             </a:extLst>
           </p:cNvPr>
@@ -7638,7 +7638,7 @@
           <p:cNvPr id="12" name="limit-title-2">
             <a:extLst xmlns:a="http://schemas.openxmlformats.org/drawingml/2006/main">
               <a:ext uri="{FF2B5EF4-FFF2-40B4-BE49-F238E27FC236}">
-                <a16:creationId xmlns:a16="http://schemas.microsoft.com/office/drawing/2014/main" id="{C5E7F6F2-70B2-4D7E-8C9A-903C344BC295}"/>
+                <a16:creationId xmlns:a16="http://schemas.microsoft.com/office/drawing/2014/main" id="{A630EC89-EB61-4A98-904B-347651CCD7C4}"/>
               </a:ext>
             </a:extLst>
           </p:cNvPr>
@@ -7765,7 +7765,7 @@
           <p:cNvPr id="13" name="limit-body-2">
             <a:extLst xmlns:a="http://schemas.openxmlformats.org/drawingml/2006/main">
               <a:ext uri="{FF2B5EF4-FFF2-40B4-BE49-F238E27FC236}">
-                <a16:creationId xmlns:a16="http://schemas.microsoft.com/office/drawing/2014/main" id="{40443441-B937-4216-9ADE-47449905B507}"/>
+                <a16:creationId xmlns:a16="http://schemas.microsoft.com/office/drawing/2014/main" id="{4DEB1404-0341-4A95-AF45-5C2242569743}"/>
               </a:ext>
             </a:extLst>
           </p:cNvPr>
@@ -7892,7 +7892,7 @@
           <p:cNvPr id="14" name="footer">
             <a:extLst xmlns:a="http://schemas.openxmlformats.org/drawingml/2006/main">
               <a:ext uri="{FF2B5EF4-FFF2-40B4-BE49-F238E27FC236}">
-                <a16:creationId xmlns:a16="http://schemas.microsoft.com/office/drawing/2014/main" id="{FB2279EA-B1D1-4931-8084-E261EB71D885}"/>
+                <a16:creationId xmlns:a16="http://schemas.microsoft.com/office/drawing/2014/main" id="{0A45F6CA-2187-4D36-B2D0-4F3D483141E0}"/>
               </a:ext>
             </a:extLst>
           </p:cNvPr>
@@ -8017,7 +8017,7 @@
     </p:spTree>
     <p:extLst>
       <p:ext uri="{BB962C8B-B14F-4D97-AF65-F5344CB8AC3E}">
-        <p14:creationId xmlns:p14="http://schemas.microsoft.com/office/powerpoint/2010/main" val="1523250959"/>
+        <p14:creationId xmlns:p14="http://schemas.microsoft.com/office/powerpoint/2010/main" val="211903717"/>
       </p:ext>
     </p:extLst>
   </p:cSld>
@@ -8048,7 +8048,7 @@
           <p:cNvPr id="6" name="close-label">
             <a:extLst xmlns:a="http://schemas.openxmlformats.org/drawingml/2006/main">
               <a:ext uri="{FF2B5EF4-FFF2-40B4-BE49-F238E27FC236}">
-                <a16:creationId xmlns:a16="http://schemas.microsoft.com/office/drawing/2014/main" id="{679EE742-40A3-4C7C-B3FE-427FF32727ED}"/>
+                <a16:creationId xmlns:a16="http://schemas.microsoft.com/office/drawing/2014/main" id="{523E4A21-465D-4E4F-B4D2-63DD8BABDBB0}"/>
               </a:ext>
             </a:extLst>
           </p:cNvPr>
@@ -8175,7 +8175,7 @@
           <p:cNvPr id="2" name="close-title">
             <a:extLst xmlns:a="http://schemas.openxmlformats.org/drawingml/2006/main">
               <a:ext uri="{FF2B5EF4-FFF2-40B4-BE49-F238E27FC236}">
-                <a16:creationId xmlns:a16="http://schemas.microsoft.com/office/drawing/2014/main" id="{3E2011A6-86AA-42F0-B2D1-3F63DEA780E6}"/>
+                <a16:creationId xmlns:a16="http://schemas.microsoft.com/office/drawing/2014/main" id="{7AA02480-D6DF-4103-84EF-3683862FA4AF}"/>
               </a:ext>
             </a:extLst>
           </p:cNvPr>
@@ -8302,7 +8302,7 @@
           <p:cNvPr id="3" name="close-body">
             <a:extLst xmlns:a="http://schemas.openxmlformats.org/drawingml/2006/main">
               <a:ext uri="{FF2B5EF4-FFF2-40B4-BE49-F238E27FC236}">
-                <a16:creationId xmlns:a16="http://schemas.microsoft.com/office/drawing/2014/main" id="{59AC40CF-66F2-4BD3-8D06-71A9286CA3D2}"/>
+                <a16:creationId xmlns:a16="http://schemas.microsoft.com/office/drawing/2014/main" id="{6C6C857F-A83A-484E-AF9A-A08A17A02FBE}"/>
               </a:ext>
             </a:extLst>
           </p:cNvPr>
@@ -8450,7 +8450,7 @@
           <p:cNvPr id="4" name="close-rule">
             <a:extLst xmlns:a="http://schemas.openxmlformats.org/drawingml/2006/main">
               <a:ext uri="{FF2B5EF4-FFF2-40B4-BE49-F238E27FC236}">
-                <a16:creationId xmlns:a16="http://schemas.microsoft.com/office/drawing/2014/main" id="{A84F1D5F-A81A-4F53-AF33-E21860415BC5}"/>
+                <a16:creationId xmlns:a16="http://schemas.microsoft.com/office/drawing/2014/main" id="{45761ED2-D475-472F-B152-54B60DA23542}"/>
               </a:ext>
             </a:extLst>
           </p:cNvPr>
@@ -8481,7 +8481,7 @@
           <p:cNvPr id="5" name="close-footer">
             <a:extLst xmlns:a="http://schemas.openxmlformats.org/drawingml/2006/main">
               <a:ext uri="{FF2B5EF4-FFF2-40B4-BE49-F238E27FC236}">
-                <a16:creationId xmlns:a16="http://schemas.microsoft.com/office/drawing/2014/main" id="{B25DBFD2-CF3F-4926-B528-32CF99456D2E}"/>
+                <a16:creationId xmlns:a16="http://schemas.microsoft.com/office/drawing/2014/main" id="{507BF386-55BF-4CEA-AEE4-1F1C62163E58}"/>
               </a:ext>
             </a:extLst>
           </p:cNvPr>
@@ -8606,7 +8606,7 @@
     </p:spTree>
     <p:extLst>
       <p:ext uri="{BB962C8B-B14F-4D97-AF65-F5344CB8AC3E}">
-        <p14:creationId xmlns:p14="http://schemas.microsoft.com/office/powerpoint/2010/main" val="1433356050"/>
+        <p14:creationId xmlns:p14="http://schemas.microsoft.com/office/powerpoint/2010/main" val="1420055739"/>
       </p:ext>
     </p:extLst>
   </p:cSld>
@@ -8637,7 +8637,7 @@
           <p:cNvPr id="17" name="eyebrow">
             <a:extLst xmlns:a="http://schemas.openxmlformats.org/drawingml/2006/main">
               <a:ext uri="{FF2B5EF4-FFF2-40B4-BE49-F238E27FC236}">
-                <a16:creationId xmlns:a16="http://schemas.microsoft.com/office/drawing/2014/main" id="{32D19127-3F32-4A1C-9D10-47728E542F85}"/>
+                <a16:creationId xmlns:a16="http://schemas.microsoft.com/office/drawing/2014/main" id="{ED5D0DEA-113B-472D-8E9B-BBF9219F53D4}"/>
               </a:ext>
             </a:extLst>
           </p:cNvPr>
@@ -8764,7 +8764,7 @@
           <p:cNvPr id="2" name="page">
             <a:extLst xmlns:a="http://schemas.openxmlformats.org/drawingml/2006/main">
               <a:ext uri="{FF2B5EF4-FFF2-40B4-BE49-F238E27FC236}">
-                <a16:creationId xmlns:a16="http://schemas.microsoft.com/office/drawing/2014/main" id="{4DB87A08-87FB-4C65-A46F-DE1D9F0CB166}"/>
+                <a16:creationId xmlns:a16="http://schemas.microsoft.com/office/drawing/2014/main" id="{081A5E5A-D66B-457D-80E9-9AED42F523D8}"/>
               </a:ext>
             </a:extLst>
           </p:cNvPr>
@@ -8891,7 +8891,7 @@
           <p:cNvPr id="3" name="scope-rule">
             <a:extLst xmlns:a="http://schemas.openxmlformats.org/drawingml/2006/main">
               <a:ext uri="{FF2B5EF4-FFF2-40B4-BE49-F238E27FC236}">
-                <a16:creationId xmlns:a16="http://schemas.microsoft.com/office/drawing/2014/main" id="{01DEACC6-8B28-446D-8839-2F6C287C1457}"/>
+                <a16:creationId xmlns:a16="http://schemas.microsoft.com/office/drawing/2014/main" id="{AC7FFEAB-37DC-4142-B3F1-6C660E4F745B}"/>
               </a:ext>
             </a:extLst>
           </p:cNvPr>
@@ -8922,7 +8922,7 @@
           <p:cNvPr id="4" name="title">
             <a:extLst xmlns:a="http://schemas.openxmlformats.org/drawingml/2006/main">
               <a:ext uri="{FF2B5EF4-FFF2-40B4-BE49-F238E27FC236}">
-                <a16:creationId xmlns:a16="http://schemas.microsoft.com/office/drawing/2014/main" id="{E7FBFE99-4D8C-4BE5-8512-49971B272D46}"/>
+                <a16:creationId xmlns:a16="http://schemas.microsoft.com/office/drawing/2014/main" id="{C90FC55F-C5B4-421C-BCA0-05C27291C39F}"/>
               </a:ext>
             </a:extLst>
           </p:cNvPr>
@@ -9049,7 +9049,7 @@
           <p:cNvPr id="5" name="subtitle">
             <a:extLst xmlns:a="http://schemas.openxmlformats.org/drawingml/2006/main">
               <a:ext uri="{FF2B5EF4-FFF2-40B4-BE49-F238E27FC236}">
-                <a16:creationId xmlns:a16="http://schemas.microsoft.com/office/drawing/2014/main" id="{063283A4-603F-44E5-8D87-622A057846D8}"/>
+                <a16:creationId xmlns:a16="http://schemas.microsoft.com/office/drawing/2014/main" id="{922826B7-87D3-46EE-BD9A-97CEC704B506}"/>
               </a:ext>
             </a:extLst>
           </p:cNvPr>
@@ -9176,7 +9176,7 @@
           <p:cNvPr id="6" name="scope-left">
             <a:extLst xmlns:a="http://schemas.openxmlformats.org/drawingml/2006/main">
               <a:ext uri="{FF2B5EF4-FFF2-40B4-BE49-F238E27FC236}">
-                <a16:creationId xmlns:a16="http://schemas.microsoft.com/office/drawing/2014/main" id="{12097C3F-3CF8-424F-AF82-281F9878B10A}"/>
+                <a16:creationId xmlns:a16="http://schemas.microsoft.com/office/drawing/2014/main" id="{D232A0D0-F8A7-44CF-BE5C-AF817C4F838F}"/>
               </a:ext>
             </a:extLst>
           </p:cNvPr>
@@ -9303,7 +9303,7 @@
           <p:cNvPr id="7" name="scope-left-body">
             <a:extLst xmlns:a="http://schemas.openxmlformats.org/drawingml/2006/main">
               <a:ext uri="{FF2B5EF4-FFF2-40B4-BE49-F238E27FC236}">
-                <a16:creationId xmlns:a16="http://schemas.microsoft.com/office/drawing/2014/main" id="{4A3B5DBE-3D5B-4CA0-AB47-AE94EC11CD45}"/>
+                <a16:creationId xmlns:a16="http://schemas.microsoft.com/office/drawing/2014/main" id="{93DC741E-A1B6-4F72-AACB-165AD3C302E7}"/>
               </a:ext>
             </a:extLst>
           </p:cNvPr>
@@ -9430,7 +9430,7 @@
           <p:cNvPr id="8" name="scope-rule-1">
             <a:extLst xmlns:a="http://schemas.openxmlformats.org/drawingml/2006/main">
               <a:ext uri="{FF2B5EF4-FFF2-40B4-BE49-F238E27FC236}">
-                <a16:creationId xmlns:a16="http://schemas.microsoft.com/office/drawing/2014/main" id="{BA00695C-246A-40CE-8548-BCE1AFF5D357}"/>
+                <a16:creationId xmlns:a16="http://schemas.microsoft.com/office/drawing/2014/main" id="{4B2BA52A-8CA9-4DA6-84E8-52CEDA4AECA4}"/>
               </a:ext>
             </a:extLst>
           </p:cNvPr>
@@ -9461,7 +9461,7 @@
           <p:cNvPr id="9" name="scope-card-1-text">
             <a:extLst xmlns:a="http://schemas.openxmlformats.org/drawingml/2006/main">
               <a:ext uri="{FF2B5EF4-FFF2-40B4-BE49-F238E27FC236}">
-                <a16:creationId xmlns:a16="http://schemas.microsoft.com/office/drawing/2014/main" id="{DA5A5BBD-FC4A-4CAB-8B7D-54B2DFC08A6A}"/>
+                <a16:creationId xmlns:a16="http://schemas.microsoft.com/office/drawing/2014/main" id="{8DF1C449-119E-40C6-A3D0-CF60CB40901E}"/>
               </a:ext>
             </a:extLst>
           </p:cNvPr>
@@ -9609,7 +9609,7 @@
           <p:cNvPr id="10" name="scope-rule-2">
             <a:extLst xmlns:a="http://schemas.openxmlformats.org/drawingml/2006/main">
               <a:ext uri="{FF2B5EF4-FFF2-40B4-BE49-F238E27FC236}">
-                <a16:creationId xmlns:a16="http://schemas.microsoft.com/office/drawing/2014/main" id="{C7BDA811-7FAE-438C-8707-AAA4F9278AC9}"/>
+                <a16:creationId xmlns:a16="http://schemas.microsoft.com/office/drawing/2014/main" id="{DD108978-25E2-4016-A5BE-DE2DA98729CF}"/>
               </a:ext>
             </a:extLst>
           </p:cNvPr>
@@ -9640,7 +9640,7 @@
           <p:cNvPr id="11" name="scope-card-2-text">
             <a:extLst xmlns:a="http://schemas.openxmlformats.org/drawingml/2006/main">
               <a:ext uri="{FF2B5EF4-FFF2-40B4-BE49-F238E27FC236}">
-                <a16:creationId xmlns:a16="http://schemas.microsoft.com/office/drawing/2014/main" id="{E739B4B0-36D5-4E71-B135-6522D67A2484}"/>
+                <a16:creationId xmlns:a16="http://schemas.microsoft.com/office/drawing/2014/main" id="{09951871-8533-4131-8B1A-0ADBEAFDA7F1}"/>
               </a:ext>
             </a:extLst>
           </p:cNvPr>
@@ -9788,7 +9788,7 @@
           <p:cNvPr id="12" name="scope-rule-3">
             <a:extLst xmlns:a="http://schemas.openxmlformats.org/drawingml/2006/main">
               <a:ext uri="{FF2B5EF4-FFF2-40B4-BE49-F238E27FC236}">
-                <a16:creationId xmlns:a16="http://schemas.microsoft.com/office/drawing/2014/main" id="{11EFD329-F727-4066-BE6D-4D465F60AAF5}"/>
+                <a16:creationId xmlns:a16="http://schemas.microsoft.com/office/drawing/2014/main" id="{55E5C5B7-43FD-4366-8151-C8F334EE20AE}"/>
               </a:ext>
             </a:extLst>
           </p:cNvPr>
@@ -9819,7 +9819,7 @@
           <p:cNvPr id="13" name="scope-card-3-text">
             <a:extLst xmlns:a="http://schemas.openxmlformats.org/drawingml/2006/main">
               <a:ext uri="{FF2B5EF4-FFF2-40B4-BE49-F238E27FC236}">
-                <a16:creationId xmlns:a16="http://schemas.microsoft.com/office/drawing/2014/main" id="{9590828C-607B-4D03-9137-C5B8BC951039}"/>
+                <a16:creationId xmlns:a16="http://schemas.microsoft.com/office/drawing/2014/main" id="{B3C9333E-A5B7-4D0D-B7F2-0C4CC6111D06}"/>
               </a:ext>
             </a:extLst>
           </p:cNvPr>
@@ -9967,7 +9967,7 @@
           <p:cNvPr id="14" name="scope-rule-4">
             <a:extLst xmlns:a="http://schemas.openxmlformats.org/drawingml/2006/main">
               <a:ext uri="{FF2B5EF4-FFF2-40B4-BE49-F238E27FC236}">
-                <a16:creationId xmlns:a16="http://schemas.microsoft.com/office/drawing/2014/main" id="{7F26A997-86F5-45A4-A42A-B7131EB7B46C}"/>
+                <a16:creationId xmlns:a16="http://schemas.microsoft.com/office/drawing/2014/main" id="{15F24320-7D39-49EC-88EE-6D4AEE95D182}"/>
               </a:ext>
             </a:extLst>
           </p:cNvPr>
@@ -9998,7 +9998,7 @@
           <p:cNvPr id="15" name="scope-card-4-text">
             <a:extLst xmlns:a="http://schemas.openxmlformats.org/drawingml/2006/main">
               <a:ext uri="{FF2B5EF4-FFF2-40B4-BE49-F238E27FC236}">
-                <a16:creationId xmlns:a16="http://schemas.microsoft.com/office/drawing/2014/main" id="{CA7CD8C7-2AF3-4289-B348-DECB7250F029}"/>
+                <a16:creationId xmlns:a16="http://schemas.microsoft.com/office/drawing/2014/main" id="{49BA3956-2FAE-44B8-8A05-E83DA9E7CEE9}"/>
               </a:ext>
             </a:extLst>
           </p:cNvPr>
@@ -10146,7 +10146,7 @@
           <p:cNvPr id="16" name="footer">
             <a:extLst xmlns:a="http://schemas.openxmlformats.org/drawingml/2006/main">
               <a:ext uri="{FF2B5EF4-FFF2-40B4-BE49-F238E27FC236}">
-                <a16:creationId xmlns:a16="http://schemas.microsoft.com/office/drawing/2014/main" id="{1658CB5E-F53A-4E11-A59F-05CDA2C65EE7}"/>
+                <a16:creationId xmlns:a16="http://schemas.microsoft.com/office/drawing/2014/main" id="{0231DC42-FC35-4699-BBA5-93B8EA66EFEB}"/>
               </a:ext>
             </a:extLst>
           </p:cNvPr>
@@ -10271,7 +10271,7 @@
     </p:spTree>
     <p:extLst>
       <p:ext uri="{BB962C8B-B14F-4D97-AF65-F5344CB8AC3E}">
-        <p14:creationId xmlns:p14="http://schemas.microsoft.com/office/powerpoint/2010/main" val="1629406090"/>
+        <p14:creationId xmlns:p14="http://schemas.microsoft.com/office/powerpoint/2010/main" val="537826869"/>
       </p:ext>
     </p:extLst>
   </p:cSld>
@@ -10302,7 +10302,7 @@
           <p:cNvPr id="26" name="eyebrow">
             <a:extLst xmlns:a="http://schemas.openxmlformats.org/drawingml/2006/main">
               <a:ext uri="{FF2B5EF4-FFF2-40B4-BE49-F238E27FC236}">
-                <a16:creationId xmlns:a16="http://schemas.microsoft.com/office/drawing/2014/main" id="{FD2576FC-6EED-4C39-92C7-AAD48F94022A}"/>
+                <a16:creationId xmlns:a16="http://schemas.microsoft.com/office/drawing/2014/main" id="{F7EDD7B2-6279-4CA5-98A5-473B73E8FEEE}"/>
               </a:ext>
             </a:extLst>
           </p:cNvPr>
@@ -10429,7 +10429,7 @@
           <p:cNvPr id="2" name="page">
             <a:extLst xmlns:a="http://schemas.openxmlformats.org/drawingml/2006/main">
               <a:ext uri="{FF2B5EF4-FFF2-40B4-BE49-F238E27FC236}">
-                <a16:creationId xmlns:a16="http://schemas.microsoft.com/office/drawing/2014/main" id="{CFA6C036-FD4B-4715-8A24-EE90B08D883E}"/>
+                <a16:creationId xmlns:a16="http://schemas.microsoft.com/office/drawing/2014/main" id="{7C126B20-651A-4AB5-A769-FE51A7680BE9}"/>
               </a:ext>
             </a:extLst>
           </p:cNvPr>
@@ -10556,7 +10556,7 @@
           <p:cNvPr id="3" name="path-rule">
             <a:extLst xmlns:a="http://schemas.openxmlformats.org/drawingml/2006/main">
               <a:ext uri="{FF2B5EF4-FFF2-40B4-BE49-F238E27FC236}">
-                <a16:creationId xmlns:a16="http://schemas.microsoft.com/office/drawing/2014/main" id="{38A45CBD-AB92-4AF2-99E6-76B513506A1A}"/>
+                <a16:creationId xmlns:a16="http://schemas.microsoft.com/office/drawing/2014/main" id="{CEB48FE1-1152-4296-899A-CAAA33FD9F27}"/>
               </a:ext>
             </a:extLst>
           </p:cNvPr>
@@ -10587,7 +10587,7 @@
           <p:cNvPr id="4" name="title">
             <a:extLst xmlns:a="http://schemas.openxmlformats.org/drawingml/2006/main">
               <a:ext uri="{FF2B5EF4-FFF2-40B4-BE49-F238E27FC236}">
-                <a16:creationId xmlns:a16="http://schemas.microsoft.com/office/drawing/2014/main" id="{46FA0563-98D4-4B94-8B31-E7D7E221044F}"/>
+                <a16:creationId xmlns:a16="http://schemas.microsoft.com/office/drawing/2014/main" id="{F8A1637C-74AE-444E-B132-7709077945D1}"/>
               </a:ext>
             </a:extLst>
           </p:cNvPr>
@@ -10714,7 +10714,7 @@
           <p:cNvPr id="5" name="step-number-1">
             <a:extLst xmlns:a="http://schemas.openxmlformats.org/drawingml/2006/main">
               <a:ext uri="{FF2B5EF4-FFF2-40B4-BE49-F238E27FC236}">
-                <a16:creationId xmlns:a16="http://schemas.microsoft.com/office/drawing/2014/main" id="{A82C2FCD-7B40-4D35-BF16-88558032658B}"/>
+                <a16:creationId xmlns:a16="http://schemas.microsoft.com/office/drawing/2014/main" id="{4209DCAB-77E6-426A-A081-A209728DE801}"/>
               </a:ext>
             </a:extLst>
           </p:cNvPr>
@@ -10841,7 +10841,7 @@
           <p:cNvPr id="6" name="step-label-1">
             <a:extLst xmlns:a="http://schemas.openxmlformats.org/drawingml/2006/main">
               <a:ext uri="{FF2B5EF4-FFF2-40B4-BE49-F238E27FC236}">
-                <a16:creationId xmlns:a16="http://schemas.microsoft.com/office/drawing/2014/main" id="{8B63A0D9-8A0A-48F1-AD85-4A45F3294FD6}"/>
+                <a16:creationId xmlns:a16="http://schemas.microsoft.com/office/drawing/2014/main" id="{D528D2DD-A006-4CA0-B9D3-8AEFAA7105BE}"/>
               </a:ext>
             </a:extLst>
           </p:cNvPr>
@@ -10968,7 +10968,7 @@
           <p:cNvPr id="7" name="step-detail-1">
             <a:extLst xmlns:a="http://schemas.openxmlformats.org/drawingml/2006/main">
               <a:ext uri="{FF2B5EF4-FFF2-40B4-BE49-F238E27FC236}">
-                <a16:creationId xmlns:a16="http://schemas.microsoft.com/office/drawing/2014/main" id="{B0ED50F9-52A4-4F95-8BD7-1FEC0CB90357}"/>
+                <a16:creationId xmlns:a16="http://schemas.microsoft.com/office/drawing/2014/main" id="{02C20FC1-B884-4C36-AB98-368DB08CBBDA}"/>
               </a:ext>
             </a:extLst>
           </p:cNvPr>
@@ -11095,7 +11095,7 @@
           <p:cNvPr id="8" name="step-line-1">
             <a:extLst xmlns:a="http://schemas.openxmlformats.org/drawingml/2006/main">
               <a:ext uri="{FF2B5EF4-FFF2-40B4-BE49-F238E27FC236}">
-                <a16:creationId xmlns:a16="http://schemas.microsoft.com/office/drawing/2014/main" id="{4446AEC5-DBB0-4E5D-88F0-00104D7D82E9}"/>
+                <a16:creationId xmlns:a16="http://schemas.microsoft.com/office/drawing/2014/main" id="{202C91E8-B112-4412-BEC7-5713AD1527D4}"/>
               </a:ext>
             </a:extLst>
           </p:cNvPr>
@@ -11126,7 +11126,7 @@
           <p:cNvPr id="9" name="step-number-2">
             <a:extLst xmlns:a="http://schemas.openxmlformats.org/drawingml/2006/main">
               <a:ext uri="{FF2B5EF4-FFF2-40B4-BE49-F238E27FC236}">
-                <a16:creationId xmlns:a16="http://schemas.microsoft.com/office/drawing/2014/main" id="{4855209C-EC64-4819-AFF2-CEAAE0D722A6}"/>
+                <a16:creationId xmlns:a16="http://schemas.microsoft.com/office/drawing/2014/main" id="{E33BB2AC-CD24-4276-AACF-2B8801301D21}"/>
               </a:ext>
             </a:extLst>
           </p:cNvPr>
@@ -11253,7 +11253,7 @@
           <p:cNvPr id="10" name="step-label-2">
             <a:extLst xmlns:a="http://schemas.openxmlformats.org/drawingml/2006/main">
               <a:ext uri="{FF2B5EF4-FFF2-40B4-BE49-F238E27FC236}">
-                <a16:creationId xmlns:a16="http://schemas.microsoft.com/office/drawing/2014/main" id="{EF5FCF6A-2F4D-4405-88C6-F83A4797D8EB}"/>
+                <a16:creationId xmlns:a16="http://schemas.microsoft.com/office/drawing/2014/main" id="{67F33CC7-CB40-452C-9F7B-6DFBB090E38E}"/>
               </a:ext>
             </a:extLst>
           </p:cNvPr>
@@ -11380,7 +11380,7 @@
           <p:cNvPr id="11" name="step-detail-2">
             <a:extLst xmlns:a="http://schemas.openxmlformats.org/drawingml/2006/main">
               <a:ext uri="{FF2B5EF4-FFF2-40B4-BE49-F238E27FC236}">
-                <a16:creationId xmlns:a16="http://schemas.microsoft.com/office/drawing/2014/main" id="{44EB0666-C8B9-42A4-96D3-63EF778F8E56}"/>
+                <a16:creationId xmlns:a16="http://schemas.microsoft.com/office/drawing/2014/main" id="{B99CC1C8-693B-4816-94D4-BA6F5E4D6F7B}"/>
               </a:ext>
             </a:extLst>
           </p:cNvPr>
@@ -11507,7 +11507,7 @@
           <p:cNvPr id="12" name="step-line-2">
             <a:extLst xmlns:a="http://schemas.openxmlformats.org/drawingml/2006/main">
               <a:ext uri="{FF2B5EF4-FFF2-40B4-BE49-F238E27FC236}">
-                <a16:creationId xmlns:a16="http://schemas.microsoft.com/office/drawing/2014/main" id="{921470D7-BB7F-45CB-A0B5-91577FF2C2A6}"/>
+                <a16:creationId xmlns:a16="http://schemas.microsoft.com/office/drawing/2014/main" id="{26C20DE5-0E46-4DD4-8172-AE10C22ED665}"/>
               </a:ext>
             </a:extLst>
           </p:cNvPr>
@@ -11538,7 +11538,7 @@
           <p:cNvPr id="13" name="step-number-3">
             <a:extLst xmlns:a="http://schemas.openxmlformats.org/drawingml/2006/main">
               <a:ext uri="{FF2B5EF4-FFF2-40B4-BE49-F238E27FC236}">
-                <a16:creationId xmlns:a16="http://schemas.microsoft.com/office/drawing/2014/main" id="{507CA60E-E12E-4F74-B529-A1E29B0B630B}"/>
+                <a16:creationId xmlns:a16="http://schemas.microsoft.com/office/drawing/2014/main" id="{18252DD7-B5F8-4F13-9392-644DEDA47548}"/>
               </a:ext>
             </a:extLst>
           </p:cNvPr>
@@ -11665,7 +11665,7 @@
           <p:cNvPr id="14" name="step-label-3">
             <a:extLst xmlns:a="http://schemas.openxmlformats.org/drawingml/2006/main">
               <a:ext uri="{FF2B5EF4-FFF2-40B4-BE49-F238E27FC236}">
-                <a16:creationId xmlns:a16="http://schemas.microsoft.com/office/drawing/2014/main" id="{A0D5F003-777B-4C30-91DE-4FB48E82A30E}"/>
+                <a16:creationId xmlns:a16="http://schemas.microsoft.com/office/drawing/2014/main" id="{6A7141ED-8821-49A5-8D8F-BB1B6F988E88}"/>
               </a:ext>
             </a:extLst>
           </p:cNvPr>
@@ -11792,7 +11792,7 @@
           <p:cNvPr id="15" name="step-detail-3">
             <a:extLst xmlns:a="http://schemas.openxmlformats.org/drawingml/2006/main">
               <a:ext uri="{FF2B5EF4-FFF2-40B4-BE49-F238E27FC236}">
-                <a16:creationId xmlns:a16="http://schemas.microsoft.com/office/drawing/2014/main" id="{7CD58398-F9A0-467F-B9A8-D340FB10F181}"/>
+                <a16:creationId xmlns:a16="http://schemas.microsoft.com/office/drawing/2014/main" id="{E3D30E33-2877-4171-9454-486DC5285804}"/>
               </a:ext>
             </a:extLst>
           </p:cNvPr>
@@ -11919,7 +11919,7 @@
           <p:cNvPr id="16" name="step-line-3">
             <a:extLst xmlns:a="http://schemas.openxmlformats.org/drawingml/2006/main">
               <a:ext uri="{FF2B5EF4-FFF2-40B4-BE49-F238E27FC236}">
-                <a16:creationId xmlns:a16="http://schemas.microsoft.com/office/drawing/2014/main" id="{D51C8642-F9AC-4093-81E8-8AC140FDEDE5}"/>
+                <a16:creationId xmlns:a16="http://schemas.microsoft.com/office/drawing/2014/main" id="{FC10A586-E917-437F-B3B2-82451CAE43D7}"/>
               </a:ext>
             </a:extLst>
           </p:cNvPr>
@@ -11950,7 +11950,7 @@
           <p:cNvPr id="17" name="step-number-4">
             <a:extLst xmlns:a="http://schemas.openxmlformats.org/drawingml/2006/main">
               <a:ext uri="{FF2B5EF4-FFF2-40B4-BE49-F238E27FC236}">
-                <a16:creationId xmlns:a16="http://schemas.microsoft.com/office/drawing/2014/main" id="{0FAC0C86-E723-4034-BCAF-9EEE6F10777D}"/>
+                <a16:creationId xmlns:a16="http://schemas.microsoft.com/office/drawing/2014/main" id="{344D6563-D795-4C02-8225-B6A8B8372383}"/>
               </a:ext>
             </a:extLst>
           </p:cNvPr>
@@ -12077,7 +12077,7 @@
           <p:cNvPr id="18" name="step-label-4">
             <a:extLst xmlns:a="http://schemas.openxmlformats.org/drawingml/2006/main">
               <a:ext uri="{FF2B5EF4-FFF2-40B4-BE49-F238E27FC236}">
-                <a16:creationId xmlns:a16="http://schemas.microsoft.com/office/drawing/2014/main" id="{129E306F-2FF6-4A54-BF33-6827945DF697}"/>
+                <a16:creationId xmlns:a16="http://schemas.microsoft.com/office/drawing/2014/main" id="{630D570D-1F84-4DD8-84F4-CC284B37D5BA}"/>
               </a:ext>
             </a:extLst>
           </p:cNvPr>
@@ -12204,7 +12204,7 @@
           <p:cNvPr id="19" name="step-detail-4">
             <a:extLst xmlns:a="http://schemas.openxmlformats.org/drawingml/2006/main">
               <a:ext uri="{FF2B5EF4-FFF2-40B4-BE49-F238E27FC236}">
-                <a16:creationId xmlns:a16="http://schemas.microsoft.com/office/drawing/2014/main" id="{0A22E270-C115-40E8-AE37-DDD23E7F9BE6}"/>
+                <a16:creationId xmlns:a16="http://schemas.microsoft.com/office/drawing/2014/main" id="{2A62FC46-55BE-424A-B39D-C9F1E7C30EB4}"/>
               </a:ext>
             </a:extLst>
           </p:cNvPr>
@@ -12331,7 +12331,7 @@
           <p:cNvPr id="20" name="step-line-4">
             <a:extLst xmlns:a="http://schemas.openxmlformats.org/drawingml/2006/main">
               <a:ext uri="{FF2B5EF4-FFF2-40B4-BE49-F238E27FC236}">
-                <a16:creationId xmlns:a16="http://schemas.microsoft.com/office/drawing/2014/main" id="{C18BC290-4FE7-40EF-916E-826FD66208BF}"/>
+                <a16:creationId xmlns:a16="http://schemas.microsoft.com/office/drawing/2014/main" id="{B5EF027F-D046-4DA8-AE08-C8AF2F5F7732}"/>
               </a:ext>
             </a:extLst>
           </p:cNvPr>
@@ -12362,7 +12362,7 @@
           <p:cNvPr id="21" name="step-number-5">
             <a:extLst xmlns:a="http://schemas.openxmlformats.org/drawingml/2006/main">
               <a:ext uri="{FF2B5EF4-FFF2-40B4-BE49-F238E27FC236}">
-                <a16:creationId xmlns:a16="http://schemas.microsoft.com/office/drawing/2014/main" id="{86ED7A6D-1C45-45BC-B9CB-2BDDF42F7B62}"/>
+                <a16:creationId xmlns:a16="http://schemas.microsoft.com/office/drawing/2014/main" id="{C3605E41-0E84-494A-80A9-1DF3934326C6}"/>
               </a:ext>
             </a:extLst>
           </p:cNvPr>
@@ -12489,7 +12489,7 @@
           <p:cNvPr id="22" name="step-label-5">
             <a:extLst xmlns:a="http://schemas.openxmlformats.org/drawingml/2006/main">
               <a:ext uri="{FF2B5EF4-FFF2-40B4-BE49-F238E27FC236}">
-                <a16:creationId xmlns:a16="http://schemas.microsoft.com/office/drawing/2014/main" id="{DAFEC446-9C92-4A42-8B47-B8E504800F39}"/>
+                <a16:creationId xmlns:a16="http://schemas.microsoft.com/office/drawing/2014/main" id="{01416158-C82C-4E66-A215-9568D915A65D}"/>
               </a:ext>
             </a:extLst>
           </p:cNvPr>
@@ -12616,7 +12616,7 @@
           <p:cNvPr id="23" name="step-detail-5">
             <a:extLst xmlns:a="http://schemas.openxmlformats.org/drawingml/2006/main">
               <a:ext uri="{FF2B5EF4-FFF2-40B4-BE49-F238E27FC236}">
-                <a16:creationId xmlns:a16="http://schemas.microsoft.com/office/drawing/2014/main" id="{7B797EC5-FF2A-4A8C-9B84-22C1F8FAD970}"/>
+                <a16:creationId xmlns:a16="http://schemas.microsoft.com/office/drawing/2014/main" id="{7041B8BB-ADC6-4B5B-AC5C-FC8100C15D3F}"/>
               </a:ext>
             </a:extLst>
           </p:cNvPr>
@@ -12743,7 +12743,7 @@
           <p:cNvPr id="24" name="step-line-5">
             <a:extLst xmlns:a="http://schemas.openxmlformats.org/drawingml/2006/main">
               <a:ext uri="{FF2B5EF4-FFF2-40B4-BE49-F238E27FC236}">
-                <a16:creationId xmlns:a16="http://schemas.microsoft.com/office/drawing/2014/main" id="{7BD4BC01-2EA7-45EB-B6BF-1E3E8E7C45E1}"/>
+                <a16:creationId xmlns:a16="http://schemas.microsoft.com/office/drawing/2014/main" id="{F8424E7A-3512-4DA8-9836-E348DB4F6767}"/>
               </a:ext>
             </a:extLst>
           </p:cNvPr>
@@ -12774,7 +12774,7 @@
           <p:cNvPr id="25" name="footer">
             <a:extLst xmlns:a="http://schemas.openxmlformats.org/drawingml/2006/main">
               <a:ext uri="{FF2B5EF4-FFF2-40B4-BE49-F238E27FC236}">
-                <a16:creationId xmlns:a16="http://schemas.microsoft.com/office/drawing/2014/main" id="{11C6D2B4-6AD4-4E3D-B793-25C4F451F6CA}"/>
+                <a16:creationId xmlns:a16="http://schemas.microsoft.com/office/drawing/2014/main" id="{465EAF57-63D4-418D-8E31-CCD6EB15E23D}"/>
               </a:ext>
             </a:extLst>
           </p:cNvPr>
@@ -12899,7 +12899,7 @@
     </p:spTree>
     <p:extLst>
       <p:ext uri="{BB962C8B-B14F-4D97-AF65-F5344CB8AC3E}">
-        <p14:creationId xmlns:p14="http://schemas.microsoft.com/office/powerpoint/2010/main" val="660882876"/>
+        <p14:creationId xmlns:p14="http://schemas.microsoft.com/office/powerpoint/2010/main" val="1188945025"/>
       </p:ext>
     </p:extLst>
   </p:cSld>
@@ -12930,7 +12930,7 @@
           <p:cNvPr id="13" name="eyebrow">
             <a:extLst xmlns:a="http://schemas.openxmlformats.org/drawingml/2006/main">
               <a:ext uri="{FF2B5EF4-FFF2-40B4-BE49-F238E27FC236}">
-                <a16:creationId xmlns:a16="http://schemas.microsoft.com/office/drawing/2014/main" id="{95B6D23B-FF47-4DB4-B44A-A1CF7F86C032}"/>
+                <a16:creationId xmlns:a16="http://schemas.microsoft.com/office/drawing/2014/main" id="{B3E78A31-1C08-4036-A14E-CF33A7395207}"/>
               </a:ext>
             </a:extLst>
           </p:cNvPr>
@@ -13057,7 +13057,7 @@
           <p:cNvPr id="2" name="page">
             <a:extLst xmlns:a="http://schemas.openxmlformats.org/drawingml/2006/main">
               <a:ext uri="{FF2B5EF4-FFF2-40B4-BE49-F238E27FC236}">
-                <a16:creationId xmlns:a16="http://schemas.microsoft.com/office/drawing/2014/main" id="{B3452713-A88F-4C81-9376-F085D2CD4338}"/>
+                <a16:creationId xmlns:a16="http://schemas.microsoft.com/office/drawing/2014/main" id="{E4CCAE62-D6E5-460D-9261-D092C33CC02C}"/>
               </a:ext>
             </a:extLst>
           </p:cNvPr>
@@ -13184,7 +13184,7 @@
           <p:cNvPr id="3" name="scan-rule">
             <a:extLst xmlns:a="http://schemas.openxmlformats.org/drawingml/2006/main">
               <a:ext uri="{FF2B5EF4-FFF2-40B4-BE49-F238E27FC236}">
-                <a16:creationId xmlns:a16="http://schemas.microsoft.com/office/drawing/2014/main" id="{1906D636-887D-4F9C-B7E4-84A915A4C203}"/>
+                <a16:creationId xmlns:a16="http://schemas.microsoft.com/office/drawing/2014/main" id="{BE9AF167-DC83-4EC4-B5D6-7B7795C1D31C}"/>
               </a:ext>
             </a:extLst>
           </p:cNvPr>
@@ -13215,7 +13215,7 @@
           <p:cNvPr id="4" name="title">
             <a:extLst xmlns:a="http://schemas.openxmlformats.org/drawingml/2006/main">
               <a:ext uri="{FF2B5EF4-FFF2-40B4-BE49-F238E27FC236}">
-                <a16:creationId xmlns:a16="http://schemas.microsoft.com/office/drawing/2014/main" id="{CA9765AB-86DB-4A97-A140-5E37D8B630E3}"/>
+                <a16:creationId xmlns:a16="http://schemas.microsoft.com/office/drawing/2014/main" id="{6D65230B-522D-4F42-89A7-2039E1E2F287}"/>
               </a:ext>
             </a:extLst>
           </p:cNvPr>
@@ -13342,7 +13342,7 @@
           <p:cNvPr id="5" name="scan-metric-1">
             <a:extLst xmlns:a="http://schemas.openxmlformats.org/drawingml/2006/main">
               <a:ext uri="{FF2B5EF4-FFF2-40B4-BE49-F238E27FC236}">
-                <a16:creationId xmlns:a16="http://schemas.microsoft.com/office/drawing/2014/main" id="{E27B4B68-3F1E-41C7-AB35-9F78468C4F32}"/>
+                <a16:creationId xmlns:a16="http://schemas.microsoft.com/office/drawing/2014/main" id="{FD98800A-CE5E-4942-B3E5-2B1DD7058051}"/>
               </a:ext>
             </a:extLst>
           </p:cNvPr>
@@ -13469,7 +13469,7 @@
           <p:cNvPr id="6" name="scan-metric-1-label">
             <a:extLst xmlns:a="http://schemas.openxmlformats.org/drawingml/2006/main">
               <a:ext uri="{FF2B5EF4-FFF2-40B4-BE49-F238E27FC236}">
-                <a16:creationId xmlns:a16="http://schemas.microsoft.com/office/drawing/2014/main" id="{158F0208-6D18-42B5-B54B-F1D915065DA2}"/>
+                <a16:creationId xmlns:a16="http://schemas.microsoft.com/office/drawing/2014/main" id="{2A84A9D8-F4EC-45D5-8364-BBB146AFEA45}"/>
               </a:ext>
             </a:extLst>
           </p:cNvPr>
@@ -13596,7 +13596,7 @@
           <p:cNvPr id="7" name="scan-metric-2">
             <a:extLst xmlns:a="http://schemas.openxmlformats.org/drawingml/2006/main">
               <a:ext uri="{FF2B5EF4-FFF2-40B4-BE49-F238E27FC236}">
-                <a16:creationId xmlns:a16="http://schemas.microsoft.com/office/drawing/2014/main" id="{38BE6576-FFB1-4598-81C7-3A83980B4905}"/>
+                <a16:creationId xmlns:a16="http://schemas.microsoft.com/office/drawing/2014/main" id="{4EAB76E4-CEC4-4774-8BE7-91167B97D9D2}"/>
               </a:ext>
             </a:extLst>
           </p:cNvPr>
@@ -13723,7 +13723,7 @@
           <p:cNvPr id="8" name="scan-metric-2-label">
             <a:extLst xmlns:a="http://schemas.openxmlformats.org/drawingml/2006/main">
               <a:ext uri="{FF2B5EF4-FFF2-40B4-BE49-F238E27FC236}">
-                <a16:creationId xmlns:a16="http://schemas.microsoft.com/office/drawing/2014/main" id="{022EA207-842E-4AE5-AD8E-ABD12BA41433}"/>
+                <a16:creationId xmlns:a16="http://schemas.microsoft.com/office/drawing/2014/main" id="{DE5F89CA-6C0B-40DC-9054-B636F33B635A}"/>
               </a:ext>
             </a:extLst>
           </p:cNvPr>
@@ -13850,7 +13850,7 @@
           <p:cNvPr id="9" name="scan-metric-3">
             <a:extLst xmlns:a="http://schemas.openxmlformats.org/drawingml/2006/main">
               <a:ext uri="{FF2B5EF4-FFF2-40B4-BE49-F238E27FC236}">
-                <a16:creationId xmlns:a16="http://schemas.microsoft.com/office/drawing/2014/main" id="{6258D78D-EABB-48B3-8D16-198F2BAE7980}"/>
+                <a16:creationId xmlns:a16="http://schemas.microsoft.com/office/drawing/2014/main" id="{12789CB6-0916-440A-8920-13109117348C}"/>
               </a:ext>
             </a:extLst>
           </p:cNvPr>
@@ -13977,7 +13977,7 @@
           <p:cNvPr id="10" name="scan-metric-3-label">
             <a:extLst xmlns:a="http://schemas.openxmlformats.org/drawingml/2006/main">
               <a:ext uri="{FF2B5EF4-FFF2-40B4-BE49-F238E27FC236}">
-                <a16:creationId xmlns:a16="http://schemas.microsoft.com/office/drawing/2014/main" id="{2E93569A-DE1E-4208-9F6A-0BD3E28601BC}"/>
+                <a16:creationId xmlns:a16="http://schemas.microsoft.com/office/drawing/2014/main" id="{81098198-2112-4C74-8616-6E732BA9EA9D}"/>
               </a:ext>
             </a:extLst>
           </p:cNvPr>
@@ -14104,7 +14104,7 @@
           <p:cNvPr id="11" name="scan-body">
             <a:extLst xmlns:a="http://schemas.openxmlformats.org/drawingml/2006/main">
               <a:ext uri="{FF2B5EF4-FFF2-40B4-BE49-F238E27FC236}">
-                <a16:creationId xmlns:a16="http://schemas.microsoft.com/office/drawing/2014/main" id="{FAD4FD1C-35BC-4ED6-A092-CEE7243B0EAC}"/>
+                <a16:creationId xmlns:a16="http://schemas.microsoft.com/office/drawing/2014/main" id="{89138F4A-5135-48C6-903F-CA6FBE1CA9D8}"/>
               </a:ext>
             </a:extLst>
           </p:cNvPr>
@@ -14231,7 +14231,7 @@
           <p:cNvPr id="12" name="footer">
             <a:extLst xmlns:a="http://schemas.openxmlformats.org/drawingml/2006/main">
               <a:ext uri="{FF2B5EF4-FFF2-40B4-BE49-F238E27FC236}">
-                <a16:creationId xmlns:a16="http://schemas.microsoft.com/office/drawing/2014/main" id="{F16C6AF9-3330-4EC1-A3C3-07E257F69873}"/>
+                <a16:creationId xmlns:a16="http://schemas.microsoft.com/office/drawing/2014/main" id="{B6938886-F29F-4E9F-8A2C-D9D1BCD559F1}"/>
               </a:ext>
             </a:extLst>
           </p:cNvPr>
@@ -14356,7 +14356,7 @@
     </p:spTree>
     <p:extLst>
       <p:ext uri="{BB962C8B-B14F-4D97-AF65-F5344CB8AC3E}">
-        <p14:creationId xmlns:p14="http://schemas.microsoft.com/office/powerpoint/2010/main" val="290396334"/>
+        <p14:creationId xmlns:p14="http://schemas.microsoft.com/office/powerpoint/2010/main" val="1997118242"/>
       </p:ext>
     </p:extLst>
   </p:cSld>
@@ -14387,7 +14387,7 @@
           <p:cNvPr id="13" name="eyebrow">
             <a:extLst xmlns:a="http://schemas.openxmlformats.org/drawingml/2006/main">
               <a:ext uri="{FF2B5EF4-FFF2-40B4-BE49-F238E27FC236}">
-                <a16:creationId xmlns:a16="http://schemas.microsoft.com/office/drawing/2014/main" id="{C870C4E2-E6F6-434D-8329-ACD1CBD18AE6}"/>
+                <a16:creationId xmlns:a16="http://schemas.microsoft.com/office/drawing/2014/main" id="{73C83F2C-5FEE-4C30-97B2-2FE3D231FF99}"/>
               </a:ext>
             </a:extLst>
           </p:cNvPr>
@@ -14514,7 +14514,7 @@
           <p:cNvPr id="2" name="page">
             <a:extLst xmlns:a="http://schemas.openxmlformats.org/drawingml/2006/main">
               <a:ext uri="{FF2B5EF4-FFF2-40B4-BE49-F238E27FC236}">
-                <a16:creationId xmlns:a16="http://schemas.microsoft.com/office/drawing/2014/main" id="{6391A9D1-E9F4-4812-8302-C60D581E8555}"/>
+                <a16:creationId xmlns:a16="http://schemas.microsoft.com/office/drawing/2014/main" id="{576A29B8-459E-4F4B-AEB4-36A2C532A5D4}"/>
               </a:ext>
             </a:extLst>
           </p:cNvPr>
@@ -14641,7 +14641,7 @@
           <p:cNvPr id="3" name="parsing-rule">
             <a:extLst xmlns:a="http://schemas.openxmlformats.org/drawingml/2006/main">
               <a:ext uri="{FF2B5EF4-FFF2-40B4-BE49-F238E27FC236}">
-                <a16:creationId xmlns:a16="http://schemas.microsoft.com/office/drawing/2014/main" id="{BB248532-1B5A-4D41-9807-825575D2708A}"/>
+                <a16:creationId xmlns:a16="http://schemas.microsoft.com/office/drawing/2014/main" id="{A6A05D10-2E0C-4EB8-89B7-C4383CD61B56}"/>
               </a:ext>
             </a:extLst>
           </p:cNvPr>
@@ -14672,7 +14672,7 @@
           <p:cNvPr id="4" name="title">
             <a:extLst xmlns:a="http://schemas.openxmlformats.org/drawingml/2006/main">
               <a:ext uri="{FF2B5EF4-FFF2-40B4-BE49-F238E27FC236}">
-                <a16:creationId xmlns:a16="http://schemas.microsoft.com/office/drawing/2014/main" id="{E496531C-C969-49FF-A14A-6C48A51CCC37}"/>
+                <a16:creationId xmlns:a16="http://schemas.microsoft.com/office/drawing/2014/main" id="{1FA1A0D9-2549-44D3-9425-BB0926665191}"/>
               </a:ext>
             </a:extLst>
           </p:cNvPr>
@@ -14799,7 +14799,7 @@
           <p:cNvPr id="5" name="parse-metric-1">
             <a:extLst xmlns:a="http://schemas.openxmlformats.org/drawingml/2006/main">
               <a:ext uri="{FF2B5EF4-FFF2-40B4-BE49-F238E27FC236}">
-                <a16:creationId xmlns:a16="http://schemas.microsoft.com/office/drawing/2014/main" id="{995DB66F-F760-4CDC-9E99-9D0922C14513}"/>
+                <a16:creationId xmlns:a16="http://schemas.microsoft.com/office/drawing/2014/main" id="{6FFF48D7-3029-4861-8976-7540CD574DF4}"/>
               </a:ext>
             </a:extLst>
           </p:cNvPr>
@@ -14926,7 +14926,7 @@
           <p:cNvPr id="6" name="parse-metric-1-label">
             <a:extLst xmlns:a="http://schemas.openxmlformats.org/drawingml/2006/main">
               <a:ext uri="{FF2B5EF4-FFF2-40B4-BE49-F238E27FC236}">
-                <a16:creationId xmlns:a16="http://schemas.microsoft.com/office/drawing/2014/main" id="{2D748427-322A-4860-8C3E-A23286B1E4DB}"/>
+                <a16:creationId xmlns:a16="http://schemas.microsoft.com/office/drawing/2014/main" id="{B992948A-9871-4ED8-B8D0-4F4454EDC9DA}"/>
               </a:ext>
             </a:extLst>
           </p:cNvPr>
@@ -15053,7 +15053,7 @@
           <p:cNvPr id="7" name="parse-metric-2">
             <a:extLst xmlns:a="http://schemas.openxmlformats.org/drawingml/2006/main">
               <a:ext uri="{FF2B5EF4-FFF2-40B4-BE49-F238E27FC236}">
-                <a16:creationId xmlns:a16="http://schemas.microsoft.com/office/drawing/2014/main" id="{546CBCCE-9371-4BE3-81F2-45120DF4183C}"/>
+                <a16:creationId xmlns:a16="http://schemas.microsoft.com/office/drawing/2014/main" id="{EC9123A4-EC7C-4B05-9B4C-98C7190B54F5}"/>
               </a:ext>
             </a:extLst>
           </p:cNvPr>
@@ -15180,7 +15180,7 @@
           <p:cNvPr id="8" name="parse-metric-2-label">
             <a:extLst xmlns:a="http://schemas.openxmlformats.org/drawingml/2006/main">
               <a:ext uri="{FF2B5EF4-FFF2-40B4-BE49-F238E27FC236}">
-                <a16:creationId xmlns:a16="http://schemas.microsoft.com/office/drawing/2014/main" id="{524E1794-BB64-46DD-8A4F-132173C1B3B7}"/>
+                <a16:creationId xmlns:a16="http://schemas.microsoft.com/office/drawing/2014/main" id="{79ADB3C9-CFEA-4D04-89B9-13F792857C78}"/>
               </a:ext>
             </a:extLst>
           </p:cNvPr>
@@ -15307,7 +15307,7 @@
           <p:cNvPr id="9" name="parse-metric-3">
             <a:extLst xmlns:a="http://schemas.openxmlformats.org/drawingml/2006/main">
               <a:ext uri="{FF2B5EF4-FFF2-40B4-BE49-F238E27FC236}">
-                <a16:creationId xmlns:a16="http://schemas.microsoft.com/office/drawing/2014/main" id="{43C93A4A-7F0A-45F6-A04D-AEDDAEFBB9D6}"/>
+                <a16:creationId xmlns:a16="http://schemas.microsoft.com/office/drawing/2014/main" id="{83A3E12E-CF6B-4E22-88C2-3EA7A6DC5D9E}"/>
               </a:ext>
             </a:extLst>
           </p:cNvPr>
@@ -15434,7 +15434,7 @@
           <p:cNvPr id="10" name="parse-metric-3-label">
             <a:extLst xmlns:a="http://schemas.openxmlformats.org/drawingml/2006/main">
               <a:ext uri="{FF2B5EF4-FFF2-40B4-BE49-F238E27FC236}">
-                <a16:creationId xmlns:a16="http://schemas.microsoft.com/office/drawing/2014/main" id="{8A99E236-CCFF-4B58-B8DC-4DE57495CE15}"/>
+                <a16:creationId xmlns:a16="http://schemas.microsoft.com/office/drawing/2014/main" id="{C1234554-1C14-4F5F-95EB-8160DB346DEB}"/>
               </a:ext>
             </a:extLst>
           </p:cNvPr>
@@ -15561,7 +15561,7 @@
           <p:cNvPr id="11" name="parse-body">
             <a:extLst xmlns:a="http://schemas.openxmlformats.org/drawingml/2006/main">
               <a:ext uri="{FF2B5EF4-FFF2-40B4-BE49-F238E27FC236}">
-                <a16:creationId xmlns:a16="http://schemas.microsoft.com/office/drawing/2014/main" id="{E0BB5A4B-387D-45BD-9E89-DCA99320E005}"/>
+                <a16:creationId xmlns:a16="http://schemas.microsoft.com/office/drawing/2014/main" id="{185052DC-0D50-4078-B631-8340C136ABEA}"/>
               </a:ext>
             </a:extLst>
           </p:cNvPr>
@@ -15688,7 +15688,7 @@
           <p:cNvPr id="12" name="footer">
             <a:extLst xmlns:a="http://schemas.openxmlformats.org/drawingml/2006/main">
               <a:ext uri="{FF2B5EF4-FFF2-40B4-BE49-F238E27FC236}">
-                <a16:creationId xmlns:a16="http://schemas.microsoft.com/office/drawing/2014/main" id="{E70B76CE-9AC3-45EA-A7F5-21C6A6179466}"/>
+                <a16:creationId xmlns:a16="http://schemas.microsoft.com/office/drawing/2014/main" id="{6A05623B-8B0B-4D76-B649-BA098D260C28}"/>
               </a:ext>
             </a:extLst>
           </p:cNvPr>
@@ -15813,7 +15813,7 @@
     </p:spTree>
     <p:extLst>
       <p:ext uri="{BB962C8B-B14F-4D97-AF65-F5344CB8AC3E}">
-        <p14:creationId xmlns:p14="http://schemas.microsoft.com/office/powerpoint/2010/main" val="2122002319"/>
+        <p14:creationId xmlns:p14="http://schemas.microsoft.com/office/powerpoint/2010/main" val="1011294234"/>
       </p:ext>
     </p:extLst>
   </p:cSld>
@@ -15844,7 +15844,7 @@
           <p:cNvPr id="16" name="eyebrow">
             <a:extLst xmlns:a="http://schemas.openxmlformats.org/drawingml/2006/main">
               <a:ext uri="{FF2B5EF4-FFF2-40B4-BE49-F238E27FC236}">
-                <a16:creationId xmlns:a16="http://schemas.microsoft.com/office/drawing/2014/main" id="{6EC80755-8E8E-4294-8AD8-7F3950AABBEE}"/>
+                <a16:creationId xmlns:a16="http://schemas.microsoft.com/office/drawing/2014/main" id="{2AA2327C-D6AC-4262-922A-A281F0930D03}"/>
               </a:ext>
             </a:extLst>
           </p:cNvPr>
@@ -15971,7 +15971,7 @@
           <p:cNvPr id="2" name="page">
             <a:extLst xmlns:a="http://schemas.openxmlformats.org/drawingml/2006/main">
               <a:ext uri="{FF2B5EF4-FFF2-40B4-BE49-F238E27FC236}">
-                <a16:creationId xmlns:a16="http://schemas.microsoft.com/office/drawing/2014/main" id="{D4163A3E-04C0-4713-B981-DF7EFA1246E1}"/>
+                <a16:creationId xmlns:a16="http://schemas.microsoft.com/office/drawing/2014/main" id="{B86AF9AA-0AB4-4E12-B4C9-DD28129E67AB}"/>
               </a:ext>
             </a:extLst>
           </p:cNvPr>
@@ -16098,7 +16098,7 @@
           <p:cNvPr id="3" name="review-rule">
             <a:extLst xmlns:a="http://schemas.openxmlformats.org/drawingml/2006/main">
               <a:ext uri="{FF2B5EF4-FFF2-40B4-BE49-F238E27FC236}">
-                <a16:creationId xmlns:a16="http://schemas.microsoft.com/office/drawing/2014/main" id="{20346976-A8BC-45B1-A095-2B04ACC2C87C}"/>
+                <a16:creationId xmlns:a16="http://schemas.microsoft.com/office/drawing/2014/main" id="{E7101CEC-431D-43E0-8C95-6368D4AAFC54}"/>
               </a:ext>
             </a:extLst>
           </p:cNvPr>
@@ -16129,7 +16129,7 @@
           <p:cNvPr id="4" name="title">
             <a:extLst xmlns:a="http://schemas.openxmlformats.org/drawingml/2006/main">
               <a:ext uri="{FF2B5EF4-FFF2-40B4-BE49-F238E27FC236}">
-                <a16:creationId xmlns:a16="http://schemas.microsoft.com/office/drawing/2014/main" id="{9E6482ED-F16C-4BEB-9BD9-9904111F408A}"/>
+                <a16:creationId xmlns:a16="http://schemas.microsoft.com/office/drawing/2014/main" id="{C515802C-A9FB-445F-AB72-417E7008AD57}"/>
               </a:ext>
             </a:extLst>
           </p:cNvPr>
@@ -16256,7 +16256,7 @@
           <p:cNvPr id="5" name="review-rule-1">
             <a:extLst xmlns:a="http://schemas.openxmlformats.org/drawingml/2006/main">
               <a:ext uri="{FF2B5EF4-FFF2-40B4-BE49-F238E27FC236}">
-                <a16:creationId xmlns:a16="http://schemas.microsoft.com/office/drawing/2014/main" id="{D82F28CA-9E43-4AB5-9FF7-ABB6E766F568}"/>
+                <a16:creationId xmlns:a16="http://schemas.microsoft.com/office/drawing/2014/main" id="{FBB2AFEC-C0C9-426A-8219-537EE85533C7}"/>
               </a:ext>
             </a:extLst>
           </p:cNvPr>
@@ -16287,7 +16287,7 @@
           <p:cNvPr id="6" name="review-card-1-title">
             <a:extLst xmlns:a="http://schemas.openxmlformats.org/drawingml/2006/main">
               <a:ext uri="{FF2B5EF4-FFF2-40B4-BE49-F238E27FC236}">
-                <a16:creationId xmlns:a16="http://schemas.microsoft.com/office/drawing/2014/main" id="{E160B2FB-BE8E-45A0-90B6-DEEF88ADE786}"/>
+                <a16:creationId xmlns:a16="http://schemas.microsoft.com/office/drawing/2014/main" id="{EE739C20-A8ED-4FC2-90BD-5E7347B213CB}"/>
               </a:ext>
             </a:extLst>
           </p:cNvPr>
@@ -16414,7 +16414,7 @@
           <p:cNvPr id="7" name="review-card-1-body">
             <a:extLst xmlns:a="http://schemas.openxmlformats.org/drawingml/2006/main">
               <a:ext uri="{FF2B5EF4-FFF2-40B4-BE49-F238E27FC236}">
-                <a16:creationId xmlns:a16="http://schemas.microsoft.com/office/drawing/2014/main" id="{4723037F-149C-40F5-979A-FB4820FFC73D}"/>
+                <a16:creationId xmlns:a16="http://schemas.microsoft.com/office/drawing/2014/main" id="{C9AC5693-23DD-4764-97FC-1EEEBCE75930}"/>
               </a:ext>
             </a:extLst>
           </p:cNvPr>
@@ -16562,7 +16562,7 @@
           <p:cNvPr id="8" name="review-rule-2">
             <a:extLst xmlns:a="http://schemas.openxmlformats.org/drawingml/2006/main">
               <a:ext uri="{FF2B5EF4-FFF2-40B4-BE49-F238E27FC236}">
-                <a16:creationId xmlns:a16="http://schemas.microsoft.com/office/drawing/2014/main" id="{AA1C34E5-B38E-4E33-95BB-211A502AFCD3}"/>
+                <a16:creationId xmlns:a16="http://schemas.microsoft.com/office/drawing/2014/main" id="{5DFA370A-D3D2-44C0-9224-2F76EB99E468}"/>
               </a:ext>
             </a:extLst>
           </p:cNvPr>
@@ -16593,7 +16593,7 @@
           <p:cNvPr id="9" name="review-card-2-title">
             <a:extLst xmlns:a="http://schemas.openxmlformats.org/drawingml/2006/main">
               <a:ext uri="{FF2B5EF4-FFF2-40B4-BE49-F238E27FC236}">
-                <a16:creationId xmlns:a16="http://schemas.microsoft.com/office/drawing/2014/main" id="{75B5172D-3F91-4D36-A3C1-2D09D039AED4}"/>
+                <a16:creationId xmlns:a16="http://schemas.microsoft.com/office/drawing/2014/main" id="{E4BF4E0A-B380-4526-9933-7A0FE220CCA9}"/>
               </a:ext>
             </a:extLst>
           </p:cNvPr>
@@ -16720,7 +16720,7 @@
           <p:cNvPr id="10" name="review-card-2-body">
             <a:extLst xmlns:a="http://schemas.openxmlformats.org/drawingml/2006/main">
               <a:ext uri="{FF2B5EF4-FFF2-40B4-BE49-F238E27FC236}">
-                <a16:creationId xmlns:a16="http://schemas.microsoft.com/office/drawing/2014/main" id="{519207AA-C691-4C69-B516-2C0817654370}"/>
+                <a16:creationId xmlns:a16="http://schemas.microsoft.com/office/drawing/2014/main" id="{7FF29421-F6CC-4B76-A25E-A14A66E2D306}"/>
               </a:ext>
             </a:extLst>
           </p:cNvPr>
@@ -16868,7 +16868,7 @@
           <p:cNvPr id="11" name="review-rule-3">
             <a:extLst xmlns:a="http://schemas.openxmlformats.org/drawingml/2006/main">
               <a:ext uri="{FF2B5EF4-FFF2-40B4-BE49-F238E27FC236}">
-                <a16:creationId xmlns:a16="http://schemas.microsoft.com/office/drawing/2014/main" id="{2BA4F53B-122A-4DF9-A899-1294B0E7BA78}"/>
+                <a16:creationId xmlns:a16="http://schemas.microsoft.com/office/drawing/2014/main" id="{4465210A-2BFB-4A38-856E-A4207BFAF6ED}"/>
               </a:ext>
             </a:extLst>
           </p:cNvPr>
@@ -16899,7 +16899,7 @@
           <p:cNvPr id="12" name="review-card-3-title">
             <a:extLst xmlns:a="http://schemas.openxmlformats.org/drawingml/2006/main">
               <a:ext uri="{FF2B5EF4-FFF2-40B4-BE49-F238E27FC236}">
-                <a16:creationId xmlns:a16="http://schemas.microsoft.com/office/drawing/2014/main" id="{3A5B5A61-C709-4DC4-997A-A6EA1AC6B8A7}"/>
+                <a16:creationId xmlns:a16="http://schemas.microsoft.com/office/drawing/2014/main" id="{932D5456-8BD1-478B-89D4-C7BEC82EB17D}"/>
               </a:ext>
             </a:extLst>
           </p:cNvPr>
@@ -17026,7 +17026,7 @@
           <p:cNvPr id="13" name="review-card-3-body">
             <a:extLst xmlns:a="http://schemas.openxmlformats.org/drawingml/2006/main">
               <a:ext uri="{FF2B5EF4-FFF2-40B4-BE49-F238E27FC236}">
-                <a16:creationId xmlns:a16="http://schemas.microsoft.com/office/drawing/2014/main" id="{1F13FBE7-7B80-4468-A10B-A2DB04D5C292}"/>
+                <a16:creationId xmlns:a16="http://schemas.microsoft.com/office/drawing/2014/main" id="{FA08BBE6-8A0B-413B-8F4E-FB56D807B261}"/>
               </a:ext>
             </a:extLst>
           </p:cNvPr>
@@ -17174,7 +17174,7 @@
           <p:cNvPr id="14" name="review-footer-note">
             <a:extLst xmlns:a="http://schemas.openxmlformats.org/drawingml/2006/main">
               <a:ext uri="{FF2B5EF4-FFF2-40B4-BE49-F238E27FC236}">
-                <a16:creationId xmlns:a16="http://schemas.microsoft.com/office/drawing/2014/main" id="{694755A4-6893-41B6-83AC-8AD8FA3725E4}"/>
+                <a16:creationId xmlns:a16="http://schemas.microsoft.com/office/drawing/2014/main" id="{E3914DF1-78D3-40CF-B882-BF44CD63B741}"/>
               </a:ext>
             </a:extLst>
           </p:cNvPr>
@@ -17301,7 +17301,7 @@
           <p:cNvPr id="15" name="footer">
             <a:extLst xmlns:a="http://schemas.openxmlformats.org/drawingml/2006/main">
               <a:ext uri="{FF2B5EF4-FFF2-40B4-BE49-F238E27FC236}">
-                <a16:creationId xmlns:a16="http://schemas.microsoft.com/office/drawing/2014/main" id="{46F153D1-68CE-4549-B70F-AFA6A493350F}"/>
+                <a16:creationId xmlns:a16="http://schemas.microsoft.com/office/drawing/2014/main" id="{3A23352E-E002-4D25-8D36-3BA0476B8EC4}"/>
               </a:ext>
             </a:extLst>
           </p:cNvPr>
@@ -17426,7 +17426,7 @@
     </p:spTree>
     <p:extLst>
       <p:ext uri="{BB962C8B-B14F-4D97-AF65-F5344CB8AC3E}">
-        <p14:creationId xmlns:p14="http://schemas.microsoft.com/office/powerpoint/2010/main" val="1048305570"/>
+        <p14:creationId xmlns:p14="http://schemas.microsoft.com/office/powerpoint/2010/main" val="1268155137"/>
       </p:ext>
     </p:extLst>
   </p:cSld>
@@ -17457,7 +17457,7 @@
           <p:cNvPr id="15" name="eyebrow">
             <a:extLst xmlns:a="http://schemas.openxmlformats.org/drawingml/2006/main">
               <a:ext uri="{FF2B5EF4-FFF2-40B4-BE49-F238E27FC236}">
-                <a16:creationId xmlns:a16="http://schemas.microsoft.com/office/drawing/2014/main" id="{F4724896-0BEA-4D8C-9208-2AD28D888984}"/>
+                <a16:creationId xmlns:a16="http://schemas.microsoft.com/office/drawing/2014/main" id="{4D17B3A4-9539-45BC-811B-8E18E149A2DA}"/>
               </a:ext>
             </a:extLst>
           </p:cNvPr>
@@ -17584,7 +17584,7 @@
           <p:cNvPr id="2" name="page">
             <a:extLst xmlns:a="http://schemas.openxmlformats.org/drawingml/2006/main">
               <a:ext uri="{FF2B5EF4-FFF2-40B4-BE49-F238E27FC236}">
-                <a16:creationId xmlns:a16="http://schemas.microsoft.com/office/drawing/2014/main" id="{0112014D-8991-425A-B0AA-E5661F8F96A1}"/>
+                <a16:creationId xmlns:a16="http://schemas.microsoft.com/office/drawing/2014/main" id="{A3170FCE-DAFC-4D9B-ABFC-431F6D86CAE5}"/>
               </a:ext>
             </a:extLst>
           </p:cNvPr>
@@ -17711,7 +17711,7 @@
           <p:cNvPr id="3" name="index-rule">
             <a:extLst xmlns:a="http://schemas.openxmlformats.org/drawingml/2006/main">
               <a:ext uri="{FF2B5EF4-FFF2-40B4-BE49-F238E27FC236}">
-                <a16:creationId xmlns:a16="http://schemas.microsoft.com/office/drawing/2014/main" id="{EA5513F6-152D-4D8B-BFB7-1669EE45F1BD}"/>
+                <a16:creationId xmlns:a16="http://schemas.microsoft.com/office/drawing/2014/main" id="{23A43488-39F9-4BE2-8515-9BDEC7C2C48F}"/>
               </a:ext>
             </a:extLst>
           </p:cNvPr>
@@ -17742,7 +17742,7 @@
           <p:cNvPr id="4" name="title">
             <a:extLst xmlns:a="http://schemas.openxmlformats.org/drawingml/2006/main">
               <a:ext uri="{FF2B5EF4-FFF2-40B4-BE49-F238E27FC236}">
-                <a16:creationId xmlns:a16="http://schemas.microsoft.com/office/drawing/2014/main" id="{AD10EBF8-A462-4104-AE57-93509424E799}"/>
+                <a16:creationId xmlns:a16="http://schemas.microsoft.com/office/drawing/2014/main" id="{F89E671E-571D-4E76-B6A5-BF4534B2295F}"/>
               </a:ext>
             </a:extLst>
           </p:cNvPr>
@@ -17869,7 +17869,7 @@
           <p:cNvPr id="5" name="index-source">
             <a:extLst xmlns:a="http://schemas.openxmlformats.org/drawingml/2006/main">
               <a:ext uri="{FF2B5EF4-FFF2-40B4-BE49-F238E27FC236}">
-                <a16:creationId xmlns:a16="http://schemas.microsoft.com/office/drawing/2014/main" id="{830390EF-1ED4-4B3D-9D5A-F930EBB10C88}"/>
+                <a16:creationId xmlns:a16="http://schemas.microsoft.com/office/drawing/2014/main" id="{71C909DD-6D6B-4608-ABE6-285BF371D54C}"/>
               </a:ext>
             </a:extLst>
           </p:cNvPr>
@@ -17904,7 +17904,7 @@
           <p:cNvPr id="6" name="index-source-text">
             <a:extLst xmlns:a="http://schemas.openxmlformats.org/drawingml/2006/main">
               <a:ext uri="{FF2B5EF4-FFF2-40B4-BE49-F238E27FC236}">
-                <a16:creationId xmlns:a16="http://schemas.microsoft.com/office/drawing/2014/main" id="{6C0BCCB5-BD71-417C-B1A9-2619E3348AC6}"/>
+                <a16:creationId xmlns:a16="http://schemas.microsoft.com/office/drawing/2014/main" id="{C1C6E395-0AF7-4F56-918E-2BD8DCAB229B}"/>
               </a:ext>
             </a:extLst>
           </p:cNvPr>
@@ -18052,7 +18052,7 @@
           <p:cNvPr id="7" name="index-derived">
             <a:extLst xmlns:a="http://schemas.openxmlformats.org/drawingml/2006/main">
               <a:ext uri="{FF2B5EF4-FFF2-40B4-BE49-F238E27FC236}">
-                <a16:creationId xmlns:a16="http://schemas.microsoft.com/office/drawing/2014/main" id="{9A554AF5-5A74-4E90-9FA1-F7993A46E039}"/>
+                <a16:creationId xmlns:a16="http://schemas.microsoft.com/office/drawing/2014/main" id="{0A2DE9BC-14E5-4723-AC2F-7B67BB6EBDE4}"/>
               </a:ext>
             </a:extLst>
           </p:cNvPr>
@@ -18087,7 +18087,7 @@
           <p:cNvPr id="8" name="index-derived-text">
             <a:extLst xmlns:a="http://schemas.openxmlformats.org/drawingml/2006/main">
               <a:ext uri="{FF2B5EF4-FFF2-40B4-BE49-F238E27FC236}">
-                <a16:creationId xmlns:a16="http://schemas.microsoft.com/office/drawing/2014/main" id="{9D3C01CB-DF71-4C44-9601-BBD96207A19D}"/>
+                <a16:creationId xmlns:a16="http://schemas.microsoft.com/office/drawing/2014/main" id="{5C10D684-66B2-4F28-A88C-A526C2FAB10F}"/>
               </a:ext>
             </a:extLst>
           </p:cNvPr>
@@ -18235,7 +18235,7 @@
           <p:cNvPr id="9" name="index-api">
             <a:extLst xmlns:a="http://schemas.openxmlformats.org/drawingml/2006/main">
               <a:ext uri="{FF2B5EF4-FFF2-40B4-BE49-F238E27FC236}">
-                <a16:creationId xmlns:a16="http://schemas.microsoft.com/office/drawing/2014/main" id="{A35B11B2-48E1-4D38-B5C1-022535DCCE93}"/>
+                <a16:creationId xmlns:a16="http://schemas.microsoft.com/office/drawing/2014/main" id="{0C853FBF-02C6-493F-8FEF-16ABC870AEFF}"/>
               </a:ext>
             </a:extLst>
           </p:cNvPr>
@@ -18270,7 +18270,7 @@
           <p:cNvPr id="10" name="index-api-text">
             <a:extLst xmlns:a="http://schemas.openxmlformats.org/drawingml/2006/main">
               <a:ext uri="{FF2B5EF4-FFF2-40B4-BE49-F238E27FC236}">
-                <a16:creationId xmlns:a16="http://schemas.microsoft.com/office/drawing/2014/main" id="{F077A899-E0BA-4A1B-BC4C-1B19865D3C06}"/>
+                <a16:creationId xmlns:a16="http://schemas.microsoft.com/office/drawing/2014/main" id="{E2E4372C-8987-4FFF-B353-2A51276675EC}"/>
               </a:ext>
             </a:extLst>
           </p:cNvPr>
@@ -18418,7 +18418,7 @@
           <p:cNvPr id="11" name="index-arrow-1">
             <a:extLst xmlns:a="http://schemas.openxmlformats.org/drawingml/2006/main">
               <a:ext uri="{FF2B5EF4-FFF2-40B4-BE49-F238E27FC236}">
-                <a16:creationId xmlns:a16="http://schemas.microsoft.com/office/drawing/2014/main" id="{8F95CD58-AD3A-4D09-B5ED-6581D5B445C9}"/>
+                <a16:creationId xmlns:a16="http://schemas.microsoft.com/office/drawing/2014/main" id="{D534EBFC-01FF-4213-999C-E2DB8C66D89F}"/>
               </a:ext>
             </a:extLst>
           </p:cNvPr>
@@ -18545,7 +18545,7 @@
           <p:cNvPr id="12" name="index-arrow-2">
             <a:extLst xmlns:a="http://schemas.openxmlformats.org/drawingml/2006/main">
               <a:ext uri="{FF2B5EF4-FFF2-40B4-BE49-F238E27FC236}">
-                <a16:creationId xmlns:a16="http://schemas.microsoft.com/office/drawing/2014/main" id="{FD8FA3B6-A625-43A4-9560-AE8128F149F0}"/>
+                <a16:creationId xmlns:a16="http://schemas.microsoft.com/office/drawing/2014/main" id="{A8B72192-7C8E-4C45-A0F6-5269EECDE817}"/>
               </a:ext>
             </a:extLst>
           </p:cNvPr>
@@ -18672,7 +18672,7 @@
           <p:cNvPr id="13" name="index-body">
             <a:extLst xmlns:a="http://schemas.openxmlformats.org/drawingml/2006/main">
               <a:ext uri="{FF2B5EF4-FFF2-40B4-BE49-F238E27FC236}">
-                <a16:creationId xmlns:a16="http://schemas.microsoft.com/office/drawing/2014/main" id="{9A72DB1E-6546-4596-98F3-760E5534F7BB}"/>
+                <a16:creationId xmlns:a16="http://schemas.microsoft.com/office/drawing/2014/main" id="{047AAAD6-C8F2-45A6-B6C9-0CE2769E88CE}"/>
               </a:ext>
             </a:extLst>
           </p:cNvPr>
@@ -18799,7 +18799,7 @@
           <p:cNvPr id="14" name="footer">
             <a:extLst xmlns:a="http://schemas.openxmlformats.org/drawingml/2006/main">
               <a:ext uri="{FF2B5EF4-FFF2-40B4-BE49-F238E27FC236}">
-                <a16:creationId xmlns:a16="http://schemas.microsoft.com/office/drawing/2014/main" id="{79AB221D-9F6E-448F-9415-C16A0331E46F}"/>
+                <a16:creationId xmlns:a16="http://schemas.microsoft.com/office/drawing/2014/main" id="{A9F51B2E-F526-4F0E-8B87-86FCB7E3A093}"/>
               </a:ext>
             </a:extLst>
           </p:cNvPr>
@@ -18924,7 +18924,7 @@
     </p:spTree>
     <p:extLst>
       <p:ext uri="{BB962C8B-B14F-4D97-AF65-F5344CB8AC3E}">
-        <p14:creationId xmlns:p14="http://schemas.microsoft.com/office/powerpoint/2010/main" val="1476702767"/>
+        <p14:creationId xmlns:p14="http://schemas.microsoft.com/office/powerpoint/2010/main" val="1335841391"/>
       </p:ext>
     </p:extLst>
   </p:cSld>
@@ -18955,7 +18955,7 @@
           <p:cNvPr id="15" name="eyebrow">
             <a:extLst xmlns:a="http://schemas.openxmlformats.org/drawingml/2006/main">
               <a:ext uri="{FF2B5EF4-FFF2-40B4-BE49-F238E27FC236}">
-                <a16:creationId xmlns:a16="http://schemas.microsoft.com/office/drawing/2014/main" id="{E9200867-743B-4CEC-AC49-F501747A788A}"/>
+                <a16:creationId xmlns:a16="http://schemas.microsoft.com/office/drawing/2014/main" id="{554C69C8-DDEA-446C-B69C-4420F792C767}"/>
               </a:ext>
             </a:extLst>
           </p:cNvPr>
@@ -19082,7 +19082,7 @@
           <p:cNvPr id="2" name="page">
             <a:extLst xmlns:a="http://schemas.openxmlformats.org/drawingml/2006/main">
               <a:ext uri="{FF2B5EF4-FFF2-40B4-BE49-F238E27FC236}">
-                <a16:creationId xmlns:a16="http://schemas.microsoft.com/office/drawing/2014/main" id="{872534FC-9E1A-4EEA-87D9-47BBBB3E24B0}"/>
+                <a16:creationId xmlns:a16="http://schemas.microsoft.com/office/drawing/2014/main" id="{6A0B5392-B205-455C-B729-80198312139D}"/>
               </a:ext>
             </a:extLst>
           </p:cNvPr>
@@ -19209,7 +19209,7 @@
           <p:cNvPr id="3" name="modes-rule">
             <a:extLst xmlns:a="http://schemas.openxmlformats.org/drawingml/2006/main">
               <a:ext uri="{FF2B5EF4-FFF2-40B4-BE49-F238E27FC236}">
-                <a16:creationId xmlns:a16="http://schemas.microsoft.com/office/drawing/2014/main" id="{57CCAF4B-C88C-4947-9FFC-83C5F4E2625A}"/>
+                <a16:creationId xmlns:a16="http://schemas.microsoft.com/office/drawing/2014/main" id="{A5DE9DED-E17B-4AF4-9665-F00F7F98F1B0}"/>
               </a:ext>
             </a:extLst>
           </p:cNvPr>
@@ -19240,7 +19240,7 @@
           <p:cNvPr id="4" name="title">
             <a:extLst xmlns:a="http://schemas.openxmlformats.org/drawingml/2006/main">
               <a:ext uri="{FF2B5EF4-FFF2-40B4-BE49-F238E27FC236}">
-                <a16:creationId xmlns:a16="http://schemas.microsoft.com/office/drawing/2014/main" id="{F73C8096-0B70-4D49-BC57-2C69EB0B2AF4}"/>
+                <a16:creationId xmlns:a16="http://schemas.microsoft.com/office/drawing/2014/main" id="{5D286D72-2879-40E5-BC3B-F42C9F7329E3}"/>
               </a:ext>
             </a:extLst>
           </p:cNvPr>
@@ -19367,7 +19367,7 @@
           <p:cNvPr id="5" name="keyword-rule">
             <a:extLst xmlns:a="http://schemas.openxmlformats.org/drawingml/2006/main">
               <a:ext uri="{FF2B5EF4-FFF2-40B4-BE49-F238E27FC236}">
-                <a16:creationId xmlns:a16="http://schemas.microsoft.com/office/drawing/2014/main" id="{F4138430-6930-4CC6-8CDF-0D135D987765}"/>
+                <a16:creationId xmlns:a16="http://schemas.microsoft.com/office/drawing/2014/main" id="{19987DD8-FDDE-46FA-A08C-6C2F6CFAC199}"/>
               </a:ext>
             </a:extLst>
           </p:cNvPr>
@@ -19398,7 +19398,7 @@
           <p:cNvPr id="6" name="keyword-title">
             <a:extLst xmlns:a="http://schemas.openxmlformats.org/drawingml/2006/main">
               <a:ext uri="{FF2B5EF4-FFF2-40B4-BE49-F238E27FC236}">
-                <a16:creationId xmlns:a16="http://schemas.microsoft.com/office/drawing/2014/main" id="{7B19B304-F82C-4C17-B9CD-71A2757FBE4C}"/>
+                <a16:creationId xmlns:a16="http://schemas.microsoft.com/office/drawing/2014/main" id="{5AAA26B0-1653-435D-B506-215D13E7A33E}"/>
               </a:ext>
             </a:extLst>
           </p:cNvPr>
@@ -19525,7 +19525,7 @@
           <p:cNvPr id="7" name="keyword-score">
             <a:extLst xmlns:a="http://schemas.openxmlformats.org/drawingml/2006/main">
               <a:ext uri="{FF2B5EF4-FFF2-40B4-BE49-F238E27FC236}">
-                <a16:creationId xmlns:a16="http://schemas.microsoft.com/office/drawing/2014/main" id="{07B9D691-1FB8-4742-A705-BDF9F378FF23}"/>
+                <a16:creationId xmlns:a16="http://schemas.microsoft.com/office/drawing/2014/main" id="{F8C7349E-4DB3-41E0-8C31-433F1E5F2FD7}"/>
               </a:ext>
             </a:extLst>
           </p:cNvPr>
@@ -19652,7 +19652,7 @@
           <p:cNvPr id="8" name="keyword-body">
             <a:extLst xmlns:a="http://schemas.openxmlformats.org/drawingml/2006/main">
               <a:ext uri="{FF2B5EF4-FFF2-40B4-BE49-F238E27FC236}">
-                <a16:creationId xmlns:a16="http://schemas.microsoft.com/office/drawing/2014/main" id="{FECACCF4-299A-4E02-8A3C-D8827A9E886D}"/>
+                <a16:creationId xmlns:a16="http://schemas.microsoft.com/office/drawing/2014/main" id="{EA245A59-231C-439E-8F8F-F7A072074281}"/>
               </a:ext>
             </a:extLst>
           </p:cNvPr>
@@ -19779,7 +19779,7 @@
           <p:cNvPr id="9" name="semantic-rule">
             <a:extLst xmlns:a="http://schemas.openxmlformats.org/drawingml/2006/main">
               <a:ext uri="{FF2B5EF4-FFF2-40B4-BE49-F238E27FC236}">
-                <a16:creationId xmlns:a16="http://schemas.microsoft.com/office/drawing/2014/main" id="{3C65D953-63E3-4E31-A82E-FC92F7A0ACEC}"/>
+                <a16:creationId xmlns:a16="http://schemas.microsoft.com/office/drawing/2014/main" id="{231F35F2-18B8-433C-8C43-6270F88E4A3F}"/>
               </a:ext>
             </a:extLst>
           </p:cNvPr>
@@ -19810,7 +19810,7 @@
           <p:cNvPr id="10" name="semantic-title">
             <a:extLst xmlns:a="http://schemas.openxmlformats.org/drawingml/2006/main">
               <a:ext uri="{FF2B5EF4-FFF2-40B4-BE49-F238E27FC236}">
-                <a16:creationId xmlns:a16="http://schemas.microsoft.com/office/drawing/2014/main" id="{7413A597-E312-44E9-92A1-9C638257A12B}"/>
+                <a16:creationId xmlns:a16="http://schemas.microsoft.com/office/drawing/2014/main" id="{D99E5AD4-BCBC-4FDD-B324-E4AD02B0C220}"/>
               </a:ext>
             </a:extLst>
           </p:cNvPr>
@@ -19937,7 +19937,7 @@
           <p:cNvPr id="11" name="semantic-state">
             <a:extLst xmlns:a="http://schemas.openxmlformats.org/drawingml/2006/main">
               <a:ext uri="{FF2B5EF4-FFF2-40B4-BE49-F238E27FC236}">
-                <a16:creationId xmlns:a16="http://schemas.microsoft.com/office/drawing/2014/main" id="{BE1036AB-F915-4097-ABE4-C3DDCC1C4375}"/>
+                <a16:creationId xmlns:a16="http://schemas.microsoft.com/office/drawing/2014/main" id="{D42A249C-C8FF-415A-9F9C-6386E93D9DF9}"/>
               </a:ext>
             </a:extLst>
           </p:cNvPr>
@@ -20064,7 +20064,7 @@
           <p:cNvPr id="12" name="semantic-body">
             <a:extLst xmlns:a="http://schemas.openxmlformats.org/drawingml/2006/main">
               <a:ext uri="{FF2B5EF4-FFF2-40B4-BE49-F238E27FC236}">
-                <a16:creationId xmlns:a16="http://schemas.microsoft.com/office/drawing/2014/main" id="{F6DF5709-934F-4B27-A076-4B1227B5E387}"/>
+                <a16:creationId xmlns:a16="http://schemas.microsoft.com/office/drawing/2014/main" id="{16C9541F-16A2-4093-B3B9-F07A3477661B}"/>
               </a:ext>
             </a:extLst>
           </p:cNvPr>
@@ -20212,7 +20212,7 @@
           <p:cNvPr id="13" name="modes-footer-note">
             <a:extLst xmlns:a="http://schemas.openxmlformats.org/drawingml/2006/main">
               <a:ext uri="{FF2B5EF4-FFF2-40B4-BE49-F238E27FC236}">
-                <a16:creationId xmlns:a16="http://schemas.microsoft.com/office/drawing/2014/main" id="{89344F8C-76F5-43A0-9317-4E94AF1B3C5F}"/>
+                <a16:creationId xmlns:a16="http://schemas.microsoft.com/office/drawing/2014/main" id="{CDF2559E-7456-41B9-8070-94DAF41CA42D}"/>
               </a:ext>
             </a:extLst>
           </p:cNvPr>
@@ -20339,7 +20339,7 @@
           <p:cNvPr id="14" name="footer">
             <a:extLst xmlns:a="http://schemas.openxmlformats.org/drawingml/2006/main">
               <a:ext uri="{FF2B5EF4-FFF2-40B4-BE49-F238E27FC236}">
-                <a16:creationId xmlns:a16="http://schemas.microsoft.com/office/drawing/2014/main" id="{75FFD5EB-100D-4BFD-80EE-A9FDB71A28A5}"/>
+                <a16:creationId xmlns:a16="http://schemas.microsoft.com/office/drawing/2014/main" id="{F4D8EB93-A528-4BFE-8535-BD6D521E308C}"/>
               </a:ext>
             </a:extLst>
           </p:cNvPr>
@@ -20464,7 +20464,7 @@
     </p:spTree>
     <p:extLst>
       <p:ext uri="{BB962C8B-B14F-4D97-AF65-F5344CB8AC3E}">
-        <p14:creationId xmlns:p14="http://schemas.microsoft.com/office/powerpoint/2010/main" val="1976032038"/>
+        <p14:creationId xmlns:p14="http://schemas.microsoft.com/office/powerpoint/2010/main" val="1422350240"/>
       </p:ext>
     </p:extLst>
   </p:cSld>
@@ -20495,7 +20495,7 @@
           <p:cNvPr id="22" name="eyebrow">
             <a:extLst xmlns:a="http://schemas.openxmlformats.org/drawingml/2006/main">
               <a:ext uri="{FF2B5EF4-FFF2-40B4-BE49-F238E27FC236}">
-                <a16:creationId xmlns:a16="http://schemas.microsoft.com/office/drawing/2014/main" id="{1C991387-2E41-422B-956C-CE465048CD7E}"/>
+                <a16:creationId xmlns:a16="http://schemas.microsoft.com/office/drawing/2014/main" id="{AE404F6F-41EF-4D95-A6AF-A2F34A35471B}"/>
               </a:ext>
             </a:extLst>
           </p:cNvPr>
@@ -20622,7 +20622,7 @@
           <p:cNvPr id="2" name="page">
             <a:extLst xmlns:a="http://schemas.openxmlformats.org/drawingml/2006/main">
               <a:ext uri="{FF2B5EF4-FFF2-40B4-BE49-F238E27FC236}">
-                <a16:creationId xmlns:a16="http://schemas.microsoft.com/office/drawing/2014/main" id="{D9ED31E2-F9ED-4D83-A755-C97EDF950582}"/>
+                <a16:creationId xmlns:a16="http://schemas.microsoft.com/office/drawing/2014/main" id="{83891D8E-5776-4633-9CBA-3FF660052C44}"/>
               </a:ext>
             </a:extLst>
           </p:cNvPr>
@@ -20749,7 +20749,7 @@
           <p:cNvPr id="3" name="browser-rule">
             <a:extLst xmlns:a="http://schemas.openxmlformats.org/drawingml/2006/main">
               <a:ext uri="{FF2B5EF4-FFF2-40B4-BE49-F238E27FC236}">
-                <a16:creationId xmlns:a16="http://schemas.microsoft.com/office/drawing/2014/main" id="{8BBEB581-897C-456A-A534-92838210F3FA}"/>
+                <a16:creationId xmlns:a16="http://schemas.microsoft.com/office/drawing/2014/main" id="{B7B1EB86-6DE1-41A3-8F2A-1038A86BD9D5}"/>
               </a:ext>
             </a:extLst>
           </p:cNvPr>
@@ -20780,7 +20780,7 @@
           <p:cNvPr id="4" name="title">
             <a:extLst xmlns:a="http://schemas.openxmlformats.org/drawingml/2006/main">
               <a:ext uri="{FF2B5EF4-FFF2-40B4-BE49-F238E27FC236}">
-                <a16:creationId xmlns:a16="http://schemas.microsoft.com/office/drawing/2014/main" id="{473C4C1F-4950-492A-918F-1000C9D72880}"/>
+                <a16:creationId xmlns:a16="http://schemas.microsoft.com/office/drawing/2014/main" id="{D5C721E8-329C-4269-977F-B43D072ED919}"/>
               </a:ext>
             </a:extLst>
           </p:cNvPr>
@@ -20907,7 +20907,7 @@
           <p:cNvPr id="5" name="browser-num-01">
             <a:extLst xmlns:a="http://schemas.openxmlformats.org/drawingml/2006/main">
               <a:ext uri="{FF2B5EF4-FFF2-40B4-BE49-F238E27FC236}">
-                <a16:creationId xmlns:a16="http://schemas.microsoft.com/office/drawing/2014/main" id="{F8BD5CC5-B8FB-444A-9802-FA653A0C05CF}"/>
+                <a16:creationId xmlns:a16="http://schemas.microsoft.com/office/drawing/2014/main" id="{FF9015A2-8AA3-4796-970F-4E79119CCA1B}"/>
               </a:ext>
             </a:extLst>
           </p:cNvPr>
@@ -21034,7 +21034,7 @@
           <p:cNvPr id="6" name="browser-title-01">
             <a:extLst xmlns:a="http://schemas.openxmlformats.org/drawingml/2006/main">
               <a:ext uri="{FF2B5EF4-FFF2-40B4-BE49-F238E27FC236}">
-                <a16:creationId xmlns:a16="http://schemas.microsoft.com/office/drawing/2014/main" id="{A0C719EC-DB8F-4D90-9B5A-C2AC9C10FA68}"/>
+                <a16:creationId xmlns:a16="http://schemas.microsoft.com/office/drawing/2014/main" id="{868BCB70-B577-423F-965E-D679030BC14A}"/>
               </a:ext>
             </a:extLst>
           </p:cNvPr>
@@ -21161,7 +21161,7 @@
           <p:cNvPr id="7" name="browser-detail-01">
             <a:extLst xmlns:a="http://schemas.openxmlformats.org/drawingml/2006/main">
               <a:ext uri="{FF2B5EF4-FFF2-40B4-BE49-F238E27FC236}">
-                <a16:creationId xmlns:a16="http://schemas.microsoft.com/office/drawing/2014/main" id="{66D70957-F2D0-4C0A-849C-8F17395D2B14}"/>
+                <a16:creationId xmlns:a16="http://schemas.microsoft.com/office/drawing/2014/main" id="{0E10A8BA-5075-4468-9414-2B1CE7334C8A}"/>
               </a:ext>
             </a:extLst>
           </p:cNvPr>
@@ -21288,7 +21288,7 @@
           <p:cNvPr id="8" name="browser-line-01">
             <a:extLst xmlns:a="http://schemas.openxmlformats.org/drawingml/2006/main">
               <a:ext uri="{FF2B5EF4-FFF2-40B4-BE49-F238E27FC236}">
-                <a16:creationId xmlns:a16="http://schemas.microsoft.com/office/drawing/2014/main" id="{EDA1F4B8-58FD-4E6D-B88D-60472D832CEE}"/>
+                <a16:creationId xmlns:a16="http://schemas.microsoft.com/office/drawing/2014/main" id="{F6AB64C7-FE0D-41A4-8D62-0ED9FA1928F5}"/>
               </a:ext>
             </a:extLst>
           </p:cNvPr>
@@ -21319,7 +21319,7 @@
           <p:cNvPr id="9" name="browser-num-02">
             <a:extLst xmlns:a="http://schemas.openxmlformats.org/drawingml/2006/main">
               <a:ext uri="{FF2B5EF4-FFF2-40B4-BE49-F238E27FC236}">
-                <a16:creationId xmlns:a16="http://schemas.microsoft.com/office/drawing/2014/main" id="{3FA416AB-88BD-47C5-8B06-99BF7420E692}"/>
+                <a16:creationId xmlns:a16="http://schemas.microsoft.com/office/drawing/2014/main" id="{EC754083-DF61-4B69-8F3F-4FC469014D77}"/>
               </a:ext>
             </a:extLst>
           </p:cNvPr>
@@ -21446,7 +21446,7 @@
           <p:cNvPr id="10" name="browser-title-02">
             <a:extLst xmlns:a="http://schemas.openxmlformats.org/drawingml/2006/main">
               <a:ext uri="{FF2B5EF4-FFF2-40B4-BE49-F238E27FC236}">
-                <a16:creationId xmlns:a16="http://schemas.microsoft.com/office/drawing/2014/main" id="{D83D2BAB-FA6E-4E1A-BE5A-D8DC53DED8B4}"/>
+                <a16:creationId xmlns:a16="http://schemas.microsoft.com/office/drawing/2014/main" id="{CF3F7B35-D971-475E-B1C9-6A81783AF2A1}"/>
               </a:ext>
             </a:extLst>
           </p:cNvPr>
@@ -21573,7 +21573,7 @@
           <p:cNvPr id="11" name="browser-detail-02">
             <a:extLst xmlns:a="http://schemas.openxmlformats.org/drawingml/2006/main">
               <a:ext uri="{FF2B5EF4-FFF2-40B4-BE49-F238E27FC236}">
-                <a16:creationId xmlns:a16="http://schemas.microsoft.com/office/drawing/2014/main" id="{655428ED-F55A-47F2-979D-1A1BD4E0840F}"/>
+                <a16:creationId xmlns:a16="http://schemas.microsoft.com/office/drawing/2014/main" id="{9716BCE4-EAEF-44D5-85F4-3FC389029B3B}"/>
               </a:ext>
             </a:extLst>
           </p:cNvPr>
@@ -21700,7 +21700,7 @@
           <p:cNvPr id="12" name="browser-line-02">
             <a:extLst xmlns:a="http://schemas.openxmlformats.org/drawingml/2006/main">
               <a:ext uri="{FF2B5EF4-FFF2-40B4-BE49-F238E27FC236}">
-                <a16:creationId xmlns:a16="http://schemas.microsoft.com/office/drawing/2014/main" id="{83695F09-64A3-411E-8321-769138172BAF}"/>
+                <a16:creationId xmlns:a16="http://schemas.microsoft.com/office/drawing/2014/main" id="{73A25CCA-1BDB-4B17-B2B1-A53AD1760E6D}"/>
               </a:ext>
             </a:extLst>
           </p:cNvPr>
@@ -21731,7 +21731,7 @@
           <p:cNvPr id="13" name="browser-num-03">
             <a:extLst xmlns:a="http://schemas.openxmlformats.org/drawingml/2006/main">
               <a:ext uri="{FF2B5EF4-FFF2-40B4-BE49-F238E27FC236}">
-                <a16:creationId xmlns:a16="http://schemas.microsoft.com/office/drawing/2014/main" id="{37667F72-3FE7-481A-8F20-139565B3BB1C}"/>
+                <a16:creationId xmlns:a16="http://schemas.microsoft.com/office/drawing/2014/main" id="{1D6EBE89-D452-42D5-91F0-C643FAE15065}"/>
               </a:ext>
             </a:extLst>
           </p:cNvPr>
@@ -21858,7 +21858,7 @@
           <p:cNvPr id="14" name="browser-title-03">
             <a:extLst xmlns:a="http://schemas.openxmlformats.org/drawingml/2006/main">
               <a:ext uri="{FF2B5EF4-FFF2-40B4-BE49-F238E27FC236}">
-                <a16:creationId xmlns:a16="http://schemas.microsoft.com/office/drawing/2014/main" id="{90237819-4C18-45DB-8A54-BD2A5BE63D77}"/>
+                <a16:creationId xmlns:a16="http://schemas.microsoft.com/office/drawing/2014/main" id="{DAC48350-D0A0-4936-A1F1-EF9AB43329DF}"/>
               </a:ext>
             </a:extLst>
           </p:cNvPr>
@@ -21985,7 +21985,7 @@
           <p:cNvPr id="15" name="browser-detail-03">
             <a:extLst xmlns:a="http://schemas.openxmlformats.org/drawingml/2006/main">
               <a:ext uri="{FF2B5EF4-FFF2-40B4-BE49-F238E27FC236}">
-                <a16:creationId xmlns:a16="http://schemas.microsoft.com/office/drawing/2014/main" id="{2910E0DB-8CEC-4526-8FA8-7871A9239EFE}"/>
+                <a16:creationId xmlns:a16="http://schemas.microsoft.com/office/drawing/2014/main" id="{155BB64C-726F-4242-B8D2-84A8AB83C5DC}"/>
               </a:ext>
             </a:extLst>
           </p:cNvPr>
@@ -22112,7 +22112,7 @@
           <p:cNvPr id="16" name="browser-line-03">
             <a:extLst xmlns:a="http://schemas.openxmlformats.org/drawingml/2006/main">
               <a:ext uri="{FF2B5EF4-FFF2-40B4-BE49-F238E27FC236}">
-                <a16:creationId xmlns:a16="http://schemas.microsoft.com/office/drawing/2014/main" id="{C235E19E-F1B3-4474-A2C5-B37B1F450AF8}"/>
+                <a16:creationId xmlns:a16="http://schemas.microsoft.com/office/drawing/2014/main" id="{164BF039-C5B3-46BE-B490-97AD7B4663C8}"/>
               </a:ext>
             </a:extLst>
           </p:cNvPr>
@@ -22143,7 +22143,7 @@
           <p:cNvPr id="17" name="browser-num-04">
             <a:extLst xmlns:a="http://schemas.openxmlformats.org/drawingml/2006/main">
               <a:ext uri="{FF2B5EF4-FFF2-40B4-BE49-F238E27FC236}">
-                <a16:creationId xmlns:a16="http://schemas.microsoft.com/office/drawing/2014/main" id="{F0B3E9A3-BC92-4C91-91F7-58A9CE5C2241}"/>
+                <a16:creationId xmlns:a16="http://schemas.microsoft.com/office/drawing/2014/main" id="{905AE732-DF21-4429-853C-2343BDA060AA}"/>
               </a:ext>
             </a:extLst>
           </p:cNvPr>
@@ -22270,7 +22270,7 @@
           <p:cNvPr id="18" name="browser-title-04">
             <a:extLst xmlns:a="http://schemas.openxmlformats.org/drawingml/2006/main">
               <a:ext uri="{FF2B5EF4-FFF2-40B4-BE49-F238E27FC236}">
-                <a16:creationId xmlns:a16="http://schemas.microsoft.com/office/drawing/2014/main" id="{DB766294-E4D8-4F4A-A344-46927B72CDE1}"/>
+                <a16:creationId xmlns:a16="http://schemas.microsoft.com/office/drawing/2014/main" id="{D69CEAAB-C357-488F-AF2B-5090F1BB93C6}"/>
               </a:ext>
             </a:extLst>
           </p:cNvPr>
@@ -22397,7 +22397,7 @@
           <p:cNvPr id="19" name="browser-detail-04">
             <a:extLst xmlns:a="http://schemas.openxmlformats.org/drawingml/2006/main">
               <a:ext uri="{FF2B5EF4-FFF2-40B4-BE49-F238E27FC236}">
-                <a16:creationId xmlns:a16="http://schemas.microsoft.com/office/drawing/2014/main" id="{0C19636F-8F52-4A5A-BED8-E6AAA8F6B0FB}"/>
+                <a16:creationId xmlns:a16="http://schemas.microsoft.com/office/drawing/2014/main" id="{5AA0FB2F-A050-4F5A-8659-820F30160DC6}"/>
               </a:ext>
             </a:extLst>
           </p:cNvPr>
@@ -22524,7 +22524,7 @@
           <p:cNvPr id="20" name="browser-line-04">
             <a:extLst xmlns:a="http://schemas.openxmlformats.org/drawingml/2006/main">
               <a:ext uri="{FF2B5EF4-FFF2-40B4-BE49-F238E27FC236}">
-                <a16:creationId xmlns:a16="http://schemas.microsoft.com/office/drawing/2014/main" id="{8D06BC99-1CEF-4619-B6E0-EBD2C4A8678A}"/>
+                <a16:creationId xmlns:a16="http://schemas.microsoft.com/office/drawing/2014/main" id="{3039C0F5-37E8-4C7B-BAD7-C23BC6E65880}"/>
               </a:ext>
             </a:extLst>
           </p:cNvPr>
@@ -22555,7 +22555,7 @@
           <p:cNvPr id="21" name="footer">
             <a:extLst xmlns:a="http://schemas.openxmlformats.org/drawingml/2006/main">
               <a:ext uri="{FF2B5EF4-FFF2-40B4-BE49-F238E27FC236}">
-                <a16:creationId xmlns:a16="http://schemas.microsoft.com/office/drawing/2014/main" id="{694C2726-2149-4DE8-8F4C-5C58BAB10364}"/>
+                <a16:creationId xmlns:a16="http://schemas.microsoft.com/office/drawing/2014/main" id="{A70CFF4E-4789-453E-8D12-5BC8CAE4B9CC}"/>
               </a:ext>
             </a:extLst>
           </p:cNvPr>
@@ -22680,7 +22680,7 @@
     </p:spTree>
     <p:extLst>
       <p:ext uri="{BB962C8B-B14F-4D97-AF65-F5344CB8AC3E}">
-        <p14:creationId xmlns:p14="http://schemas.microsoft.com/office/powerpoint/2010/main" val="1414707698"/>
+        <p14:creationId xmlns:p14="http://schemas.microsoft.com/office/powerpoint/2010/main" val="2017130181"/>
       </p:ext>
     </p:extLst>
   </p:cSld>

</xml_diff>

<commit_message>
Record verified semantic search and update W7 materials
</commit_message>
<xml_diff>
--- a/submissions/week07/W07_Team11.pptx
+++ b/submissions/week07/W07_Team11.pptx
@@ -2,24 +2,24 @@
 <file path=ppt/presentation.xml><?xml version="1.0" encoding="utf-8"?>
 <p:presentation xmlns:p="http://schemas.openxmlformats.org/presentationml/2006/main">
   <p:sldMasterIdLst>
-    <p:sldMasterId xmlns:r="http://schemas.openxmlformats.org/officeDocument/2006/relationships" id="2147483648" r:id="R7735f6b9bd6349c7"/>
+    <p:sldMasterId xmlns:r="http://schemas.openxmlformats.org/officeDocument/2006/relationships" id="2147483648" r:id="Rd0e5d01758594b40"/>
   </p:sldMasterIdLst>
   <p:notesMasterIdLst>
-    <p:notesMasterId xmlns:r="http://schemas.openxmlformats.org/officeDocument/2006/relationships" r:id="R29dd9400c6704fbf"/>
+    <p:notesMasterId xmlns:r="http://schemas.openxmlformats.org/officeDocument/2006/relationships" r:id="R315749873e9c457d"/>
   </p:notesMasterIdLst>
   <p:sldIdLst>
-    <p:sldId xmlns:r="http://schemas.openxmlformats.org/officeDocument/2006/relationships" id="256" r:id="R48c36623389b4882"/>
-    <p:sldId xmlns:r="http://schemas.openxmlformats.org/officeDocument/2006/relationships" id="257" r:id="R01a8d2d247fb45b9"/>
-    <p:sldId xmlns:r="http://schemas.openxmlformats.org/officeDocument/2006/relationships" id="258" r:id="Ra76e51e58d3a4221"/>
-    <p:sldId xmlns:r="http://schemas.openxmlformats.org/officeDocument/2006/relationships" id="259" r:id="Ra81dcd80fd5d494d"/>
-    <p:sldId xmlns:r="http://schemas.openxmlformats.org/officeDocument/2006/relationships" id="260" r:id="Rf8a2d6c6a611412a"/>
-    <p:sldId xmlns:r="http://schemas.openxmlformats.org/officeDocument/2006/relationships" id="261" r:id="Rbe1063bbaf6948a5"/>
-    <p:sldId xmlns:r="http://schemas.openxmlformats.org/officeDocument/2006/relationships" id="262" r:id="R950cc68787634392"/>
-    <p:sldId xmlns:r="http://schemas.openxmlformats.org/officeDocument/2006/relationships" id="263" r:id="Rdfb2b801c50e469b"/>
-    <p:sldId xmlns:r="http://schemas.openxmlformats.org/officeDocument/2006/relationships" id="264" r:id="R68c5367ff62d415c"/>
-    <p:sldId xmlns:r="http://schemas.openxmlformats.org/officeDocument/2006/relationships" id="265" r:id="R34bc98cd34814bd1"/>
-    <p:sldId xmlns:r="http://schemas.openxmlformats.org/officeDocument/2006/relationships" id="266" r:id="Ra894f52f15a14075"/>
-    <p:sldId xmlns:r="http://schemas.openxmlformats.org/officeDocument/2006/relationships" id="267" r:id="Rc076a1a7713a48ad"/>
+    <p:sldId xmlns:r="http://schemas.openxmlformats.org/officeDocument/2006/relationships" id="256" r:id="R496e24015c844c4f"/>
+    <p:sldId xmlns:r="http://schemas.openxmlformats.org/officeDocument/2006/relationships" id="257" r:id="Rb13bcaef33024bd7"/>
+    <p:sldId xmlns:r="http://schemas.openxmlformats.org/officeDocument/2006/relationships" id="258" r:id="R4714e210a3b44965"/>
+    <p:sldId xmlns:r="http://schemas.openxmlformats.org/officeDocument/2006/relationships" id="259" r:id="R5e73372f4f9e490b"/>
+    <p:sldId xmlns:r="http://schemas.openxmlformats.org/officeDocument/2006/relationships" id="260" r:id="Re6a88d110b154ee7"/>
+    <p:sldId xmlns:r="http://schemas.openxmlformats.org/officeDocument/2006/relationships" id="261" r:id="Rc1cf274e408841f6"/>
+    <p:sldId xmlns:r="http://schemas.openxmlformats.org/officeDocument/2006/relationships" id="262" r:id="Rb066f27e91ec4c99"/>
+    <p:sldId xmlns:r="http://schemas.openxmlformats.org/officeDocument/2006/relationships" id="263" r:id="R3c3c1914db004974"/>
+    <p:sldId xmlns:r="http://schemas.openxmlformats.org/officeDocument/2006/relationships" id="264" r:id="R6971e108d2554491"/>
+    <p:sldId xmlns:r="http://schemas.openxmlformats.org/officeDocument/2006/relationships" id="265" r:id="Rb695c7a66d044557"/>
+    <p:sldId xmlns:r="http://schemas.openxmlformats.org/officeDocument/2006/relationships" id="266" r:id="Rd3d4cc5380584152"/>
+    <p:sldId xmlns:r="http://schemas.openxmlformats.org/officeDocument/2006/relationships" id="267" r:id="R00d88e7fee11459d"/>
   </p:sldIdLst>
   <p:sldSz cx="12192000" cy="6858000"/>
   <p:notesSz cx="6858000" cy="9144000"/>
@@ -1153,7 +1153,7 @@
           <a:lstStyle xmlns:a="http://schemas.openxmlformats.org/drawingml/2006/main"/>
           <a:p xmlns:a="http://schemas.openxmlformats.org/drawingml/2006/main">
             <a:r>
-              <a:t>The mandatory M1 search gate is keyword. Five of five fixed queries returned the expected file and page. Semantic code exists, but the model bundle is absent, so the honest status is partial and the UI says so.</a:t>
+              <a:t>The keyword gate is 5/5. The pinned E5 model then embedded 20 chunks and the five frozen descriptions hit the expected file and page 5/5 in Top-3. The fallback remains explicit if the model or AI service is unavailable.</a:t>
             </a:r>
           </a:p>
         </p:txBody>
@@ -1270,7 +1270,7 @@
           <p:cNvPr id="3" name="Title">
             <a:extLst xmlns:a="http://schemas.openxmlformats.org/drawingml/2006/main">
               <a:ext uri="{FF2B5EF4-FFF2-40B4-BE49-F238E27FC236}">
-                <a16:creationId xmlns:a16="http://schemas.microsoft.com/office/drawing/2014/main" id="{509476F3-4C2D-4B45-BED5-631F316A7539}"/>
+                <a16:creationId xmlns:a16="http://schemas.microsoft.com/office/drawing/2014/main" id="{37672912-BDD5-413F-A9DB-BE49D66C46A9}"/>
               </a:ext>
             </a:extLst>
           </p:cNvPr>
@@ -1499,7 +1499,7 @@
           <p:cNvPr id="2" name="Subtitle">
             <a:extLst xmlns:a="http://schemas.openxmlformats.org/drawingml/2006/main">
               <a:ext uri="{FF2B5EF4-FFF2-40B4-BE49-F238E27FC236}">
-                <a16:creationId xmlns:a16="http://schemas.microsoft.com/office/drawing/2014/main" id="{09B2B6AF-2D78-4927-91DC-EAFFC110995A}"/>
+                <a16:creationId xmlns:a16="http://schemas.microsoft.com/office/drawing/2014/main" id="{33CD3907-BE3F-4D59-AEA4-94C07F3AF3C3}"/>
               </a:ext>
             </a:extLst>
           </p:cNvPr>
@@ -1745,7 +1745,7 @@
           <p:cNvPr id="2" name="Section title">
             <a:extLst xmlns:a="http://schemas.openxmlformats.org/drawingml/2006/main">
               <a:ext uri="{FF2B5EF4-FFF2-40B4-BE49-F238E27FC236}">
-                <a16:creationId xmlns:a16="http://schemas.microsoft.com/office/drawing/2014/main" id="{D74E381C-22A3-4311-89CF-90E9A342D1F1}"/>
+                <a16:creationId xmlns:a16="http://schemas.microsoft.com/office/drawing/2014/main" id="{C8D5FB40-8E9E-4575-8D3C-B1FF6BF83507}"/>
               </a:ext>
             </a:extLst>
           </p:cNvPr>
@@ -1991,7 +1991,7 @@
           <p:cNvPr id="3" name="Title">
             <a:extLst xmlns:a="http://schemas.openxmlformats.org/drawingml/2006/main">
               <a:ext uri="{FF2B5EF4-FFF2-40B4-BE49-F238E27FC236}">
-                <a16:creationId xmlns:a16="http://schemas.microsoft.com/office/drawing/2014/main" id="{ED3D5CAF-332D-4C84-96C9-1A948F74D99B}"/>
+                <a16:creationId xmlns:a16="http://schemas.microsoft.com/office/drawing/2014/main" id="{E0C55E91-B76D-48BE-842A-0AADB87D900C}"/>
               </a:ext>
             </a:extLst>
           </p:cNvPr>
@@ -2220,7 +2220,7 @@
           <p:cNvPr id="2" name="Body">
             <a:extLst xmlns:a="http://schemas.openxmlformats.org/drawingml/2006/main">
               <a:ext uri="{FF2B5EF4-FFF2-40B4-BE49-F238E27FC236}">
-                <a16:creationId xmlns:a16="http://schemas.microsoft.com/office/drawing/2014/main" id="{B01F02DB-3DCF-45B2-8F09-9B43A089E7DB}"/>
+                <a16:creationId xmlns:a16="http://schemas.microsoft.com/office/drawing/2014/main" id="{9BA8C5A3-EB0B-428F-ABC9-5EBDB9B9162A}"/>
               </a:ext>
             </a:extLst>
           </p:cNvPr>
@@ -2466,7 +2466,7 @@
           <p:cNvPr id="4" name="Title">
             <a:extLst xmlns:a="http://schemas.openxmlformats.org/drawingml/2006/main">
               <a:ext uri="{FF2B5EF4-FFF2-40B4-BE49-F238E27FC236}">
-                <a16:creationId xmlns:a16="http://schemas.microsoft.com/office/drawing/2014/main" id="{D30EE4DD-C74F-47ED-9863-22F2E9DE84A4}"/>
+                <a16:creationId xmlns:a16="http://schemas.microsoft.com/office/drawing/2014/main" id="{CAC8F82D-C8BA-48D3-8098-B1FB30C4BDC3}"/>
               </a:ext>
             </a:extLst>
           </p:cNvPr>
@@ -2695,7 +2695,7 @@
           <p:cNvPr id="2" name="Left column">
             <a:extLst xmlns:a="http://schemas.openxmlformats.org/drawingml/2006/main">
               <a:ext uri="{FF2B5EF4-FFF2-40B4-BE49-F238E27FC236}">
-                <a16:creationId xmlns:a16="http://schemas.microsoft.com/office/drawing/2014/main" id="{5C280892-B90E-4EC2-8C72-C2EAA105C263}"/>
+                <a16:creationId xmlns:a16="http://schemas.microsoft.com/office/drawing/2014/main" id="{5C92876F-7A1B-499D-A451-6C10670D79C9}"/>
               </a:ext>
             </a:extLst>
           </p:cNvPr>
@@ -2924,7 +2924,7 @@
           <p:cNvPr id="3" name="Right column">
             <a:extLst xmlns:a="http://schemas.openxmlformats.org/drawingml/2006/main">
               <a:ext uri="{FF2B5EF4-FFF2-40B4-BE49-F238E27FC236}">
-                <a16:creationId xmlns:a16="http://schemas.microsoft.com/office/drawing/2014/main" id="{08AE3046-1378-4EA8-908E-EE44A4CD5981}"/>
+                <a16:creationId xmlns:a16="http://schemas.microsoft.com/office/drawing/2014/main" id="{94DE41EA-5380-4777-9F8D-413605D3C76A}"/>
               </a:ext>
             </a:extLst>
           </p:cNvPr>
@@ -3170,7 +3170,7 @@
           <p:cNvPr id="3" name="Title">
             <a:extLst xmlns:a="http://schemas.openxmlformats.org/drawingml/2006/main">
               <a:ext uri="{FF2B5EF4-FFF2-40B4-BE49-F238E27FC236}">
-                <a16:creationId xmlns:a16="http://schemas.microsoft.com/office/drawing/2014/main" id="{4B913D04-E393-4F30-B85C-E50F3672CFFB}"/>
+                <a16:creationId xmlns:a16="http://schemas.microsoft.com/office/drawing/2014/main" id="{4ACC2F8B-A619-4E5B-A75B-F5DCFC40C93C}"/>
               </a:ext>
             </a:extLst>
           </p:cNvPr>
@@ -3399,7 +3399,7 @@
           <p:cNvPr id="2" name="Left column">
             <a:extLst xmlns:a="http://schemas.openxmlformats.org/drawingml/2006/main">
               <a:ext uri="{FF2B5EF4-FFF2-40B4-BE49-F238E27FC236}">
-                <a16:creationId xmlns:a16="http://schemas.microsoft.com/office/drawing/2014/main" id="{6353FB56-B603-4AF4-ADBC-56C01BF3B82E}"/>
+                <a16:creationId xmlns:a16="http://schemas.microsoft.com/office/drawing/2014/main" id="{6171B585-FB33-49C9-A8AC-3FCECED1EF2D}"/>
               </a:ext>
             </a:extLst>
           </p:cNvPr>
@@ -3666,12 +3666,12 @@
   </p:cSld>
   <p:clrMap bg1="lt1" tx1="dk1" bg2="lt2" tx2="dk2" accent1="accent1" accent2="accent2" accent3="accent3" accent4="accent4" accent5="accent5" accent6="accent6" hlink="hlink" folHlink="folHlink"/>
   <p:sldLayoutIdLst>
-    <p:sldLayoutId xmlns:r="http://schemas.openxmlformats.org/officeDocument/2006/relationships" id="2147483649" r:id="R45afabc2059f4eb6"/>
-    <p:sldLayoutId xmlns:r="http://schemas.openxmlformats.org/officeDocument/2006/relationships" id="2147483650" r:id="R7ef7aeeb055a472d"/>
-    <p:sldLayoutId xmlns:r="http://schemas.openxmlformats.org/officeDocument/2006/relationships" id="2147483651" r:id="R524047b7bb3a48ef"/>
-    <p:sldLayoutId xmlns:r="http://schemas.openxmlformats.org/officeDocument/2006/relationships" id="2147483652" r:id="Rd6cd31216d574590"/>
-    <p:sldLayoutId xmlns:r="http://schemas.openxmlformats.org/officeDocument/2006/relationships" id="2147483653" r:id="Rff70977b545c40e7"/>
-    <p:sldLayoutId xmlns:r="http://schemas.openxmlformats.org/officeDocument/2006/relationships" id="2147483654" r:id="Rc501fd1bd6b64e66"/>
+    <p:sldLayoutId xmlns:r="http://schemas.openxmlformats.org/officeDocument/2006/relationships" id="2147483649" r:id="Rca637e9da308419b"/>
+    <p:sldLayoutId xmlns:r="http://schemas.openxmlformats.org/officeDocument/2006/relationships" id="2147483650" r:id="Re74449c98bda4215"/>
+    <p:sldLayoutId xmlns:r="http://schemas.openxmlformats.org/officeDocument/2006/relationships" id="2147483651" r:id="R932a04e335504809"/>
+    <p:sldLayoutId xmlns:r="http://schemas.openxmlformats.org/officeDocument/2006/relationships" id="2147483652" r:id="R495ca53d40d64269"/>
+    <p:sldLayoutId xmlns:r="http://schemas.openxmlformats.org/officeDocument/2006/relationships" id="2147483653" r:id="R03a0dc01aa7c4b0d"/>
+    <p:sldLayoutId xmlns:r="http://schemas.openxmlformats.org/officeDocument/2006/relationships" id="2147483654" r:id="R6487d02db1f34091"/>
   </p:sldLayoutIdLst>
   <p:txStyles>
     <p:titleStyle>
@@ -4222,7 +4222,7 @@
           <p:cNvPr id="6" name="cover-label">
             <a:extLst xmlns:a="http://schemas.openxmlformats.org/drawingml/2006/main">
               <a:ext uri="{FF2B5EF4-FFF2-40B4-BE49-F238E27FC236}">
-                <a16:creationId xmlns:a16="http://schemas.microsoft.com/office/drawing/2014/main" id="{4E5839E1-55E2-41BF-8923-49963614EA65}"/>
+                <a16:creationId xmlns:a16="http://schemas.microsoft.com/office/drawing/2014/main" id="{8D5E7E9B-5409-4C92-99A9-F7D68C86E243}"/>
               </a:ext>
             </a:extLst>
           </p:cNvPr>
@@ -4349,7 +4349,7 @@
           <p:cNvPr id="2" name="cover-title">
             <a:extLst xmlns:a="http://schemas.openxmlformats.org/drawingml/2006/main">
               <a:ext uri="{FF2B5EF4-FFF2-40B4-BE49-F238E27FC236}">
-                <a16:creationId xmlns:a16="http://schemas.microsoft.com/office/drawing/2014/main" id="{DB6B3C56-BF74-49C4-BB38-B6D2D9FA4F4E}"/>
+                <a16:creationId xmlns:a16="http://schemas.microsoft.com/office/drawing/2014/main" id="{35F03039-CAD2-41EE-8E93-7C2F80002B06}"/>
               </a:ext>
             </a:extLst>
           </p:cNvPr>
@@ -4476,7 +4476,7 @@
           <p:cNvPr id="3" name="cover-subtitle">
             <a:extLst xmlns:a="http://schemas.openxmlformats.org/drawingml/2006/main">
               <a:ext uri="{FF2B5EF4-FFF2-40B4-BE49-F238E27FC236}">
-                <a16:creationId xmlns:a16="http://schemas.microsoft.com/office/drawing/2014/main" id="{8D971F10-C964-4FAA-97A9-D7EE9E2E1D19}"/>
+                <a16:creationId xmlns:a16="http://schemas.microsoft.com/office/drawing/2014/main" id="{DE598E2E-00BE-4544-8352-CBCE9F64D5C1}"/>
               </a:ext>
             </a:extLst>
           </p:cNvPr>
@@ -4603,7 +4603,7 @@
           <p:cNvPr id="4" name="cover-rule">
             <a:extLst xmlns:a="http://schemas.openxmlformats.org/drawingml/2006/main">
               <a:ext uri="{FF2B5EF4-FFF2-40B4-BE49-F238E27FC236}">
-                <a16:creationId xmlns:a16="http://schemas.microsoft.com/office/drawing/2014/main" id="{D8EED17F-63D8-40F3-81FE-70CD886DD4FA}"/>
+                <a16:creationId xmlns:a16="http://schemas.microsoft.com/office/drawing/2014/main" id="{ABCAD92F-6436-4806-BE22-EDB21C1E5F78}"/>
               </a:ext>
             </a:extLst>
           </p:cNvPr>
@@ -4634,7 +4634,7 @@
           <p:cNvPr id="5" name="cover-meta">
             <a:extLst xmlns:a="http://schemas.openxmlformats.org/drawingml/2006/main">
               <a:ext uri="{FF2B5EF4-FFF2-40B4-BE49-F238E27FC236}">
-                <a16:creationId xmlns:a16="http://schemas.microsoft.com/office/drawing/2014/main" id="{AFD819B7-ED0D-4182-9251-397CF0DA4795}"/>
+                <a16:creationId xmlns:a16="http://schemas.microsoft.com/office/drawing/2014/main" id="{233C5F76-084F-4355-B2C3-A7B4EEF5AC01}"/>
               </a:ext>
             </a:extLst>
           </p:cNvPr>
@@ -4759,7 +4759,7 @@
     </p:spTree>
     <p:extLst>
       <p:ext uri="{BB962C8B-B14F-4D97-AF65-F5344CB8AC3E}">
-        <p14:creationId xmlns:p14="http://schemas.microsoft.com/office/powerpoint/2010/main" val="641339905"/>
+        <p14:creationId xmlns:p14="http://schemas.microsoft.com/office/powerpoint/2010/main" val="938987393"/>
       </p:ext>
     </p:extLst>
   </p:cSld>
@@ -4790,7 +4790,7 @@
           <p:cNvPr id="19" name="eyebrow">
             <a:extLst xmlns:a="http://schemas.openxmlformats.org/drawingml/2006/main">
               <a:ext uri="{FF2B5EF4-FFF2-40B4-BE49-F238E27FC236}">
-                <a16:creationId xmlns:a16="http://schemas.microsoft.com/office/drawing/2014/main" id="{6ED28E49-3CE8-41B7-A732-511B2EC87C28}"/>
+                <a16:creationId xmlns:a16="http://schemas.microsoft.com/office/drawing/2014/main" id="{AB7AAFFC-C571-4B29-9DDB-B36F27B35E66}"/>
               </a:ext>
             </a:extLst>
           </p:cNvPr>
@@ -4917,7 +4917,7 @@
           <p:cNvPr id="2" name="page">
             <a:extLst xmlns:a="http://schemas.openxmlformats.org/drawingml/2006/main">
               <a:ext uri="{FF2B5EF4-FFF2-40B4-BE49-F238E27FC236}">
-                <a16:creationId xmlns:a16="http://schemas.microsoft.com/office/drawing/2014/main" id="{9FD204E9-8045-4960-A8EC-7A8C7CFF3DAA}"/>
+                <a16:creationId xmlns:a16="http://schemas.microsoft.com/office/drawing/2014/main" id="{AD02D99C-511D-4FE2-8752-3F8B6830C6A6}"/>
               </a:ext>
             </a:extLst>
           </p:cNvPr>
@@ -5044,7 +5044,7 @@
           <p:cNvPr id="3" name="acceptance-rule">
             <a:extLst xmlns:a="http://schemas.openxmlformats.org/drawingml/2006/main">
               <a:ext uri="{FF2B5EF4-FFF2-40B4-BE49-F238E27FC236}">
-                <a16:creationId xmlns:a16="http://schemas.microsoft.com/office/drawing/2014/main" id="{254DDC3E-8A2B-4088-B062-32BB181222CB}"/>
+                <a16:creationId xmlns:a16="http://schemas.microsoft.com/office/drawing/2014/main" id="{045686B1-051B-4B3F-BBC7-D10C07833EE7}"/>
               </a:ext>
             </a:extLst>
           </p:cNvPr>
@@ -5075,7 +5075,7 @@
           <p:cNvPr id="4" name="title">
             <a:extLst xmlns:a="http://schemas.openxmlformats.org/drawingml/2006/main">
               <a:ext uri="{FF2B5EF4-FFF2-40B4-BE49-F238E27FC236}">
-                <a16:creationId xmlns:a16="http://schemas.microsoft.com/office/drawing/2014/main" id="{A3DBE1E2-360A-4081-BE43-FE165485989A}"/>
+                <a16:creationId xmlns:a16="http://schemas.microsoft.com/office/drawing/2014/main" id="{84CE02AE-044D-41DE-976C-E678F6E144BB}"/>
               </a:ext>
             </a:extLst>
           </p:cNvPr>
@@ -5202,7 +5202,7 @@
           <p:cNvPr id="5" name="evidence-rule-0">
             <a:extLst xmlns:a="http://schemas.openxmlformats.org/drawingml/2006/main">
               <a:ext uri="{FF2B5EF4-FFF2-40B4-BE49-F238E27FC236}">
-                <a16:creationId xmlns:a16="http://schemas.microsoft.com/office/drawing/2014/main" id="{70746BE1-BE64-4994-BE6A-89F8F2DC7BD3}"/>
+                <a16:creationId xmlns:a16="http://schemas.microsoft.com/office/drawing/2014/main" id="{BB82F838-EAA8-40A5-A601-95655846ED8B}"/>
               </a:ext>
             </a:extLst>
           </p:cNvPr>
@@ -5233,7 +5233,7 @@
           <p:cNvPr id="6" name="evidence-number-0">
             <a:extLst xmlns:a="http://schemas.openxmlformats.org/drawingml/2006/main">
               <a:ext uri="{FF2B5EF4-FFF2-40B4-BE49-F238E27FC236}">
-                <a16:creationId xmlns:a16="http://schemas.microsoft.com/office/drawing/2014/main" id="{EAF6F036-DC04-4AE6-9F35-549809930994}"/>
+                <a16:creationId xmlns:a16="http://schemas.microsoft.com/office/drawing/2014/main" id="{296CFE86-045D-47CB-9334-01C3DA8AC90D}"/>
               </a:ext>
             </a:extLst>
           </p:cNvPr>
@@ -5360,7 +5360,7 @@
           <p:cNvPr id="7" name="evidence-label-0">
             <a:extLst xmlns:a="http://schemas.openxmlformats.org/drawingml/2006/main">
               <a:ext uri="{FF2B5EF4-FFF2-40B4-BE49-F238E27FC236}">
-                <a16:creationId xmlns:a16="http://schemas.microsoft.com/office/drawing/2014/main" id="{0DBBCFA2-D39F-4BDD-B775-833D3D941CB4}"/>
+                <a16:creationId xmlns:a16="http://schemas.microsoft.com/office/drawing/2014/main" id="{28C203D5-4A1D-4522-8220-2469070EF845}"/>
               </a:ext>
             </a:extLst>
           </p:cNvPr>
@@ -5487,7 +5487,7 @@
           <p:cNvPr id="8" name="evidence-rule-1">
             <a:extLst xmlns:a="http://schemas.openxmlformats.org/drawingml/2006/main">
               <a:ext uri="{FF2B5EF4-FFF2-40B4-BE49-F238E27FC236}">
-                <a16:creationId xmlns:a16="http://schemas.microsoft.com/office/drawing/2014/main" id="{3C4D899F-5400-4C38-B48E-6597E6C32041}"/>
+                <a16:creationId xmlns:a16="http://schemas.microsoft.com/office/drawing/2014/main" id="{E593B079-A0D7-472C-B210-9F4508243ABD}"/>
               </a:ext>
             </a:extLst>
           </p:cNvPr>
@@ -5518,7 +5518,7 @@
           <p:cNvPr id="9" name="evidence-number-1">
             <a:extLst xmlns:a="http://schemas.openxmlformats.org/drawingml/2006/main">
               <a:ext uri="{FF2B5EF4-FFF2-40B4-BE49-F238E27FC236}">
-                <a16:creationId xmlns:a16="http://schemas.microsoft.com/office/drawing/2014/main" id="{BAB99003-5B80-4668-BFF3-F85DD69C6D1B}"/>
+                <a16:creationId xmlns:a16="http://schemas.microsoft.com/office/drawing/2014/main" id="{5BA0A9E1-4428-4319-BEFE-DF0A6436B61E}"/>
               </a:ext>
             </a:extLst>
           </p:cNvPr>
@@ -5645,7 +5645,7 @@
           <p:cNvPr id="10" name="evidence-label-1">
             <a:extLst xmlns:a="http://schemas.openxmlformats.org/drawingml/2006/main">
               <a:ext uri="{FF2B5EF4-FFF2-40B4-BE49-F238E27FC236}">
-                <a16:creationId xmlns:a16="http://schemas.microsoft.com/office/drawing/2014/main" id="{44C33BC7-96ED-4C12-B8BA-1E46DFBE56A1}"/>
+                <a16:creationId xmlns:a16="http://schemas.microsoft.com/office/drawing/2014/main" id="{7A211D7E-7DD9-4272-81AE-496B622D4848}"/>
               </a:ext>
             </a:extLst>
           </p:cNvPr>
@@ -5772,7 +5772,7 @@
           <p:cNvPr id="11" name="evidence-rule-2">
             <a:extLst xmlns:a="http://schemas.openxmlformats.org/drawingml/2006/main">
               <a:ext uri="{FF2B5EF4-FFF2-40B4-BE49-F238E27FC236}">
-                <a16:creationId xmlns:a16="http://schemas.microsoft.com/office/drawing/2014/main" id="{63D28E90-922B-4A14-8CF6-B09D532EC9D1}"/>
+                <a16:creationId xmlns:a16="http://schemas.microsoft.com/office/drawing/2014/main" id="{EF27A16F-7208-4A90-AD24-70217DC61EC9}"/>
               </a:ext>
             </a:extLst>
           </p:cNvPr>
@@ -5803,7 +5803,7 @@
           <p:cNvPr id="12" name="evidence-number-2">
             <a:extLst xmlns:a="http://schemas.openxmlformats.org/drawingml/2006/main">
               <a:ext uri="{FF2B5EF4-FFF2-40B4-BE49-F238E27FC236}">
-                <a16:creationId xmlns:a16="http://schemas.microsoft.com/office/drawing/2014/main" id="{5126AD16-EF24-4F46-A166-F11EB69BFB5D}"/>
+                <a16:creationId xmlns:a16="http://schemas.microsoft.com/office/drawing/2014/main" id="{2E3ABF17-39D4-4D1F-9554-8D751C861171}"/>
               </a:ext>
             </a:extLst>
           </p:cNvPr>
@@ -5930,7 +5930,7 @@
           <p:cNvPr id="13" name="evidence-label-2">
             <a:extLst xmlns:a="http://schemas.openxmlformats.org/drawingml/2006/main">
               <a:ext uri="{FF2B5EF4-FFF2-40B4-BE49-F238E27FC236}">
-                <a16:creationId xmlns:a16="http://schemas.microsoft.com/office/drawing/2014/main" id="{918910AA-097F-4FC1-9B6F-A13E586F72B0}"/>
+                <a16:creationId xmlns:a16="http://schemas.microsoft.com/office/drawing/2014/main" id="{CFB059FB-C535-4ED5-BCCC-0D94E032374D}"/>
               </a:ext>
             </a:extLst>
           </p:cNvPr>
@@ -6057,7 +6057,7 @@
           <p:cNvPr id="14" name="evidence-rule-3">
             <a:extLst xmlns:a="http://schemas.openxmlformats.org/drawingml/2006/main">
               <a:ext uri="{FF2B5EF4-FFF2-40B4-BE49-F238E27FC236}">
-                <a16:creationId xmlns:a16="http://schemas.microsoft.com/office/drawing/2014/main" id="{3ABBE12E-881F-4993-9666-799EAACD9927}"/>
+                <a16:creationId xmlns:a16="http://schemas.microsoft.com/office/drawing/2014/main" id="{C9D29CE5-2802-480E-9907-D0D0F3B02E3F}"/>
               </a:ext>
             </a:extLst>
           </p:cNvPr>
@@ -6088,7 +6088,7 @@
           <p:cNvPr id="15" name="evidence-number-3">
             <a:extLst xmlns:a="http://schemas.openxmlformats.org/drawingml/2006/main">
               <a:ext uri="{FF2B5EF4-FFF2-40B4-BE49-F238E27FC236}">
-                <a16:creationId xmlns:a16="http://schemas.microsoft.com/office/drawing/2014/main" id="{6CBAB85C-FDD0-4450-9C25-2EDC794F6F15}"/>
+                <a16:creationId xmlns:a16="http://schemas.microsoft.com/office/drawing/2014/main" id="{7B3C4286-0CC6-4718-9BE6-B9ABB2496412}"/>
               </a:ext>
             </a:extLst>
           </p:cNvPr>
@@ -6215,7 +6215,7 @@
           <p:cNvPr id="16" name="evidence-label-3">
             <a:extLst xmlns:a="http://schemas.openxmlformats.org/drawingml/2006/main">
               <a:ext uri="{FF2B5EF4-FFF2-40B4-BE49-F238E27FC236}">
-                <a16:creationId xmlns:a16="http://schemas.microsoft.com/office/drawing/2014/main" id="{C7FF3A80-E246-4670-9BAF-8668F636C2B0}"/>
+                <a16:creationId xmlns:a16="http://schemas.microsoft.com/office/drawing/2014/main" id="{7525F6F2-614E-4EBB-8D3A-611CED5ED2BB}"/>
               </a:ext>
             </a:extLst>
           </p:cNvPr>
@@ -6342,7 +6342,7 @@
           <p:cNvPr id="17" name="acceptance-passage">
             <a:extLst xmlns:a="http://schemas.openxmlformats.org/drawingml/2006/main">
               <a:ext uri="{FF2B5EF4-FFF2-40B4-BE49-F238E27FC236}">
-                <a16:creationId xmlns:a16="http://schemas.microsoft.com/office/drawing/2014/main" id="{26EB9C61-B112-40BD-8AE0-CC83D9A1AAED}"/>
+                <a16:creationId xmlns:a16="http://schemas.microsoft.com/office/drawing/2014/main" id="{7F559C22-5CE8-4D69-95D6-697DB19EF94C}"/>
               </a:ext>
             </a:extLst>
           </p:cNvPr>
@@ -6469,7 +6469,7 @@
           <p:cNvPr id="18" name="footer">
             <a:extLst xmlns:a="http://schemas.openxmlformats.org/drawingml/2006/main">
               <a:ext uri="{FF2B5EF4-FFF2-40B4-BE49-F238E27FC236}">
-                <a16:creationId xmlns:a16="http://schemas.microsoft.com/office/drawing/2014/main" id="{B8D4409A-E39A-42E9-B149-EAD831DA0451}"/>
+                <a16:creationId xmlns:a16="http://schemas.microsoft.com/office/drawing/2014/main" id="{F9AC02E6-7C9C-4791-A14D-112BC292C71B}"/>
               </a:ext>
             </a:extLst>
           </p:cNvPr>
@@ -6594,7 +6594,7 @@
     </p:spTree>
     <p:extLst>
       <p:ext uri="{BB962C8B-B14F-4D97-AF65-F5344CB8AC3E}">
-        <p14:creationId xmlns:p14="http://schemas.microsoft.com/office/powerpoint/2010/main" val="105476693"/>
+        <p14:creationId xmlns:p14="http://schemas.microsoft.com/office/powerpoint/2010/main" val="65631793"/>
       </p:ext>
     </p:extLst>
   </p:cSld>
@@ -6625,7 +6625,7 @@
           <p:cNvPr id="15" name="eyebrow">
             <a:extLst xmlns:a="http://schemas.openxmlformats.org/drawingml/2006/main">
               <a:ext uri="{FF2B5EF4-FFF2-40B4-BE49-F238E27FC236}">
-                <a16:creationId xmlns:a16="http://schemas.microsoft.com/office/drawing/2014/main" id="{23CF0889-C7AB-451A-B3A0-9E32F4C8DA33}"/>
+                <a16:creationId xmlns:a16="http://schemas.microsoft.com/office/drawing/2014/main" id="{3C1D7683-8D94-48AA-B523-31DC604A2AFF}"/>
               </a:ext>
             </a:extLst>
           </p:cNvPr>
@@ -6752,7 +6752,7 @@
           <p:cNvPr id="2" name="page">
             <a:extLst xmlns:a="http://schemas.openxmlformats.org/drawingml/2006/main">
               <a:ext uri="{FF2B5EF4-FFF2-40B4-BE49-F238E27FC236}">
-                <a16:creationId xmlns:a16="http://schemas.microsoft.com/office/drawing/2014/main" id="{D8F579B7-C763-4A9E-9AB9-2F072659B29B}"/>
+                <a16:creationId xmlns:a16="http://schemas.microsoft.com/office/drawing/2014/main" id="{5DD6BB22-843B-452A-9CE5-9E68CABDA95A}"/>
               </a:ext>
             </a:extLst>
           </p:cNvPr>
@@ -6879,7 +6879,7 @@
           <p:cNvPr id="3" name="limits-rule">
             <a:extLst xmlns:a="http://schemas.openxmlformats.org/drawingml/2006/main">
               <a:ext uri="{FF2B5EF4-FFF2-40B4-BE49-F238E27FC236}">
-                <a16:creationId xmlns:a16="http://schemas.microsoft.com/office/drawing/2014/main" id="{B4E9AF85-31C8-401F-8285-D8F3799186E3}"/>
+                <a16:creationId xmlns:a16="http://schemas.microsoft.com/office/drawing/2014/main" id="{ED224CEE-3EBC-4167-A109-9033F779EB0F}"/>
               </a:ext>
             </a:extLst>
           </p:cNvPr>
@@ -6910,7 +6910,7 @@
           <p:cNvPr id="4" name="title">
             <a:extLst xmlns:a="http://schemas.openxmlformats.org/drawingml/2006/main">
               <a:ext uri="{FF2B5EF4-FFF2-40B4-BE49-F238E27FC236}">
-                <a16:creationId xmlns:a16="http://schemas.microsoft.com/office/drawing/2014/main" id="{AF91B098-E850-44E7-970C-CEBB484C91FB}"/>
+                <a16:creationId xmlns:a16="http://schemas.microsoft.com/office/drawing/2014/main" id="{E6DC8E6B-3B78-4B2B-BBB6-A1F4840296ED}"/>
               </a:ext>
             </a:extLst>
           </p:cNvPr>
@@ -7037,7 +7037,7 @@
           <p:cNvPr id="5" name="limit-rule-0">
             <a:extLst xmlns:a="http://schemas.openxmlformats.org/drawingml/2006/main">
               <a:ext uri="{FF2B5EF4-FFF2-40B4-BE49-F238E27FC236}">
-                <a16:creationId xmlns:a16="http://schemas.microsoft.com/office/drawing/2014/main" id="{D738174E-2D19-4CBF-9192-8DB7CB5FFF6D}"/>
+                <a16:creationId xmlns:a16="http://schemas.microsoft.com/office/drawing/2014/main" id="{B55D57F7-FFE2-4607-9454-6AFE33E25AA4}"/>
               </a:ext>
             </a:extLst>
           </p:cNvPr>
@@ -7068,7 +7068,7 @@
           <p:cNvPr id="6" name="limit-title-0">
             <a:extLst xmlns:a="http://schemas.openxmlformats.org/drawingml/2006/main">
               <a:ext uri="{FF2B5EF4-FFF2-40B4-BE49-F238E27FC236}">
-                <a16:creationId xmlns:a16="http://schemas.microsoft.com/office/drawing/2014/main" id="{4C32AFE3-F08F-47CD-A2D9-F32A9878BA80}"/>
+                <a16:creationId xmlns:a16="http://schemas.microsoft.com/office/drawing/2014/main" id="{6FE65440-0C19-406B-AC33-ABC3E9B98CD9}"/>
               </a:ext>
             </a:extLst>
           </p:cNvPr>
@@ -7195,7 +7195,7 @@
           <p:cNvPr id="7" name="limit-body-0">
             <a:extLst xmlns:a="http://schemas.openxmlformats.org/drawingml/2006/main">
               <a:ext uri="{FF2B5EF4-FFF2-40B4-BE49-F238E27FC236}">
-                <a16:creationId xmlns:a16="http://schemas.microsoft.com/office/drawing/2014/main" id="{E37A48A8-CF3A-46A3-95FD-FE01AF513A00}"/>
+                <a16:creationId xmlns:a16="http://schemas.microsoft.com/office/drawing/2014/main" id="{EF671EBC-C866-4B93-8A19-C9EDE315005E}"/>
               </a:ext>
             </a:extLst>
           </p:cNvPr>
@@ -7312,7 +7312,7 @@
                   <a:srgbClr val="7B3306"/>
                 </a:solidFill>
               </a:rPr>
-              <a:t>No local E5 model in this checkout. Keyword-only degradation is the honest state.</a:t>
+              <a:t>Pinned E5 model prepared. Twenty chunks embedded and S01-S05 hit 5/5 with matching evidence.</a:t>
             </a:r>
           </a:p>
         </p:txBody>
@@ -7322,7 +7322,7 @@
           <p:cNvPr id="8" name="limit-rule-1">
             <a:extLst xmlns:a="http://schemas.openxmlformats.org/drawingml/2006/main">
               <a:ext uri="{FF2B5EF4-FFF2-40B4-BE49-F238E27FC236}">
-                <a16:creationId xmlns:a16="http://schemas.microsoft.com/office/drawing/2014/main" id="{C3B809C2-D055-420A-A108-5C733059DF39}"/>
+                <a16:creationId xmlns:a16="http://schemas.microsoft.com/office/drawing/2014/main" id="{9E0CC321-E8CA-4ADB-B1A0-63E78CC0C1CA}"/>
               </a:ext>
             </a:extLst>
           </p:cNvPr>
@@ -7353,7 +7353,7 @@
           <p:cNvPr id="9" name="limit-title-1">
             <a:extLst xmlns:a="http://schemas.openxmlformats.org/drawingml/2006/main">
               <a:ext uri="{FF2B5EF4-FFF2-40B4-BE49-F238E27FC236}">
-                <a16:creationId xmlns:a16="http://schemas.microsoft.com/office/drawing/2014/main" id="{2A38318D-5FD4-4DCC-8A5F-D4182DF9D65A}"/>
+                <a16:creationId xmlns:a16="http://schemas.microsoft.com/office/drawing/2014/main" id="{832B2DBA-8334-4E88-8FAB-6A840AFEAFD5}"/>
               </a:ext>
             </a:extLst>
           </p:cNvPr>
@@ -7480,7 +7480,7 @@
           <p:cNvPr id="10" name="limit-body-1">
             <a:extLst xmlns:a="http://schemas.openxmlformats.org/drawingml/2006/main">
               <a:ext uri="{FF2B5EF4-FFF2-40B4-BE49-F238E27FC236}">
-                <a16:creationId xmlns:a16="http://schemas.microsoft.com/office/drawing/2014/main" id="{4872D6CB-9859-4583-86D7-0728FA771DD1}"/>
+                <a16:creationId xmlns:a16="http://schemas.microsoft.com/office/drawing/2014/main" id="{B9D2DA5B-2666-4CF4-93D8-A75E22FD21F8}"/>
               </a:ext>
             </a:extLst>
           </p:cNvPr>
@@ -7607,7 +7607,7 @@
           <p:cNvPr id="11" name="limit-rule-2">
             <a:extLst xmlns:a="http://schemas.openxmlformats.org/drawingml/2006/main">
               <a:ext uri="{FF2B5EF4-FFF2-40B4-BE49-F238E27FC236}">
-                <a16:creationId xmlns:a16="http://schemas.microsoft.com/office/drawing/2014/main" id="{8AE9C157-885C-470F-8B8D-0163C4EA6CD1}"/>
+                <a16:creationId xmlns:a16="http://schemas.microsoft.com/office/drawing/2014/main" id="{BFCFDEA4-F719-46D1-AF0B-6657168A7BDC}"/>
               </a:ext>
             </a:extLst>
           </p:cNvPr>
@@ -7638,7 +7638,7 @@
           <p:cNvPr id="12" name="limit-title-2">
             <a:extLst xmlns:a="http://schemas.openxmlformats.org/drawingml/2006/main">
               <a:ext uri="{FF2B5EF4-FFF2-40B4-BE49-F238E27FC236}">
-                <a16:creationId xmlns:a16="http://schemas.microsoft.com/office/drawing/2014/main" id="{A630EC89-EB61-4A98-904B-347651CCD7C4}"/>
+                <a16:creationId xmlns:a16="http://schemas.microsoft.com/office/drawing/2014/main" id="{947BBBD6-D3B5-4AC9-9277-AD6807B60DE7}"/>
               </a:ext>
             </a:extLst>
           </p:cNvPr>
@@ -7765,7 +7765,7 @@
           <p:cNvPr id="13" name="limit-body-2">
             <a:extLst xmlns:a="http://schemas.openxmlformats.org/drawingml/2006/main">
               <a:ext uri="{FF2B5EF4-FFF2-40B4-BE49-F238E27FC236}">
-                <a16:creationId xmlns:a16="http://schemas.microsoft.com/office/drawing/2014/main" id="{4DEB1404-0341-4A95-AF45-5C2242569743}"/>
+                <a16:creationId xmlns:a16="http://schemas.microsoft.com/office/drawing/2014/main" id="{6EF93919-AA9A-47EB-899E-94BCD525E55A}"/>
               </a:ext>
             </a:extLst>
           </p:cNvPr>
@@ -7892,7 +7892,7 @@
           <p:cNvPr id="14" name="footer">
             <a:extLst xmlns:a="http://schemas.openxmlformats.org/drawingml/2006/main">
               <a:ext uri="{FF2B5EF4-FFF2-40B4-BE49-F238E27FC236}">
-                <a16:creationId xmlns:a16="http://schemas.microsoft.com/office/drawing/2014/main" id="{0A45F6CA-2187-4D36-B2D0-4F3D483141E0}"/>
+                <a16:creationId xmlns:a16="http://schemas.microsoft.com/office/drawing/2014/main" id="{213A78DF-2FF6-4FB4-8764-DD455A0870AD}"/>
               </a:ext>
             </a:extLst>
           </p:cNvPr>
@@ -8017,7 +8017,7 @@
     </p:spTree>
     <p:extLst>
       <p:ext uri="{BB962C8B-B14F-4D97-AF65-F5344CB8AC3E}">
-        <p14:creationId xmlns:p14="http://schemas.microsoft.com/office/powerpoint/2010/main" val="211903717"/>
+        <p14:creationId xmlns:p14="http://schemas.microsoft.com/office/powerpoint/2010/main" val="1598176017"/>
       </p:ext>
     </p:extLst>
   </p:cSld>
@@ -8048,7 +8048,7 @@
           <p:cNvPr id="6" name="close-label">
             <a:extLst xmlns:a="http://schemas.openxmlformats.org/drawingml/2006/main">
               <a:ext uri="{FF2B5EF4-FFF2-40B4-BE49-F238E27FC236}">
-                <a16:creationId xmlns:a16="http://schemas.microsoft.com/office/drawing/2014/main" id="{523E4A21-465D-4E4F-B4D2-63DD8BABDBB0}"/>
+                <a16:creationId xmlns:a16="http://schemas.microsoft.com/office/drawing/2014/main" id="{153103FF-3381-43D5-A5CB-5D4586CB0FE1}"/>
               </a:ext>
             </a:extLst>
           </p:cNvPr>
@@ -8175,7 +8175,7 @@
           <p:cNvPr id="2" name="close-title">
             <a:extLst xmlns:a="http://schemas.openxmlformats.org/drawingml/2006/main">
               <a:ext uri="{FF2B5EF4-FFF2-40B4-BE49-F238E27FC236}">
-                <a16:creationId xmlns:a16="http://schemas.microsoft.com/office/drawing/2014/main" id="{7AA02480-D6DF-4103-84EF-3683862FA4AF}"/>
+                <a16:creationId xmlns:a16="http://schemas.microsoft.com/office/drawing/2014/main" id="{97225FF9-8251-4FFE-AD39-B5043652063C}"/>
               </a:ext>
             </a:extLst>
           </p:cNvPr>
@@ -8302,7 +8302,7 @@
           <p:cNvPr id="3" name="close-body">
             <a:extLst xmlns:a="http://schemas.openxmlformats.org/drawingml/2006/main">
               <a:ext uri="{FF2B5EF4-FFF2-40B4-BE49-F238E27FC236}">
-                <a16:creationId xmlns:a16="http://schemas.microsoft.com/office/drawing/2014/main" id="{6C6C857F-A83A-484E-AF9A-A08A17A02FBE}"/>
+                <a16:creationId xmlns:a16="http://schemas.microsoft.com/office/drawing/2014/main" id="{54831165-913B-4466-8895-7A3654DA6B0B}"/>
               </a:ext>
             </a:extLst>
           </p:cNvPr>
@@ -8450,7 +8450,7 @@
           <p:cNvPr id="4" name="close-rule">
             <a:extLst xmlns:a="http://schemas.openxmlformats.org/drawingml/2006/main">
               <a:ext uri="{FF2B5EF4-FFF2-40B4-BE49-F238E27FC236}">
-                <a16:creationId xmlns:a16="http://schemas.microsoft.com/office/drawing/2014/main" id="{45761ED2-D475-472F-B152-54B60DA23542}"/>
+                <a16:creationId xmlns:a16="http://schemas.microsoft.com/office/drawing/2014/main" id="{619029B3-CF84-4676-A516-DA0C2BC73561}"/>
               </a:ext>
             </a:extLst>
           </p:cNvPr>
@@ -8481,7 +8481,7 @@
           <p:cNvPr id="5" name="close-footer">
             <a:extLst xmlns:a="http://schemas.openxmlformats.org/drawingml/2006/main">
               <a:ext uri="{FF2B5EF4-FFF2-40B4-BE49-F238E27FC236}">
-                <a16:creationId xmlns:a16="http://schemas.microsoft.com/office/drawing/2014/main" id="{507BF386-55BF-4CEA-AEE4-1F1C62163E58}"/>
+                <a16:creationId xmlns:a16="http://schemas.microsoft.com/office/drawing/2014/main" id="{AE8A4256-142C-42A8-8528-FAE254754E6D}"/>
               </a:ext>
             </a:extLst>
           </p:cNvPr>
@@ -8606,7 +8606,7 @@
     </p:spTree>
     <p:extLst>
       <p:ext uri="{BB962C8B-B14F-4D97-AF65-F5344CB8AC3E}">
-        <p14:creationId xmlns:p14="http://schemas.microsoft.com/office/powerpoint/2010/main" val="1420055739"/>
+        <p14:creationId xmlns:p14="http://schemas.microsoft.com/office/powerpoint/2010/main" val="866489565"/>
       </p:ext>
     </p:extLst>
   </p:cSld>
@@ -8637,7 +8637,7 @@
           <p:cNvPr id="17" name="eyebrow">
             <a:extLst xmlns:a="http://schemas.openxmlformats.org/drawingml/2006/main">
               <a:ext uri="{FF2B5EF4-FFF2-40B4-BE49-F238E27FC236}">
-                <a16:creationId xmlns:a16="http://schemas.microsoft.com/office/drawing/2014/main" id="{ED5D0DEA-113B-472D-8E9B-BBF9219F53D4}"/>
+                <a16:creationId xmlns:a16="http://schemas.microsoft.com/office/drawing/2014/main" id="{627E8044-B881-42B7-9E29-D75F47B977E9}"/>
               </a:ext>
             </a:extLst>
           </p:cNvPr>
@@ -8764,7 +8764,7 @@
           <p:cNvPr id="2" name="page">
             <a:extLst xmlns:a="http://schemas.openxmlformats.org/drawingml/2006/main">
               <a:ext uri="{FF2B5EF4-FFF2-40B4-BE49-F238E27FC236}">
-                <a16:creationId xmlns:a16="http://schemas.microsoft.com/office/drawing/2014/main" id="{081A5E5A-D66B-457D-80E9-9AED42F523D8}"/>
+                <a16:creationId xmlns:a16="http://schemas.microsoft.com/office/drawing/2014/main" id="{AE591A0F-E42B-411A-8C87-F662C53EE3BC}"/>
               </a:ext>
             </a:extLst>
           </p:cNvPr>
@@ -8891,7 +8891,7 @@
           <p:cNvPr id="3" name="scope-rule">
             <a:extLst xmlns:a="http://schemas.openxmlformats.org/drawingml/2006/main">
               <a:ext uri="{FF2B5EF4-FFF2-40B4-BE49-F238E27FC236}">
-                <a16:creationId xmlns:a16="http://schemas.microsoft.com/office/drawing/2014/main" id="{AC7FFEAB-37DC-4142-B3F1-6C660E4F745B}"/>
+                <a16:creationId xmlns:a16="http://schemas.microsoft.com/office/drawing/2014/main" id="{05FF98D9-3610-4AD1-A7AD-ADB759147A00}"/>
               </a:ext>
             </a:extLst>
           </p:cNvPr>
@@ -8922,7 +8922,7 @@
           <p:cNvPr id="4" name="title">
             <a:extLst xmlns:a="http://schemas.openxmlformats.org/drawingml/2006/main">
               <a:ext uri="{FF2B5EF4-FFF2-40B4-BE49-F238E27FC236}">
-                <a16:creationId xmlns:a16="http://schemas.microsoft.com/office/drawing/2014/main" id="{C90FC55F-C5B4-421C-BCA0-05C27291C39F}"/>
+                <a16:creationId xmlns:a16="http://schemas.microsoft.com/office/drawing/2014/main" id="{A5024C36-C5F1-4A0B-9E38-7EF1D49C2940}"/>
               </a:ext>
             </a:extLst>
           </p:cNvPr>
@@ -9049,7 +9049,7 @@
           <p:cNvPr id="5" name="subtitle">
             <a:extLst xmlns:a="http://schemas.openxmlformats.org/drawingml/2006/main">
               <a:ext uri="{FF2B5EF4-FFF2-40B4-BE49-F238E27FC236}">
-                <a16:creationId xmlns:a16="http://schemas.microsoft.com/office/drawing/2014/main" id="{922826B7-87D3-46EE-BD9A-97CEC704B506}"/>
+                <a16:creationId xmlns:a16="http://schemas.microsoft.com/office/drawing/2014/main" id="{1CAD3AFF-B411-4B13-87E4-15B03F945F93}"/>
               </a:ext>
             </a:extLst>
           </p:cNvPr>
@@ -9176,7 +9176,7 @@
           <p:cNvPr id="6" name="scope-left">
             <a:extLst xmlns:a="http://schemas.openxmlformats.org/drawingml/2006/main">
               <a:ext uri="{FF2B5EF4-FFF2-40B4-BE49-F238E27FC236}">
-                <a16:creationId xmlns:a16="http://schemas.microsoft.com/office/drawing/2014/main" id="{D232A0D0-F8A7-44CF-BE5C-AF817C4F838F}"/>
+                <a16:creationId xmlns:a16="http://schemas.microsoft.com/office/drawing/2014/main" id="{D9C9A58E-B51E-490B-B506-EC865601BC50}"/>
               </a:ext>
             </a:extLst>
           </p:cNvPr>
@@ -9303,7 +9303,7 @@
           <p:cNvPr id="7" name="scope-left-body">
             <a:extLst xmlns:a="http://schemas.openxmlformats.org/drawingml/2006/main">
               <a:ext uri="{FF2B5EF4-FFF2-40B4-BE49-F238E27FC236}">
-                <a16:creationId xmlns:a16="http://schemas.microsoft.com/office/drawing/2014/main" id="{93DC741E-A1B6-4F72-AACB-165AD3C302E7}"/>
+                <a16:creationId xmlns:a16="http://schemas.microsoft.com/office/drawing/2014/main" id="{DA98233F-B1CD-4160-9D97-0AE5E3D94219}"/>
               </a:ext>
             </a:extLst>
           </p:cNvPr>
@@ -9430,7 +9430,7 @@
           <p:cNvPr id="8" name="scope-rule-1">
             <a:extLst xmlns:a="http://schemas.openxmlformats.org/drawingml/2006/main">
               <a:ext uri="{FF2B5EF4-FFF2-40B4-BE49-F238E27FC236}">
-                <a16:creationId xmlns:a16="http://schemas.microsoft.com/office/drawing/2014/main" id="{4B2BA52A-8CA9-4DA6-84E8-52CEDA4AECA4}"/>
+                <a16:creationId xmlns:a16="http://schemas.microsoft.com/office/drawing/2014/main" id="{FCEBE7FE-02D1-4319-9AD5-1D68DDDD65A5}"/>
               </a:ext>
             </a:extLst>
           </p:cNvPr>
@@ -9461,7 +9461,7 @@
           <p:cNvPr id="9" name="scope-card-1-text">
             <a:extLst xmlns:a="http://schemas.openxmlformats.org/drawingml/2006/main">
               <a:ext uri="{FF2B5EF4-FFF2-40B4-BE49-F238E27FC236}">
-                <a16:creationId xmlns:a16="http://schemas.microsoft.com/office/drawing/2014/main" id="{8DF1C449-119E-40C6-A3D0-CF60CB40901E}"/>
+                <a16:creationId xmlns:a16="http://schemas.microsoft.com/office/drawing/2014/main" id="{3825BD2D-FBC9-419A-B121-6D6AD59D971A}"/>
               </a:ext>
             </a:extLst>
           </p:cNvPr>
@@ -9609,7 +9609,7 @@
           <p:cNvPr id="10" name="scope-rule-2">
             <a:extLst xmlns:a="http://schemas.openxmlformats.org/drawingml/2006/main">
               <a:ext uri="{FF2B5EF4-FFF2-40B4-BE49-F238E27FC236}">
-                <a16:creationId xmlns:a16="http://schemas.microsoft.com/office/drawing/2014/main" id="{DD108978-25E2-4016-A5BE-DE2DA98729CF}"/>
+                <a16:creationId xmlns:a16="http://schemas.microsoft.com/office/drawing/2014/main" id="{936AA6CA-ED61-4412-A14D-B2A4C90F7890}"/>
               </a:ext>
             </a:extLst>
           </p:cNvPr>
@@ -9640,7 +9640,7 @@
           <p:cNvPr id="11" name="scope-card-2-text">
             <a:extLst xmlns:a="http://schemas.openxmlformats.org/drawingml/2006/main">
               <a:ext uri="{FF2B5EF4-FFF2-40B4-BE49-F238E27FC236}">
-                <a16:creationId xmlns:a16="http://schemas.microsoft.com/office/drawing/2014/main" id="{09951871-8533-4131-8B1A-0ADBEAFDA7F1}"/>
+                <a16:creationId xmlns:a16="http://schemas.microsoft.com/office/drawing/2014/main" id="{758D198E-3C02-4876-B891-47F922806463}"/>
               </a:ext>
             </a:extLst>
           </p:cNvPr>
@@ -9788,7 +9788,7 @@
           <p:cNvPr id="12" name="scope-rule-3">
             <a:extLst xmlns:a="http://schemas.openxmlformats.org/drawingml/2006/main">
               <a:ext uri="{FF2B5EF4-FFF2-40B4-BE49-F238E27FC236}">
-                <a16:creationId xmlns:a16="http://schemas.microsoft.com/office/drawing/2014/main" id="{55E5C5B7-43FD-4366-8151-C8F334EE20AE}"/>
+                <a16:creationId xmlns:a16="http://schemas.microsoft.com/office/drawing/2014/main" id="{665F09B1-C16B-4923-83FB-98E2D168C336}"/>
               </a:ext>
             </a:extLst>
           </p:cNvPr>
@@ -9819,7 +9819,7 @@
           <p:cNvPr id="13" name="scope-card-3-text">
             <a:extLst xmlns:a="http://schemas.openxmlformats.org/drawingml/2006/main">
               <a:ext uri="{FF2B5EF4-FFF2-40B4-BE49-F238E27FC236}">
-                <a16:creationId xmlns:a16="http://schemas.microsoft.com/office/drawing/2014/main" id="{B3C9333E-A5B7-4D0D-B7F2-0C4CC6111D06}"/>
+                <a16:creationId xmlns:a16="http://schemas.microsoft.com/office/drawing/2014/main" id="{4BC835B0-B1B9-4398-9995-58A444A09988}"/>
               </a:ext>
             </a:extLst>
           </p:cNvPr>
@@ -9967,7 +9967,7 @@
           <p:cNvPr id="14" name="scope-rule-4">
             <a:extLst xmlns:a="http://schemas.openxmlformats.org/drawingml/2006/main">
               <a:ext uri="{FF2B5EF4-FFF2-40B4-BE49-F238E27FC236}">
-                <a16:creationId xmlns:a16="http://schemas.microsoft.com/office/drawing/2014/main" id="{15F24320-7D39-49EC-88EE-6D4AEE95D182}"/>
+                <a16:creationId xmlns:a16="http://schemas.microsoft.com/office/drawing/2014/main" id="{0F3C4563-736F-49CA-B087-A49C3A73993F}"/>
               </a:ext>
             </a:extLst>
           </p:cNvPr>
@@ -9998,7 +9998,7 @@
           <p:cNvPr id="15" name="scope-card-4-text">
             <a:extLst xmlns:a="http://schemas.openxmlformats.org/drawingml/2006/main">
               <a:ext uri="{FF2B5EF4-FFF2-40B4-BE49-F238E27FC236}">
-                <a16:creationId xmlns:a16="http://schemas.microsoft.com/office/drawing/2014/main" id="{49BA3956-2FAE-44B8-8A05-E83DA9E7CEE9}"/>
+                <a16:creationId xmlns:a16="http://schemas.microsoft.com/office/drawing/2014/main" id="{CC7D3EAA-B2C5-4E70-BB2C-D4543CC88299}"/>
               </a:ext>
             </a:extLst>
           </p:cNvPr>
@@ -10146,7 +10146,7 @@
           <p:cNvPr id="16" name="footer">
             <a:extLst xmlns:a="http://schemas.openxmlformats.org/drawingml/2006/main">
               <a:ext uri="{FF2B5EF4-FFF2-40B4-BE49-F238E27FC236}">
-                <a16:creationId xmlns:a16="http://schemas.microsoft.com/office/drawing/2014/main" id="{0231DC42-FC35-4699-BBA5-93B8EA66EFEB}"/>
+                <a16:creationId xmlns:a16="http://schemas.microsoft.com/office/drawing/2014/main" id="{FD309732-CCB7-4A0D-A917-986E78A7CC94}"/>
               </a:ext>
             </a:extLst>
           </p:cNvPr>
@@ -10271,7 +10271,7 @@
     </p:spTree>
     <p:extLst>
       <p:ext uri="{BB962C8B-B14F-4D97-AF65-F5344CB8AC3E}">
-        <p14:creationId xmlns:p14="http://schemas.microsoft.com/office/powerpoint/2010/main" val="537826869"/>
+        <p14:creationId xmlns:p14="http://schemas.microsoft.com/office/powerpoint/2010/main" val="304098937"/>
       </p:ext>
     </p:extLst>
   </p:cSld>
@@ -10302,7 +10302,7 @@
           <p:cNvPr id="26" name="eyebrow">
             <a:extLst xmlns:a="http://schemas.openxmlformats.org/drawingml/2006/main">
               <a:ext uri="{FF2B5EF4-FFF2-40B4-BE49-F238E27FC236}">
-                <a16:creationId xmlns:a16="http://schemas.microsoft.com/office/drawing/2014/main" id="{F7EDD7B2-6279-4CA5-98A5-473B73E8FEEE}"/>
+                <a16:creationId xmlns:a16="http://schemas.microsoft.com/office/drawing/2014/main" id="{1A1250CD-1ECD-490D-A8AD-393CBFDA1DA5}"/>
               </a:ext>
             </a:extLst>
           </p:cNvPr>
@@ -10429,7 +10429,7 @@
           <p:cNvPr id="2" name="page">
             <a:extLst xmlns:a="http://schemas.openxmlformats.org/drawingml/2006/main">
               <a:ext uri="{FF2B5EF4-FFF2-40B4-BE49-F238E27FC236}">
-                <a16:creationId xmlns:a16="http://schemas.microsoft.com/office/drawing/2014/main" id="{7C126B20-651A-4AB5-A769-FE51A7680BE9}"/>
+                <a16:creationId xmlns:a16="http://schemas.microsoft.com/office/drawing/2014/main" id="{5EB84BF5-53C2-4CCC-A4D5-6E8C5CBDE9B8}"/>
               </a:ext>
             </a:extLst>
           </p:cNvPr>
@@ -10556,7 +10556,7 @@
           <p:cNvPr id="3" name="path-rule">
             <a:extLst xmlns:a="http://schemas.openxmlformats.org/drawingml/2006/main">
               <a:ext uri="{FF2B5EF4-FFF2-40B4-BE49-F238E27FC236}">
-                <a16:creationId xmlns:a16="http://schemas.microsoft.com/office/drawing/2014/main" id="{CEB48FE1-1152-4296-899A-CAAA33FD9F27}"/>
+                <a16:creationId xmlns:a16="http://schemas.microsoft.com/office/drawing/2014/main" id="{92EBF3F2-2DCB-46F0-A04F-F24BF52C5777}"/>
               </a:ext>
             </a:extLst>
           </p:cNvPr>
@@ -10587,7 +10587,7 @@
           <p:cNvPr id="4" name="title">
             <a:extLst xmlns:a="http://schemas.openxmlformats.org/drawingml/2006/main">
               <a:ext uri="{FF2B5EF4-FFF2-40B4-BE49-F238E27FC236}">
-                <a16:creationId xmlns:a16="http://schemas.microsoft.com/office/drawing/2014/main" id="{F8A1637C-74AE-444E-B132-7709077945D1}"/>
+                <a16:creationId xmlns:a16="http://schemas.microsoft.com/office/drawing/2014/main" id="{5B151EB7-5276-4CDA-8E33-BAADA2283CD0}"/>
               </a:ext>
             </a:extLst>
           </p:cNvPr>
@@ -10714,7 +10714,7 @@
           <p:cNvPr id="5" name="step-number-1">
             <a:extLst xmlns:a="http://schemas.openxmlformats.org/drawingml/2006/main">
               <a:ext uri="{FF2B5EF4-FFF2-40B4-BE49-F238E27FC236}">
-                <a16:creationId xmlns:a16="http://schemas.microsoft.com/office/drawing/2014/main" id="{4209DCAB-77E6-426A-A081-A209728DE801}"/>
+                <a16:creationId xmlns:a16="http://schemas.microsoft.com/office/drawing/2014/main" id="{0DE6E198-E6CF-49F0-9691-DCDB23FA5761}"/>
               </a:ext>
             </a:extLst>
           </p:cNvPr>
@@ -10841,7 +10841,7 @@
           <p:cNvPr id="6" name="step-label-1">
             <a:extLst xmlns:a="http://schemas.openxmlformats.org/drawingml/2006/main">
               <a:ext uri="{FF2B5EF4-FFF2-40B4-BE49-F238E27FC236}">
-                <a16:creationId xmlns:a16="http://schemas.microsoft.com/office/drawing/2014/main" id="{D528D2DD-A006-4CA0-B9D3-8AEFAA7105BE}"/>
+                <a16:creationId xmlns:a16="http://schemas.microsoft.com/office/drawing/2014/main" id="{81386B0C-299A-4CB0-AFAC-EE63F00A3D37}"/>
               </a:ext>
             </a:extLst>
           </p:cNvPr>
@@ -10968,7 +10968,7 @@
           <p:cNvPr id="7" name="step-detail-1">
             <a:extLst xmlns:a="http://schemas.openxmlformats.org/drawingml/2006/main">
               <a:ext uri="{FF2B5EF4-FFF2-40B4-BE49-F238E27FC236}">
-                <a16:creationId xmlns:a16="http://schemas.microsoft.com/office/drawing/2014/main" id="{02C20FC1-B884-4C36-AB98-368DB08CBBDA}"/>
+                <a16:creationId xmlns:a16="http://schemas.microsoft.com/office/drawing/2014/main" id="{62E9F05B-87FD-4674-8019-E8D57087CC3F}"/>
               </a:ext>
             </a:extLst>
           </p:cNvPr>
@@ -11095,7 +11095,7 @@
           <p:cNvPr id="8" name="step-line-1">
             <a:extLst xmlns:a="http://schemas.openxmlformats.org/drawingml/2006/main">
               <a:ext uri="{FF2B5EF4-FFF2-40B4-BE49-F238E27FC236}">
-                <a16:creationId xmlns:a16="http://schemas.microsoft.com/office/drawing/2014/main" id="{202C91E8-B112-4412-BEC7-5713AD1527D4}"/>
+                <a16:creationId xmlns:a16="http://schemas.microsoft.com/office/drawing/2014/main" id="{14AB0E43-E724-4F8E-B50E-E6F7CBD6FCB4}"/>
               </a:ext>
             </a:extLst>
           </p:cNvPr>
@@ -11126,7 +11126,7 @@
           <p:cNvPr id="9" name="step-number-2">
             <a:extLst xmlns:a="http://schemas.openxmlformats.org/drawingml/2006/main">
               <a:ext uri="{FF2B5EF4-FFF2-40B4-BE49-F238E27FC236}">
-                <a16:creationId xmlns:a16="http://schemas.microsoft.com/office/drawing/2014/main" id="{E33BB2AC-CD24-4276-AACF-2B8801301D21}"/>
+                <a16:creationId xmlns:a16="http://schemas.microsoft.com/office/drawing/2014/main" id="{D8224CC6-B13F-4CE4-92C6-6E7C595AA292}"/>
               </a:ext>
             </a:extLst>
           </p:cNvPr>
@@ -11253,7 +11253,7 @@
           <p:cNvPr id="10" name="step-label-2">
             <a:extLst xmlns:a="http://schemas.openxmlformats.org/drawingml/2006/main">
               <a:ext uri="{FF2B5EF4-FFF2-40B4-BE49-F238E27FC236}">
-                <a16:creationId xmlns:a16="http://schemas.microsoft.com/office/drawing/2014/main" id="{67F33CC7-CB40-452C-9F7B-6DFBB090E38E}"/>
+                <a16:creationId xmlns:a16="http://schemas.microsoft.com/office/drawing/2014/main" id="{9270696A-85B8-4F02-8308-C58BB2DE53D2}"/>
               </a:ext>
             </a:extLst>
           </p:cNvPr>
@@ -11380,7 +11380,7 @@
           <p:cNvPr id="11" name="step-detail-2">
             <a:extLst xmlns:a="http://schemas.openxmlformats.org/drawingml/2006/main">
               <a:ext uri="{FF2B5EF4-FFF2-40B4-BE49-F238E27FC236}">
-                <a16:creationId xmlns:a16="http://schemas.microsoft.com/office/drawing/2014/main" id="{B99CC1C8-693B-4816-94D4-BA6F5E4D6F7B}"/>
+                <a16:creationId xmlns:a16="http://schemas.microsoft.com/office/drawing/2014/main" id="{A4D23EFC-AFE5-466A-93D2-675B05431C0D}"/>
               </a:ext>
             </a:extLst>
           </p:cNvPr>
@@ -11507,7 +11507,7 @@
           <p:cNvPr id="12" name="step-line-2">
             <a:extLst xmlns:a="http://schemas.openxmlformats.org/drawingml/2006/main">
               <a:ext uri="{FF2B5EF4-FFF2-40B4-BE49-F238E27FC236}">
-                <a16:creationId xmlns:a16="http://schemas.microsoft.com/office/drawing/2014/main" id="{26C20DE5-0E46-4DD4-8172-AE10C22ED665}"/>
+                <a16:creationId xmlns:a16="http://schemas.microsoft.com/office/drawing/2014/main" id="{1EC0CBE6-FB81-4B15-AF92-9DAC9079A6DC}"/>
               </a:ext>
             </a:extLst>
           </p:cNvPr>
@@ -11538,7 +11538,7 @@
           <p:cNvPr id="13" name="step-number-3">
             <a:extLst xmlns:a="http://schemas.openxmlformats.org/drawingml/2006/main">
               <a:ext uri="{FF2B5EF4-FFF2-40B4-BE49-F238E27FC236}">
-                <a16:creationId xmlns:a16="http://schemas.microsoft.com/office/drawing/2014/main" id="{18252DD7-B5F8-4F13-9392-644DEDA47548}"/>
+                <a16:creationId xmlns:a16="http://schemas.microsoft.com/office/drawing/2014/main" id="{863308E7-A253-4DF8-9DC0-BA72E48FE59C}"/>
               </a:ext>
             </a:extLst>
           </p:cNvPr>
@@ -11665,7 +11665,7 @@
           <p:cNvPr id="14" name="step-label-3">
             <a:extLst xmlns:a="http://schemas.openxmlformats.org/drawingml/2006/main">
               <a:ext uri="{FF2B5EF4-FFF2-40B4-BE49-F238E27FC236}">
-                <a16:creationId xmlns:a16="http://schemas.microsoft.com/office/drawing/2014/main" id="{6A7141ED-8821-49A5-8D8F-BB1B6F988E88}"/>
+                <a16:creationId xmlns:a16="http://schemas.microsoft.com/office/drawing/2014/main" id="{E0941C13-E0FF-4F1B-A4DE-C9409603B6E1}"/>
               </a:ext>
             </a:extLst>
           </p:cNvPr>
@@ -11792,7 +11792,7 @@
           <p:cNvPr id="15" name="step-detail-3">
             <a:extLst xmlns:a="http://schemas.openxmlformats.org/drawingml/2006/main">
               <a:ext uri="{FF2B5EF4-FFF2-40B4-BE49-F238E27FC236}">
-                <a16:creationId xmlns:a16="http://schemas.microsoft.com/office/drawing/2014/main" id="{E3D30E33-2877-4171-9454-486DC5285804}"/>
+                <a16:creationId xmlns:a16="http://schemas.microsoft.com/office/drawing/2014/main" id="{0881F6B4-D4B3-443E-AE41-60B8BB7F60AA}"/>
               </a:ext>
             </a:extLst>
           </p:cNvPr>
@@ -11919,7 +11919,7 @@
           <p:cNvPr id="16" name="step-line-3">
             <a:extLst xmlns:a="http://schemas.openxmlformats.org/drawingml/2006/main">
               <a:ext uri="{FF2B5EF4-FFF2-40B4-BE49-F238E27FC236}">
-                <a16:creationId xmlns:a16="http://schemas.microsoft.com/office/drawing/2014/main" id="{FC10A586-E917-437F-B3B2-82451CAE43D7}"/>
+                <a16:creationId xmlns:a16="http://schemas.microsoft.com/office/drawing/2014/main" id="{92EAD9B8-765A-4E17-BB3C-62D188737EC5}"/>
               </a:ext>
             </a:extLst>
           </p:cNvPr>
@@ -11950,7 +11950,7 @@
           <p:cNvPr id="17" name="step-number-4">
             <a:extLst xmlns:a="http://schemas.openxmlformats.org/drawingml/2006/main">
               <a:ext uri="{FF2B5EF4-FFF2-40B4-BE49-F238E27FC236}">
-                <a16:creationId xmlns:a16="http://schemas.microsoft.com/office/drawing/2014/main" id="{344D6563-D795-4C02-8225-B6A8B8372383}"/>
+                <a16:creationId xmlns:a16="http://schemas.microsoft.com/office/drawing/2014/main" id="{DC5FE754-6423-4157-B6EA-C2F899167790}"/>
               </a:ext>
             </a:extLst>
           </p:cNvPr>
@@ -12077,7 +12077,7 @@
           <p:cNvPr id="18" name="step-label-4">
             <a:extLst xmlns:a="http://schemas.openxmlformats.org/drawingml/2006/main">
               <a:ext uri="{FF2B5EF4-FFF2-40B4-BE49-F238E27FC236}">
-                <a16:creationId xmlns:a16="http://schemas.microsoft.com/office/drawing/2014/main" id="{630D570D-1F84-4DD8-84F4-CC284B37D5BA}"/>
+                <a16:creationId xmlns:a16="http://schemas.microsoft.com/office/drawing/2014/main" id="{47C42CFC-6052-4C90-9701-9FBE0F053D79}"/>
               </a:ext>
             </a:extLst>
           </p:cNvPr>
@@ -12204,7 +12204,7 @@
           <p:cNvPr id="19" name="step-detail-4">
             <a:extLst xmlns:a="http://schemas.openxmlformats.org/drawingml/2006/main">
               <a:ext uri="{FF2B5EF4-FFF2-40B4-BE49-F238E27FC236}">
-                <a16:creationId xmlns:a16="http://schemas.microsoft.com/office/drawing/2014/main" id="{2A62FC46-55BE-424A-B39D-C9F1E7C30EB4}"/>
+                <a16:creationId xmlns:a16="http://schemas.microsoft.com/office/drawing/2014/main" id="{9D04DD4E-033E-4412-9BAA-D420BBF21363}"/>
               </a:ext>
             </a:extLst>
           </p:cNvPr>
@@ -12331,7 +12331,7 @@
           <p:cNvPr id="20" name="step-line-4">
             <a:extLst xmlns:a="http://schemas.openxmlformats.org/drawingml/2006/main">
               <a:ext uri="{FF2B5EF4-FFF2-40B4-BE49-F238E27FC236}">
-                <a16:creationId xmlns:a16="http://schemas.microsoft.com/office/drawing/2014/main" id="{B5EF027F-D046-4DA8-AE08-C8AF2F5F7732}"/>
+                <a16:creationId xmlns:a16="http://schemas.microsoft.com/office/drawing/2014/main" id="{E0331400-46D2-4E93-AB3C-CE9B3A2C6BE6}"/>
               </a:ext>
             </a:extLst>
           </p:cNvPr>
@@ -12362,7 +12362,7 @@
           <p:cNvPr id="21" name="step-number-5">
             <a:extLst xmlns:a="http://schemas.openxmlformats.org/drawingml/2006/main">
               <a:ext uri="{FF2B5EF4-FFF2-40B4-BE49-F238E27FC236}">
-                <a16:creationId xmlns:a16="http://schemas.microsoft.com/office/drawing/2014/main" id="{C3605E41-0E84-494A-80A9-1DF3934326C6}"/>
+                <a16:creationId xmlns:a16="http://schemas.microsoft.com/office/drawing/2014/main" id="{BBF8B99A-C77F-4F84-BD23-1C614A7A32A9}"/>
               </a:ext>
             </a:extLst>
           </p:cNvPr>
@@ -12489,7 +12489,7 @@
           <p:cNvPr id="22" name="step-label-5">
             <a:extLst xmlns:a="http://schemas.openxmlformats.org/drawingml/2006/main">
               <a:ext uri="{FF2B5EF4-FFF2-40B4-BE49-F238E27FC236}">
-                <a16:creationId xmlns:a16="http://schemas.microsoft.com/office/drawing/2014/main" id="{01416158-C82C-4E66-A215-9568D915A65D}"/>
+                <a16:creationId xmlns:a16="http://schemas.microsoft.com/office/drawing/2014/main" id="{D1940E11-9405-408E-8F1A-243516CFEB81}"/>
               </a:ext>
             </a:extLst>
           </p:cNvPr>
@@ -12616,7 +12616,7 @@
           <p:cNvPr id="23" name="step-detail-5">
             <a:extLst xmlns:a="http://schemas.openxmlformats.org/drawingml/2006/main">
               <a:ext uri="{FF2B5EF4-FFF2-40B4-BE49-F238E27FC236}">
-                <a16:creationId xmlns:a16="http://schemas.microsoft.com/office/drawing/2014/main" id="{7041B8BB-ADC6-4B5B-AC5C-FC8100C15D3F}"/>
+                <a16:creationId xmlns:a16="http://schemas.microsoft.com/office/drawing/2014/main" id="{15B97E33-9B4C-492A-AA54-750A2C8699CE}"/>
               </a:ext>
             </a:extLst>
           </p:cNvPr>
@@ -12743,7 +12743,7 @@
           <p:cNvPr id="24" name="step-line-5">
             <a:extLst xmlns:a="http://schemas.openxmlformats.org/drawingml/2006/main">
               <a:ext uri="{FF2B5EF4-FFF2-40B4-BE49-F238E27FC236}">
-                <a16:creationId xmlns:a16="http://schemas.microsoft.com/office/drawing/2014/main" id="{F8424E7A-3512-4DA8-9836-E348DB4F6767}"/>
+                <a16:creationId xmlns:a16="http://schemas.microsoft.com/office/drawing/2014/main" id="{DDF6C909-E37E-4B55-8C27-84DF0B4A03BE}"/>
               </a:ext>
             </a:extLst>
           </p:cNvPr>
@@ -12774,7 +12774,7 @@
           <p:cNvPr id="25" name="footer">
             <a:extLst xmlns:a="http://schemas.openxmlformats.org/drawingml/2006/main">
               <a:ext uri="{FF2B5EF4-FFF2-40B4-BE49-F238E27FC236}">
-                <a16:creationId xmlns:a16="http://schemas.microsoft.com/office/drawing/2014/main" id="{465EAF57-63D4-418D-8E31-CCD6EB15E23D}"/>
+                <a16:creationId xmlns:a16="http://schemas.microsoft.com/office/drawing/2014/main" id="{6ABCCAAB-0AC8-4F2F-8F26-B06BB0F4FC92}"/>
               </a:ext>
             </a:extLst>
           </p:cNvPr>
@@ -12899,7 +12899,7 @@
     </p:spTree>
     <p:extLst>
       <p:ext uri="{BB962C8B-B14F-4D97-AF65-F5344CB8AC3E}">
-        <p14:creationId xmlns:p14="http://schemas.microsoft.com/office/powerpoint/2010/main" val="1188945025"/>
+        <p14:creationId xmlns:p14="http://schemas.microsoft.com/office/powerpoint/2010/main" val="268139092"/>
       </p:ext>
     </p:extLst>
   </p:cSld>
@@ -12930,7 +12930,7 @@
           <p:cNvPr id="13" name="eyebrow">
             <a:extLst xmlns:a="http://schemas.openxmlformats.org/drawingml/2006/main">
               <a:ext uri="{FF2B5EF4-FFF2-40B4-BE49-F238E27FC236}">
-                <a16:creationId xmlns:a16="http://schemas.microsoft.com/office/drawing/2014/main" id="{B3E78A31-1C08-4036-A14E-CF33A7395207}"/>
+                <a16:creationId xmlns:a16="http://schemas.microsoft.com/office/drawing/2014/main" id="{5414C82E-5719-42B3-8861-D20837F64529}"/>
               </a:ext>
             </a:extLst>
           </p:cNvPr>
@@ -13057,7 +13057,7 @@
           <p:cNvPr id="2" name="page">
             <a:extLst xmlns:a="http://schemas.openxmlformats.org/drawingml/2006/main">
               <a:ext uri="{FF2B5EF4-FFF2-40B4-BE49-F238E27FC236}">
-                <a16:creationId xmlns:a16="http://schemas.microsoft.com/office/drawing/2014/main" id="{E4CCAE62-D6E5-460D-9261-D092C33CC02C}"/>
+                <a16:creationId xmlns:a16="http://schemas.microsoft.com/office/drawing/2014/main" id="{F5677424-1604-4CAB-A291-3A202EE24E70}"/>
               </a:ext>
             </a:extLst>
           </p:cNvPr>
@@ -13184,7 +13184,7 @@
           <p:cNvPr id="3" name="scan-rule">
             <a:extLst xmlns:a="http://schemas.openxmlformats.org/drawingml/2006/main">
               <a:ext uri="{FF2B5EF4-FFF2-40B4-BE49-F238E27FC236}">
-                <a16:creationId xmlns:a16="http://schemas.microsoft.com/office/drawing/2014/main" id="{BE9AF167-DC83-4EC4-B5D6-7B7795C1D31C}"/>
+                <a16:creationId xmlns:a16="http://schemas.microsoft.com/office/drawing/2014/main" id="{760C8BC5-56ED-4A82-908D-350E06ACBC7E}"/>
               </a:ext>
             </a:extLst>
           </p:cNvPr>
@@ -13215,7 +13215,7 @@
           <p:cNvPr id="4" name="title">
             <a:extLst xmlns:a="http://schemas.openxmlformats.org/drawingml/2006/main">
               <a:ext uri="{FF2B5EF4-FFF2-40B4-BE49-F238E27FC236}">
-                <a16:creationId xmlns:a16="http://schemas.microsoft.com/office/drawing/2014/main" id="{6D65230B-522D-4F42-89A7-2039E1E2F287}"/>
+                <a16:creationId xmlns:a16="http://schemas.microsoft.com/office/drawing/2014/main" id="{37EA05F5-9B42-44D6-AB64-0BB1B22E9F18}"/>
               </a:ext>
             </a:extLst>
           </p:cNvPr>
@@ -13342,7 +13342,7 @@
           <p:cNvPr id="5" name="scan-metric-1">
             <a:extLst xmlns:a="http://schemas.openxmlformats.org/drawingml/2006/main">
               <a:ext uri="{FF2B5EF4-FFF2-40B4-BE49-F238E27FC236}">
-                <a16:creationId xmlns:a16="http://schemas.microsoft.com/office/drawing/2014/main" id="{FD98800A-CE5E-4942-B3E5-2B1DD7058051}"/>
+                <a16:creationId xmlns:a16="http://schemas.microsoft.com/office/drawing/2014/main" id="{2B431240-86F1-4940-A006-2DE488F62A57}"/>
               </a:ext>
             </a:extLst>
           </p:cNvPr>
@@ -13469,7 +13469,7 @@
           <p:cNvPr id="6" name="scan-metric-1-label">
             <a:extLst xmlns:a="http://schemas.openxmlformats.org/drawingml/2006/main">
               <a:ext uri="{FF2B5EF4-FFF2-40B4-BE49-F238E27FC236}">
-                <a16:creationId xmlns:a16="http://schemas.microsoft.com/office/drawing/2014/main" id="{2A84A9D8-F4EC-45D5-8364-BBB146AFEA45}"/>
+                <a16:creationId xmlns:a16="http://schemas.microsoft.com/office/drawing/2014/main" id="{C8B9A4EA-D87F-4D30-92DC-FA528EC408AC}"/>
               </a:ext>
             </a:extLst>
           </p:cNvPr>
@@ -13596,7 +13596,7 @@
           <p:cNvPr id="7" name="scan-metric-2">
             <a:extLst xmlns:a="http://schemas.openxmlformats.org/drawingml/2006/main">
               <a:ext uri="{FF2B5EF4-FFF2-40B4-BE49-F238E27FC236}">
-                <a16:creationId xmlns:a16="http://schemas.microsoft.com/office/drawing/2014/main" id="{4EAB76E4-CEC4-4774-8BE7-91167B97D9D2}"/>
+                <a16:creationId xmlns:a16="http://schemas.microsoft.com/office/drawing/2014/main" id="{9C84FFE0-A738-41AC-893D-FF1C26EA8829}"/>
               </a:ext>
             </a:extLst>
           </p:cNvPr>
@@ -13723,7 +13723,7 @@
           <p:cNvPr id="8" name="scan-metric-2-label">
             <a:extLst xmlns:a="http://schemas.openxmlformats.org/drawingml/2006/main">
               <a:ext uri="{FF2B5EF4-FFF2-40B4-BE49-F238E27FC236}">
-                <a16:creationId xmlns:a16="http://schemas.microsoft.com/office/drawing/2014/main" id="{DE5F89CA-6C0B-40DC-9054-B636F33B635A}"/>
+                <a16:creationId xmlns:a16="http://schemas.microsoft.com/office/drawing/2014/main" id="{B3BCA95A-4315-43DA-B5CF-D8A838F6BB1C}"/>
               </a:ext>
             </a:extLst>
           </p:cNvPr>
@@ -13850,7 +13850,7 @@
           <p:cNvPr id="9" name="scan-metric-3">
             <a:extLst xmlns:a="http://schemas.openxmlformats.org/drawingml/2006/main">
               <a:ext uri="{FF2B5EF4-FFF2-40B4-BE49-F238E27FC236}">
-                <a16:creationId xmlns:a16="http://schemas.microsoft.com/office/drawing/2014/main" id="{12789CB6-0916-440A-8920-13109117348C}"/>
+                <a16:creationId xmlns:a16="http://schemas.microsoft.com/office/drawing/2014/main" id="{982471E9-B3DD-4E83-B9A6-6A79982B1DF8}"/>
               </a:ext>
             </a:extLst>
           </p:cNvPr>
@@ -13977,7 +13977,7 @@
           <p:cNvPr id="10" name="scan-metric-3-label">
             <a:extLst xmlns:a="http://schemas.openxmlformats.org/drawingml/2006/main">
               <a:ext uri="{FF2B5EF4-FFF2-40B4-BE49-F238E27FC236}">
-                <a16:creationId xmlns:a16="http://schemas.microsoft.com/office/drawing/2014/main" id="{81098198-2112-4C74-8616-6E732BA9EA9D}"/>
+                <a16:creationId xmlns:a16="http://schemas.microsoft.com/office/drawing/2014/main" id="{EA815DCE-AF6B-4D0E-BD57-0B2CBB7BD91C}"/>
               </a:ext>
             </a:extLst>
           </p:cNvPr>
@@ -14104,7 +14104,7 @@
           <p:cNvPr id="11" name="scan-body">
             <a:extLst xmlns:a="http://schemas.openxmlformats.org/drawingml/2006/main">
               <a:ext uri="{FF2B5EF4-FFF2-40B4-BE49-F238E27FC236}">
-                <a16:creationId xmlns:a16="http://schemas.microsoft.com/office/drawing/2014/main" id="{89138F4A-5135-48C6-903F-CA6FBE1CA9D8}"/>
+                <a16:creationId xmlns:a16="http://schemas.microsoft.com/office/drawing/2014/main" id="{D1CE7309-697E-4C84-8716-249D222D7EBE}"/>
               </a:ext>
             </a:extLst>
           </p:cNvPr>
@@ -14231,7 +14231,7 @@
           <p:cNvPr id="12" name="footer">
             <a:extLst xmlns:a="http://schemas.openxmlformats.org/drawingml/2006/main">
               <a:ext uri="{FF2B5EF4-FFF2-40B4-BE49-F238E27FC236}">
-                <a16:creationId xmlns:a16="http://schemas.microsoft.com/office/drawing/2014/main" id="{B6938886-F29F-4E9F-8A2C-D9D1BCD559F1}"/>
+                <a16:creationId xmlns:a16="http://schemas.microsoft.com/office/drawing/2014/main" id="{7E6F524B-CE3F-4789-A35F-ED39BBF9BBDE}"/>
               </a:ext>
             </a:extLst>
           </p:cNvPr>
@@ -14356,7 +14356,7 @@
     </p:spTree>
     <p:extLst>
       <p:ext uri="{BB962C8B-B14F-4D97-AF65-F5344CB8AC3E}">
-        <p14:creationId xmlns:p14="http://schemas.microsoft.com/office/powerpoint/2010/main" val="1997118242"/>
+        <p14:creationId xmlns:p14="http://schemas.microsoft.com/office/powerpoint/2010/main" val="1594014084"/>
       </p:ext>
     </p:extLst>
   </p:cSld>
@@ -14387,7 +14387,7 @@
           <p:cNvPr id="13" name="eyebrow">
             <a:extLst xmlns:a="http://schemas.openxmlformats.org/drawingml/2006/main">
               <a:ext uri="{FF2B5EF4-FFF2-40B4-BE49-F238E27FC236}">
-                <a16:creationId xmlns:a16="http://schemas.microsoft.com/office/drawing/2014/main" id="{73C83F2C-5FEE-4C30-97B2-2FE3D231FF99}"/>
+                <a16:creationId xmlns:a16="http://schemas.microsoft.com/office/drawing/2014/main" id="{6900C420-C2E5-4837-8700-3A6B9123827D}"/>
               </a:ext>
             </a:extLst>
           </p:cNvPr>
@@ -14514,7 +14514,7 @@
           <p:cNvPr id="2" name="page">
             <a:extLst xmlns:a="http://schemas.openxmlformats.org/drawingml/2006/main">
               <a:ext uri="{FF2B5EF4-FFF2-40B4-BE49-F238E27FC236}">
-                <a16:creationId xmlns:a16="http://schemas.microsoft.com/office/drawing/2014/main" id="{576A29B8-459E-4F4B-AEB4-36A2C532A5D4}"/>
+                <a16:creationId xmlns:a16="http://schemas.microsoft.com/office/drawing/2014/main" id="{55BD0BED-4E14-43AB-A28F-640FC98D35EB}"/>
               </a:ext>
             </a:extLst>
           </p:cNvPr>
@@ -14641,7 +14641,7 @@
           <p:cNvPr id="3" name="parsing-rule">
             <a:extLst xmlns:a="http://schemas.openxmlformats.org/drawingml/2006/main">
               <a:ext uri="{FF2B5EF4-FFF2-40B4-BE49-F238E27FC236}">
-                <a16:creationId xmlns:a16="http://schemas.microsoft.com/office/drawing/2014/main" id="{A6A05D10-2E0C-4EB8-89B7-C4383CD61B56}"/>
+                <a16:creationId xmlns:a16="http://schemas.microsoft.com/office/drawing/2014/main" id="{FEFBD473-E22E-4D9F-AA1E-53B3504A29D2}"/>
               </a:ext>
             </a:extLst>
           </p:cNvPr>
@@ -14672,7 +14672,7 @@
           <p:cNvPr id="4" name="title">
             <a:extLst xmlns:a="http://schemas.openxmlformats.org/drawingml/2006/main">
               <a:ext uri="{FF2B5EF4-FFF2-40B4-BE49-F238E27FC236}">
-                <a16:creationId xmlns:a16="http://schemas.microsoft.com/office/drawing/2014/main" id="{1FA1A0D9-2549-44D3-9425-BB0926665191}"/>
+                <a16:creationId xmlns:a16="http://schemas.microsoft.com/office/drawing/2014/main" id="{4B7CF422-729B-41BD-B032-1494EFFACF5B}"/>
               </a:ext>
             </a:extLst>
           </p:cNvPr>
@@ -14799,7 +14799,7 @@
           <p:cNvPr id="5" name="parse-metric-1">
             <a:extLst xmlns:a="http://schemas.openxmlformats.org/drawingml/2006/main">
               <a:ext uri="{FF2B5EF4-FFF2-40B4-BE49-F238E27FC236}">
-                <a16:creationId xmlns:a16="http://schemas.microsoft.com/office/drawing/2014/main" id="{6FFF48D7-3029-4861-8976-7540CD574DF4}"/>
+                <a16:creationId xmlns:a16="http://schemas.microsoft.com/office/drawing/2014/main" id="{D8E96661-B12B-49AE-8BD2-C52244390BFF}"/>
               </a:ext>
             </a:extLst>
           </p:cNvPr>
@@ -14926,7 +14926,7 @@
           <p:cNvPr id="6" name="parse-metric-1-label">
             <a:extLst xmlns:a="http://schemas.openxmlformats.org/drawingml/2006/main">
               <a:ext uri="{FF2B5EF4-FFF2-40B4-BE49-F238E27FC236}">
-                <a16:creationId xmlns:a16="http://schemas.microsoft.com/office/drawing/2014/main" id="{B992948A-9871-4ED8-B8D0-4F4454EDC9DA}"/>
+                <a16:creationId xmlns:a16="http://schemas.microsoft.com/office/drawing/2014/main" id="{0207D027-C27D-4B2B-AF0C-C34283EC8B2D}"/>
               </a:ext>
             </a:extLst>
           </p:cNvPr>
@@ -15053,7 +15053,7 @@
           <p:cNvPr id="7" name="parse-metric-2">
             <a:extLst xmlns:a="http://schemas.openxmlformats.org/drawingml/2006/main">
               <a:ext uri="{FF2B5EF4-FFF2-40B4-BE49-F238E27FC236}">
-                <a16:creationId xmlns:a16="http://schemas.microsoft.com/office/drawing/2014/main" id="{EC9123A4-EC7C-4B05-9B4C-98C7190B54F5}"/>
+                <a16:creationId xmlns:a16="http://schemas.microsoft.com/office/drawing/2014/main" id="{7098D08F-7AB7-4CB3-9671-BBC4981AAFAE}"/>
               </a:ext>
             </a:extLst>
           </p:cNvPr>
@@ -15180,7 +15180,7 @@
           <p:cNvPr id="8" name="parse-metric-2-label">
             <a:extLst xmlns:a="http://schemas.openxmlformats.org/drawingml/2006/main">
               <a:ext uri="{FF2B5EF4-FFF2-40B4-BE49-F238E27FC236}">
-                <a16:creationId xmlns:a16="http://schemas.microsoft.com/office/drawing/2014/main" id="{79ADB3C9-CFEA-4D04-89B9-13F792857C78}"/>
+                <a16:creationId xmlns:a16="http://schemas.microsoft.com/office/drawing/2014/main" id="{AA56E499-584A-43E3-BC49-772A32A8D5F5}"/>
               </a:ext>
             </a:extLst>
           </p:cNvPr>
@@ -15307,7 +15307,7 @@
           <p:cNvPr id="9" name="parse-metric-3">
             <a:extLst xmlns:a="http://schemas.openxmlformats.org/drawingml/2006/main">
               <a:ext uri="{FF2B5EF4-FFF2-40B4-BE49-F238E27FC236}">
-                <a16:creationId xmlns:a16="http://schemas.microsoft.com/office/drawing/2014/main" id="{83A3E12E-CF6B-4E22-88C2-3EA7A6DC5D9E}"/>
+                <a16:creationId xmlns:a16="http://schemas.microsoft.com/office/drawing/2014/main" id="{EC1B5FAC-F625-4019-BE9F-CACB8995D760}"/>
               </a:ext>
             </a:extLst>
           </p:cNvPr>
@@ -15434,7 +15434,7 @@
           <p:cNvPr id="10" name="parse-metric-3-label">
             <a:extLst xmlns:a="http://schemas.openxmlformats.org/drawingml/2006/main">
               <a:ext uri="{FF2B5EF4-FFF2-40B4-BE49-F238E27FC236}">
-                <a16:creationId xmlns:a16="http://schemas.microsoft.com/office/drawing/2014/main" id="{C1234554-1C14-4F5F-95EB-8160DB346DEB}"/>
+                <a16:creationId xmlns:a16="http://schemas.microsoft.com/office/drawing/2014/main" id="{71FD1DAD-E1A8-4D4D-88D4-A240DD449240}"/>
               </a:ext>
             </a:extLst>
           </p:cNvPr>
@@ -15561,7 +15561,7 @@
           <p:cNvPr id="11" name="parse-body">
             <a:extLst xmlns:a="http://schemas.openxmlformats.org/drawingml/2006/main">
               <a:ext uri="{FF2B5EF4-FFF2-40B4-BE49-F238E27FC236}">
-                <a16:creationId xmlns:a16="http://schemas.microsoft.com/office/drawing/2014/main" id="{185052DC-0D50-4078-B631-8340C136ABEA}"/>
+                <a16:creationId xmlns:a16="http://schemas.microsoft.com/office/drawing/2014/main" id="{506A9011-0BC9-42B4-A6C6-EACFDC6E24AD}"/>
               </a:ext>
             </a:extLst>
           </p:cNvPr>
@@ -15688,7 +15688,7 @@
           <p:cNvPr id="12" name="footer">
             <a:extLst xmlns:a="http://schemas.openxmlformats.org/drawingml/2006/main">
               <a:ext uri="{FF2B5EF4-FFF2-40B4-BE49-F238E27FC236}">
-                <a16:creationId xmlns:a16="http://schemas.microsoft.com/office/drawing/2014/main" id="{6A05623B-8B0B-4D76-B649-BA098D260C28}"/>
+                <a16:creationId xmlns:a16="http://schemas.microsoft.com/office/drawing/2014/main" id="{F365CA38-2F3F-4EB0-9F86-03D939181E28}"/>
               </a:ext>
             </a:extLst>
           </p:cNvPr>
@@ -15813,7 +15813,7 @@
     </p:spTree>
     <p:extLst>
       <p:ext uri="{BB962C8B-B14F-4D97-AF65-F5344CB8AC3E}">
-        <p14:creationId xmlns:p14="http://schemas.microsoft.com/office/powerpoint/2010/main" val="1011294234"/>
+        <p14:creationId xmlns:p14="http://schemas.microsoft.com/office/powerpoint/2010/main" val="1283954744"/>
       </p:ext>
     </p:extLst>
   </p:cSld>
@@ -15844,7 +15844,7 @@
           <p:cNvPr id="16" name="eyebrow">
             <a:extLst xmlns:a="http://schemas.openxmlformats.org/drawingml/2006/main">
               <a:ext uri="{FF2B5EF4-FFF2-40B4-BE49-F238E27FC236}">
-                <a16:creationId xmlns:a16="http://schemas.microsoft.com/office/drawing/2014/main" id="{2AA2327C-D6AC-4262-922A-A281F0930D03}"/>
+                <a16:creationId xmlns:a16="http://schemas.microsoft.com/office/drawing/2014/main" id="{E9F76807-0E8E-43BC-B8DA-FA337E1F4285}"/>
               </a:ext>
             </a:extLst>
           </p:cNvPr>
@@ -15971,7 +15971,7 @@
           <p:cNvPr id="2" name="page">
             <a:extLst xmlns:a="http://schemas.openxmlformats.org/drawingml/2006/main">
               <a:ext uri="{FF2B5EF4-FFF2-40B4-BE49-F238E27FC236}">
-                <a16:creationId xmlns:a16="http://schemas.microsoft.com/office/drawing/2014/main" id="{B86AF9AA-0AB4-4E12-B4C9-DD28129E67AB}"/>
+                <a16:creationId xmlns:a16="http://schemas.microsoft.com/office/drawing/2014/main" id="{BED1826B-4963-4699-8A3B-AFE272E16B5B}"/>
               </a:ext>
             </a:extLst>
           </p:cNvPr>
@@ -16098,7 +16098,7 @@
           <p:cNvPr id="3" name="review-rule">
             <a:extLst xmlns:a="http://schemas.openxmlformats.org/drawingml/2006/main">
               <a:ext uri="{FF2B5EF4-FFF2-40B4-BE49-F238E27FC236}">
-                <a16:creationId xmlns:a16="http://schemas.microsoft.com/office/drawing/2014/main" id="{E7101CEC-431D-43E0-8C95-6368D4AAFC54}"/>
+                <a16:creationId xmlns:a16="http://schemas.microsoft.com/office/drawing/2014/main" id="{85A6D451-31BC-4D86-AFA6-97CC4B2FE818}"/>
               </a:ext>
             </a:extLst>
           </p:cNvPr>
@@ -16129,7 +16129,7 @@
           <p:cNvPr id="4" name="title">
             <a:extLst xmlns:a="http://schemas.openxmlformats.org/drawingml/2006/main">
               <a:ext uri="{FF2B5EF4-FFF2-40B4-BE49-F238E27FC236}">
-                <a16:creationId xmlns:a16="http://schemas.microsoft.com/office/drawing/2014/main" id="{C515802C-A9FB-445F-AB72-417E7008AD57}"/>
+                <a16:creationId xmlns:a16="http://schemas.microsoft.com/office/drawing/2014/main" id="{5A380B16-55C3-4436-8A4B-038F8C940BDD}"/>
               </a:ext>
             </a:extLst>
           </p:cNvPr>
@@ -16256,7 +16256,7 @@
           <p:cNvPr id="5" name="review-rule-1">
             <a:extLst xmlns:a="http://schemas.openxmlformats.org/drawingml/2006/main">
               <a:ext uri="{FF2B5EF4-FFF2-40B4-BE49-F238E27FC236}">
-                <a16:creationId xmlns:a16="http://schemas.microsoft.com/office/drawing/2014/main" id="{FBB2AFEC-C0C9-426A-8219-537EE85533C7}"/>
+                <a16:creationId xmlns:a16="http://schemas.microsoft.com/office/drawing/2014/main" id="{25F36F6B-297A-430D-853E-B057479DE077}"/>
               </a:ext>
             </a:extLst>
           </p:cNvPr>
@@ -16287,7 +16287,7 @@
           <p:cNvPr id="6" name="review-card-1-title">
             <a:extLst xmlns:a="http://schemas.openxmlformats.org/drawingml/2006/main">
               <a:ext uri="{FF2B5EF4-FFF2-40B4-BE49-F238E27FC236}">
-                <a16:creationId xmlns:a16="http://schemas.microsoft.com/office/drawing/2014/main" id="{EE739C20-A8ED-4FC2-90BD-5E7347B213CB}"/>
+                <a16:creationId xmlns:a16="http://schemas.microsoft.com/office/drawing/2014/main" id="{C060FBEB-35CF-4FAD-9A82-DEFBACE993BB}"/>
               </a:ext>
             </a:extLst>
           </p:cNvPr>
@@ -16414,7 +16414,7 @@
           <p:cNvPr id="7" name="review-card-1-body">
             <a:extLst xmlns:a="http://schemas.openxmlformats.org/drawingml/2006/main">
               <a:ext uri="{FF2B5EF4-FFF2-40B4-BE49-F238E27FC236}">
-                <a16:creationId xmlns:a16="http://schemas.microsoft.com/office/drawing/2014/main" id="{C9AC5693-23DD-4764-97FC-1EEEBCE75930}"/>
+                <a16:creationId xmlns:a16="http://schemas.microsoft.com/office/drawing/2014/main" id="{5C2CC4E5-4E18-48C3-A81D-A6EEEDC7314F}"/>
               </a:ext>
             </a:extLst>
           </p:cNvPr>
@@ -16562,7 +16562,7 @@
           <p:cNvPr id="8" name="review-rule-2">
             <a:extLst xmlns:a="http://schemas.openxmlformats.org/drawingml/2006/main">
               <a:ext uri="{FF2B5EF4-FFF2-40B4-BE49-F238E27FC236}">
-                <a16:creationId xmlns:a16="http://schemas.microsoft.com/office/drawing/2014/main" id="{5DFA370A-D3D2-44C0-9224-2F76EB99E468}"/>
+                <a16:creationId xmlns:a16="http://schemas.microsoft.com/office/drawing/2014/main" id="{0C3746D9-10BA-4E43-8B3D-0828B0693148}"/>
               </a:ext>
             </a:extLst>
           </p:cNvPr>
@@ -16593,7 +16593,7 @@
           <p:cNvPr id="9" name="review-card-2-title">
             <a:extLst xmlns:a="http://schemas.openxmlformats.org/drawingml/2006/main">
               <a:ext uri="{FF2B5EF4-FFF2-40B4-BE49-F238E27FC236}">
-                <a16:creationId xmlns:a16="http://schemas.microsoft.com/office/drawing/2014/main" id="{E4BF4E0A-B380-4526-9933-7A0FE220CCA9}"/>
+                <a16:creationId xmlns:a16="http://schemas.microsoft.com/office/drawing/2014/main" id="{A38FC53E-E2A4-4BD8-89A8-FF220C17EAD5}"/>
               </a:ext>
             </a:extLst>
           </p:cNvPr>
@@ -16720,7 +16720,7 @@
           <p:cNvPr id="10" name="review-card-2-body">
             <a:extLst xmlns:a="http://schemas.openxmlformats.org/drawingml/2006/main">
               <a:ext uri="{FF2B5EF4-FFF2-40B4-BE49-F238E27FC236}">
-                <a16:creationId xmlns:a16="http://schemas.microsoft.com/office/drawing/2014/main" id="{7FF29421-F6CC-4B76-A25E-A14A66E2D306}"/>
+                <a16:creationId xmlns:a16="http://schemas.microsoft.com/office/drawing/2014/main" id="{30831575-1485-4EDF-8C03-7984D2AAC2AF}"/>
               </a:ext>
             </a:extLst>
           </p:cNvPr>
@@ -16868,7 +16868,7 @@
           <p:cNvPr id="11" name="review-rule-3">
             <a:extLst xmlns:a="http://schemas.openxmlformats.org/drawingml/2006/main">
               <a:ext uri="{FF2B5EF4-FFF2-40B4-BE49-F238E27FC236}">
-                <a16:creationId xmlns:a16="http://schemas.microsoft.com/office/drawing/2014/main" id="{4465210A-2BFB-4A38-856E-A4207BFAF6ED}"/>
+                <a16:creationId xmlns:a16="http://schemas.microsoft.com/office/drawing/2014/main" id="{519C852A-F806-4F75-8ED6-3039B98AD879}"/>
               </a:ext>
             </a:extLst>
           </p:cNvPr>
@@ -16899,7 +16899,7 @@
           <p:cNvPr id="12" name="review-card-3-title">
             <a:extLst xmlns:a="http://schemas.openxmlformats.org/drawingml/2006/main">
               <a:ext uri="{FF2B5EF4-FFF2-40B4-BE49-F238E27FC236}">
-                <a16:creationId xmlns:a16="http://schemas.microsoft.com/office/drawing/2014/main" id="{932D5456-8BD1-478B-89D4-C7BEC82EB17D}"/>
+                <a16:creationId xmlns:a16="http://schemas.microsoft.com/office/drawing/2014/main" id="{4C28740D-6C9B-4A60-BF64-77B8DDEDA5F5}"/>
               </a:ext>
             </a:extLst>
           </p:cNvPr>
@@ -17026,7 +17026,7 @@
           <p:cNvPr id="13" name="review-card-3-body">
             <a:extLst xmlns:a="http://schemas.openxmlformats.org/drawingml/2006/main">
               <a:ext uri="{FF2B5EF4-FFF2-40B4-BE49-F238E27FC236}">
-                <a16:creationId xmlns:a16="http://schemas.microsoft.com/office/drawing/2014/main" id="{FA08BBE6-8A0B-413B-8F4E-FB56D807B261}"/>
+                <a16:creationId xmlns:a16="http://schemas.microsoft.com/office/drawing/2014/main" id="{E990185A-9670-429D-A1C7-178055442134}"/>
               </a:ext>
             </a:extLst>
           </p:cNvPr>
@@ -17174,7 +17174,7 @@
           <p:cNvPr id="14" name="review-footer-note">
             <a:extLst xmlns:a="http://schemas.openxmlformats.org/drawingml/2006/main">
               <a:ext uri="{FF2B5EF4-FFF2-40B4-BE49-F238E27FC236}">
-                <a16:creationId xmlns:a16="http://schemas.microsoft.com/office/drawing/2014/main" id="{E3914DF1-78D3-40CF-B882-BF44CD63B741}"/>
+                <a16:creationId xmlns:a16="http://schemas.microsoft.com/office/drawing/2014/main" id="{5B0C280A-755A-4BA9-8F54-2AB35A01F1CE}"/>
               </a:ext>
             </a:extLst>
           </p:cNvPr>
@@ -17301,7 +17301,7 @@
           <p:cNvPr id="15" name="footer">
             <a:extLst xmlns:a="http://schemas.openxmlformats.org/drawingml/2006/main">
               <a:ext uri="{FF2B5EF4-FFF2-40B4-BE49-F238E27FC236}">
-                <a16:creationId xmlns:a16="http://schemas.microsoft.com/office/drawing/2014/main" id="{3A23352E-E002-4D25-8D36-3BA0476B8EC4}"/>
+                <a16:creationId xmlns:a16="http://schemas.microsoft.com/office/drawing/2014/main" id="{90127668-1294-457D-9A6B-0825A9F8D476}"/>
               </a:ext>
             </a:extLst>
           </p:cNvPr>
@@ -17426,7 +17426,7 @@
     </p:spTree>
     <p:extLst>
       <p:ext uri="{BB962C8B-B14F-4D97-AF65-F5344CB8AC3E}">
-        <p14:creationId xmlns:p14="http://schemas.microsoft.com/office/powerpoint/2010/main" val="1268155137"/>
+        <p14:creationId xmlns:p14="http://schemas.microsoft.com/office/powerpoint/2010/main" val="1534709905"/>
       </p:ext>
     </p:extLst>
   </p:cSld>
@@ -17457,7 +17457,7 @@
           <p:cNvPr id="15" name="eyebrow">
             <a:extLst xmlns:a="http://schemas.openxmlformats.org/drawingml/2006/main">
               <a:ext uri="{FF2B5EF4-FFF2-40B4-BE49-F238E27FC236}">
-                <a16:creationId xmlns:a16="http://schemas.microsoft.com/office/drawing/2014/main" id="{4D17B3A4-9539-45BC-811B-8E18E149A2DA}"/>
+                <a16:creationId xmlns:a16="http://schemas.microsoft.com/office/drawing/2014/main" id="{E895EDBF-34EC-4842-A85F-F4C0810AF48E}"/>
               </a:ext>
             </a:extLst>
           </p:cNvPr>
@@ -17584,7 +17584,7 @@
           <p:cNvPr id="2" name="page">
             <a:extLst xmlns:a="http://schemas.openxmlformats.org/drawingml/2006/main">
               <a:ext uri="{FF2B5EF4-FFF2-40B4-BE49-F238E27FC236}">
-                <a16:creationId xmlns:a16="http://schemas.microsoft.com/office/drawing/2014/main" id="{A3170FCE-DAFC-4D9B-ABFC-431F6D86CAE5}"/>
+                <a16:creationId xmlns:a16="http://schemas.microsoft.com/office/drawing/2014/main" id="{86478717-676B-4BD0-97F5-10DD3902C559}"/>
               </a:ext>
             </a:extLst>
           </p:cNvPr>
@@ -17711,7 +17711,7 @@
           <p:cNvPr id="3" name="index-rule">
             <a:extLst xmlns:a="http://schemas.openxmlformats.org/drawingml/2006/main">
               <a:ext uri="{FF2B5EF4-FFF2-40B4-BE49-F238E27FC236}">
-                <a16:creationId xmlns:a16="http://schemas.microsoft.com/office/drawing/2014/main" id="{23A43488-39F9-4BE2-8515-9BDEC7C2C48F}"/>
+                <a16:creationId xmlns:a16="http://schemas.microsoft.com/office/drawing/2014/main" id="{B1C87686-3B0F-4AD5-9353-75643D166AD4}"/>
               </a:ext>
             </a:extLst>
           </p:cNvPr>
@@ -17742,7 +17742,7 @@
           <p:cNvPr id="4" name="title">
             <a:extLst xmlns:a="http://schemas.openxmlformats.org/drawingml/2006/main">
               <a:ext uri="{FF2B5EF4-FFF2-40B4-BE49-F238E27FC236}">
-                <a16:creationId xmlns:a16="http://schemas.microsoft.com/office/drawing/2014/main" id="{F89E671E-571D-4E76-B6A5-BF4534B2295F}"/>
+                <a16:creationId xmlns:a16="http://schemas.microsoft.com/office/drawing/2014/main" id="{035CC8A7-652C-44F4-A461-9F5D53893FCF}"/>
               </a:ext>
             </a:extLst>
           </p:cNvPr>
@@ -17869,7 +17869,7 @@
           <p:cNvPr id="5" name="index-source">
             <a:extLst xmlns:a="http://schemas.openxmlformats.org/drawingml/2006/main">
               <a:ext uri="{FF2B5EF4-FFF2-40B4-BE49-F238E27FC236}">
-                <a16:creationId xmlns:a16="http://schemas.microsoft.com/office/drawing/2014/main" id="{71C909DD-6D6B-4608-ABE6-285BF371D54C}"/>
+                <a16:creationId xmlns:a16="http://schemas.microsoft.com/office/drawing/2014/main" id="{F5A029F1-F2F2-4D2A-8603-327C88DC5C59}"/>
               </a:ext>
             </a:extLst>
           </p:cNvPr>
@@ -17904,7 +17904,7 @@
           <p:cNvPr id="6" name="index-source-text">
             <a:extLst xmlns:a="http://schemas.openxmlformats.org/drawingml/2006/main">
               <a:ext uri="{FF2B5EF4-FFF2-40B4-BE49-F238E27FC236}">
-                <a16:creationId xmlns:a16="http://schemas.microsoft.com/office/drawing/2014/main" id="{C1C6E395-0AF7-4F56-918E-2BD8DCAB229B}"/>
+                <a16:creationId xmlns:a16="http://schemas.microsoft.com/office/drawing/2014/main" id="{2A9BD51D-0394-44B1-BC84-116BCF70B0C5}"/>
               </a:ext>
             </a:extLst>
           </p:cNvPr>
@@ -18052,7 +18052,7 @@
           <p:cNvPr id="7" name="index-derived">
             <a:extLst xmlns:a="http://schemas.openxmlformats.org/drawingml/2006/main">
               <a:ext uri="{FF2B5EF4-FFF2-40B4-BE49-F238E27FC236}">
-                <a16:creationId xmlns:a16="http://schemas.microsoft.com/office/drawing/2014/main" id="{0A2DE9BC-14E5-4723-AC2F-7B67BB6EBDE4}"/>
+                <a16:creationId xmlns:a16="http://schemas.microsoft.com/office/drawing/2014/main" id="{58909799-68D6-4247-84E8-9F5E9C085B75}"/>
               </a:ext>
             </a:extLst>
           </p:cNvPr>
@@ -18087,7 +18087,7 @@
           <p:cNvPr id="8" name="index-derived-text">
             <a:extLst xmlns:a="http://schemas.openxmlformats.org/drawingml/2006/main">
               <a:ext uri="{FF2B5EF4-FFF2-40B4-BE49-F238E27FC236}">
-                <a16:creationId xmlns:a16="http://schemas.microsoft.com/office/drawing/2014/main" id="{5C10D684-66B2-4F28-A88C-A526C2FAB10F}"/>
+                <a16:creationId xmlns:a16="http://schemas.microsoft.com/office/drawing/2014/main" id="{5DB0BD0C-D57A-40C8-AA73-DF2D272962B1}"/>
               </a:ext>
             </a:extLst>
           </p:cNvPr>
@@ -18235,7 +18235,7 @@
           <p:cNvPr id="9" name="index-api">
             <a:extLst xmlns:a="http://schemas.openxmlformats.org/drawingml/2006/main">
               <a:ext uri="{FF2B5EF4-FFF2-40B4-BE49-F238E27FC236}">
-                <a16:creationId xmlns:a16="http://schemas.microsoft.com/office/drawing/2014/main" id="{0C853FBF-02C6-493F-8FEF-16ABC870AEFF}"/>
+                <a16:creationId xmlns:a16="http://schemas.microsoft.com/office/drawing/2014/main" id="{45EE659B-CB09-48BC-B6C9-417E9BE14390}"/>
               </a:ext>
             </a:extLst>
           </p:cNvPr>
@@ -18270,7 +18270,7 @@
           <p:cNvPr id="10" name="index-api-text">
             <a:extLst xmlns:a="http://schemas.openxmlformats.org/drawingml/2006/main">
               <a:ext uri="{FF2B5EF4-FFF2-40B4-BE49-F238E27FC236}">
-                <a16:creationId xmlns:a16="http://schemas.microsoft.com/office/drawing/2014/main" id="{E2E4372C-8987-4FFF-B353-2A51276675EC}"/>
+                <a16:creationId xmlns:a16="http://schemas.microsoft.com/office/drawing/2014/main" id="{80791FE6-722B-4CFC-B69F-D1E08FE5092F}"/>
               </a:ext>
             </a:extLst>
           </p:cNvPr>
@@ -18418,7 +18418,7 @@
           <p:cNvPr id="11" name="index-arrow-1">
             <a:extLst xmlns:a="http://schemas.openxmlformats.org/drawingml/2006/main">
               <a:ext uri="{FF2B5EF4-FFF2-40B4-BE49-F238E27FC236}">
-                <a16:creationId xmlns:a16="http://schemas.microsoft.com/office/drawing/2014/main" id="{D534EBFC-01FF-4213-999C-E2DB8C66D89F}"/>
+                <a16:creationId xmlns:a16="http://schemas.microsoft.com/office/drawing/2014/main" id="{0A4DE2F9-7910-47C3-A906-03A44BAE5884}"/>
               </a:ext>
             </a:extLst>
           </p:cNvPr>
@@ -18545,7 +18545,7 @@
           <p:cNvPr id="12" name="index-arrow-2">
             <a:extLst xmlns:a="http://schemas.openxmlformats.org/drawingml/2006/main">
               <a:ext uri="{FF2B5EF4-FFF2-40B4-BE49-F238E27FC236}">
-                <a16:creationId xmlns:a16="http://schemas.microsoft.com/office/drawing/2014/main" id="{A8B72192-7C8E-4C45-A0F6-5269EECDE817}"/>
+                <a16:creationId xmlns:a16="http://schemas.microsoft.com/office/drawing/2014/main" id="{3FBDF1F7-EBE9-42CE-B620-00DFC0AD2210}"/>
               </a:ext>
             </a:extLst>
           </p:cNvPr>
@@ -18672,7 +18672,7 @@
           <p:cNvPr id="13" name="index-body">
             <a:extLst xmlns:a="http://schemas.openxmlformats.org/drawingml/2006/main">
               <a:ext uri="{FF2B5EF4-FFF2-40B4-BE49-F238E27FC236}">
-                <a16:creationId xmlns:a16="http://schemas.microsoft.com/office/drawing/2014/main" id="{047AAAD6-C8F2-45A6-B6C9-0CE2769E88CE}"/>
+                <a16:creationId xmlns:a16="http://schemas.microsoft.com/office/drawing/2014/main" id="{63B5646E-B374-486F-850A-F83E37C10F7C}"/>
               </a:ext>
             </a:extLst>
           </p:cNvPr>
@@ -18799,7 +18799,7 @@
           <p:cNvPr id="14" name="footer">
             <a:extLst xmlns:a="http://schemas.openxmlformats.org/drawingml/2006/main">
               <a:ext uri="{FF2B5EF4-FFF2-40B4-BE49-F238E27FC236}">
-                <a16:creationId xmlns:a16="http://schemas.microsoft.com/office/drawing/2014/main" id="{A9F51B2E-F526-4F0E-8B87-86FCB7E3A093}"/>
+                <a16:creationId xmlns:a16="http://schemas.microsoft.com/office/drawing/2014/main" id="{D51439A6-3EBE-41C8-BA1C-7F51A7E25970}"/>
               </a:ext>
             </a:extLst>
           </p:cNvPr>
@@ -18924,7 +18924,7 @@
     </p:spTree>
     <p:extLst>
       <p:ext uri="{BB962C8B-B14F-4D97-AF65-F5344CB8AC3E}">
-        <p14:creationId xmlns:p14="http://schemas.microsoft.com/office/powerpoint/2010/main" val="1335841391"/>
+        <p14:creationId xmlns:p14="http://schemas.microsoft.com/office/powerpoint/2010/main" val="508871187"/>
       </p:ext>
     </p:extLst>
   </p:cSld>
@@ -18955,7 +18955,7 @@
           <p:cNvPr id="15" name="eyebrow">
             <a:extLst xmlns:a="http://schemas.openxmlformats.org/drawingml/2006/main">
               <a:ext uri="{FF2B5EF4-FFF2-40B4-BE49-F238E27FC236}">
-                <a16:creationId xmlns:a16="http://schemas.microsoft.com/office/drawing/2014/main" id="{554C69C8-DDEA-446C-B69C-4420F792C767}"/>
+                <a16:creationId xmlns:a16="http://schemas.microsoft.com/office/drawing/2014/main" id="{7AF79B00-DB66-4A41-B548-B2330D0E2F01}"/>
               </a:ext>
             </a:extLst>
           </p:cNvPr>
@@ -19082,7 +19082,7 @@
           <p:cNvPr id="2" name="page">
             <a:extLst xmlns:a="http://schemas.openxmlformats.org/drawingml/2006/main">
               <a:ext uri="{FF2B5EF4-FFF2-40B4-BE49-F238E27FC236}">
-                <a16:creationId xmlns:a16="http://schemas.microsoft.com/office/drawing/2014/main" id="{6A0B5392-B205-455C-B729-80198312139D}"/>
+                <a16:creationId xmlns:a16="http://schemas.microsoft.com/office/drawing/2014/main" id="{88A9015D-21F8-4783-B943-7EE8CD4623ED}"/>
               </a:ext>
             </a:extLst>
           </p:cNvPr>
@@ -19209,7 +19209,7 @@
           <p:cNvPr id="3" name="modes-rule">
             <a:extLst xmlns:a="http://schemas.openxmlformats.org/drawingml/2006/main">
               <a:ext uri="{FF2B5EF4-FFF2-40B4-BE49-F238E27FC236}">
-                <a16:creationId xmlns:a16="http://schemas.microsoft.com/office/drawing/2014/main" id="{A5DE9DED-E17B-4AF4-9665-F00F7F98F1B0}"/>
+                <a16:creationId xmlns:a16="http://schemas.microsoft.com/office/drawing/2014/main" id="{42A8EA77-E562-4734-9E07-D555E0320358}"/>
               </a:ext>
             </a:extLst>
           </p:cNvPr>
@@ -19240,7 +19240,7 @@
           <p:cNvPr id="4" name="title">
             <a:extLst xmlns:a="http://schemas.openxmlformats.org/drawingml/2006/main">
               <a:ext uri="{FF2B5EF4-FFF2-40B4-BE49-F238E27FC236}">
-                <a16:creationId xmlns:a16="http://schemas.microsoft.com/office/drawing/2014/main" id="{5D286D72-2879-40E5-BC3B-F42C9F7329E3}"/>
+                <a16:creationId xmlns:a16="http://schemas.microsoft.com/office/drawing/2014/main" id="{64EC745E-08BB-4DFC-8DEB-78B5CAE1E6DF}"/>
               </a:ext>
             </a:extLst>
           </p:cNvPr>
@@ -19357,7 +19357,7 @@
                   <a:srgbClr val="020618"/>
                 </a:solidFill>
               </a:rPr>
-              <a:t>Keyword search is live. Semantic search degrades visibly.</a:t>
+              <a:t>Keyword and semantic search are both live.</a:t>
             </a:r>
           </a:p>
         </p:txBody>
@@ -19367,7 +19367,7 @@
           <p:cNvPr id="5" name="keyword-rule">
             <a:extLst xmlns:a="http://schemas.openxmlformats.org/drawingml/2006/main">
               <a:ext uri="{FF2B5EF4-FFF2-40B4-BE49-F238E27FC236}">
-                <a16:creationId xmlns:a16="http://schemas.microsoft.com/office/drawing/2014/main" id="{19987DD8-FDDE-46FA-A08C-6C2F6CFAC199}"/>
+                <a16:creationId xmlns:a16="http://schemas.microsoft.com/office/drawing/2014/main" id="{B65DBB38-C77F-44A2-9253-62CDEBB2CB44}"/>
               </a:ext>
             </a:extLst>
           </p:cNvPr>
@@ -19398,7 +19398,7 @@
           <p:cNvPr id="6" name="keyword-title">
             <a:extLst xmlns:a="http://schemas.openxmlformats.org/drawingml/2006/main">
               <a:ext uri="{FF2B5EF4-FFF2-40B4-BE49-F238E27FC236}">
-                <a16:creationId xmlns:a16="http://schemas.microsoft.com/office/drawing/2014/main" id="{5AAA26B0-1653-435D-B506-215D13E7A33E}"/>
+                <a16:creationId xmlns:a16="http://schemas.microsoft.com/office/drawing/2014/main" id="{79AC8E3A-D764-47BA-972B-6D89B5C2BEED}"/>
               </a:ext>
             </a:extLst>
           </p:cNvPr>
@@ -19525,7 +19525,7 @@
           <p:cNvPr id="7" name="keyword-score">
             <a:extLst xmlns:a="http://schemas.openxmlformats.org/drawingml/2006/main">
               <a:ext uri="{FF2B5EF4-FFF2-40B4-BE49-F238E27FC236}">
-                <a16:creationId xmlns:a16="http://schemas.microsoft.com/office/drawing/2014/main" id="{F8C7349E-4DB3-41E0-8C31-433F1E5F2FD7}"/>
+                <a16:creationId xmlns:a16="http://schemas.microsoft.com/office/drawing/2014/main" id="{51970FCC-4AE0-4741-A768-D75F7B706D11}"/>
               </a:ext>
             </a:extLst>
           </p:cNvPr>
@@ -19652,7 +19652,7 @@
           <p:cNvPr id="8" name="keyword-body">
             <a:extLst xmlns:a="http://schemas.openxmlformats.org/drawingml/2006/main">
               <a:ext uri="{FF2B5EF4-FFF2-40B4-BE49-F238E27FC236}">
-                <a16:creationId xmlns:a16="http://schemas.microsoft.com/office/drawing/2014/main" id="{EA245A59-231C-439E-8F8F-F7A072074281}"/>
+                <a16:creationId xmlns:a16="http://schemas.microsoft.com/office/drawing/2014/main" id="{BD0B1751-A692-4DA5-9AE5-89974766CB26}"/>
               </a:ext>
             </a:extLst>
           </p:cNvPr>
@@ -19779,7 +19779,7 @@
           <p:cNvPr id="9" name="semantic-rule">
             <a:extLst xmlns:a="http://schemas.openxmlformats.org/drawingml/2006/main">
               <a:ext uri="{FF2B5EF4-FFF2-40B4-BE49-F238E27FC236}">
-                <a16:creationId xmlns:a16="http://schemas.microsoft.com/office/drawing/2014/main" id="{231F35F2-18B8-433C-8C43-6270F88E4A3F}"/>
+                <a16:creationId xmlns:a16="http://schemas.microsoft.com/office/drawing/2014/main" id="{3C36F6BE-44C8-47A4-812E-52B2CBC08B69}"/>
               </a:ext>
             </a:extLst>
           </p:cNvPr>
@@ -19810,7 +19810,7 @@
           <p:cNvPr id="10" name="semantic-title">
             <a:extLst xmlns:a="http://schemas.openxmlformats.org/drawingml/2006/main">
               <a:ext uri="{FF2B5EF4-FFF2-40B4-BE49-F238E27FC236}">
-                <a16:creationId xmlns:a16="http://schemas.microsoft.com/office/drawing/2014/main" id="{D99E5AD4-BCBC-4FDD-B324-E4AD02B0C220}"/>
+                <a16:creationId xmlns:a16="http://schemas.microsoft.com/office/drawing/2014/main" id="{6128F8D0-D44E-4EC5-BE85-D9419AAC9FE8}"/>
               </a:ext>
             </a:extLst>
           </p:cNvPr>
@@ -19937,7 +19937,7 @@
           <p:cNvPr id="11" name="semantic-state">
             <a:extLst xmlns:a="http://schemas.openxmlformats.org/drawingml/2006/main">
               <a:ext uri="{FF2B5EF4-FFF2-40B4-BE49-F238E27FC236}">
-                <a16:creationId xmlns:a16="http://schemas.microsoft.com/office/drawing/2014/main" id="{D42A249C-C8FF-415A-9F9C-6386E93D9DF9}"/>
+                <a16:creationId xmlns:a16="http://schemas.microsoft.com/office/drawing/2014/main" id="{BDD8731B-EBE7-466F-9FF4-D603CB155B37}"/>
               </a:ext>
             </a:extLst>
           </p:cNvPr>
@@ -19966,72 +19966,72 @@
           </a:bodyPr>
           <a:lstStyle xmlns:a="http://schemas.openxmlformats.org/drawingml/2006/main">
             <a:defPPr algn="l">
-              <a:defRPr sz="4050" b="1">
-                <a:solidFill>
-                  <a:srgbClr val="973C00"/>
+              <a:defRPr sz="4800" b="1">
+                <a:solidFill>
+                  <a:srgbClr val="007A55"/>
                 </a:solidFill>
               </a:defRPr>
             </a:defPPr>
             <a:lvl1pPr algn="l">
-              <a:defRPr sz="4050" b="1">
-                <a:solidFill>
-                  <a:srgbClr val="973C00"/>
+              <a:defRPr sz="4800" b="1">
+                <a:solidFill>
+                  <a:srgbClr val="007A55"/>
                 </a:solidFill>
               </a:defRPr>
             </a:lvl1pPr>
             <a:lvl2pPr algn="l">
-              <a:defRPr sz="4050" b="1">
-                <a:solidFill>
-                  <a:srgbClr val="973C00"/>
+              <a:defRPr sz="4800" b="1">
+                <a:solidFill>
+                  <a:srgbClr val="007A55"/>
                 </a:solidFill>
               </a:defRPr>
             </a:lvl2pPr>
             <a:lvl3pPr algn="l">
-              <a:defRPr sz="4050" b="1">
-                <a:solidFill>
-                  <a:srgbClr val="973C00"/>
+              <a:defRPr sz="4800" b="1">
+                <a:solidFill>
+                  <a:srgbClr val="007A55"/>
                 </a:solidFill>
               </a:defRPr>
             </a:lvl3pPr>
             <a:lvl4pPr algn="l">
-              <a:defRPr sz="4050" b="1">
-                <a:solidFill>
-                  <a:srgbClr val="973C00"/>
+              <a:defRPr sz="4800" b="1">
+                <a:solidFill>
+                  <a:srgbClr val="007A55"/>
                 </a:solidFill>
               </a:defRPr>
             </a:lvl4pPr>
             <a:lvl5pPr algn="l">
-              <a:defRPr sz="4050" b="1">
-                <a:solidFill>
-                  <a:srgbClr val="973C00"/>
+              <a:defRPr sz="4800" b="1">
+                <a:solidFill>
+                  <a:srgbClr val="007A55"/>
                 </a:solidFill>
               </a:defRPr>
             </a:lvl5pPr>
             <a:lvl6pPr algn="l">
-              <a:defRPr sz="4050" b="1">
-                <a:solidFill>
-                  <a:srgbClr val="973C00"/>
+              <a:defRPr sz="4800" b="1">
+                <a:solidFill>
+                  <a:srgbClr val="007A55"/>
                 </a:solidFill>
               </a:defRPr>
             </a:lvl6pPr>
             <a:lvl7pPr algn="l">
-              <a:defRPr sz="4050" b="1">
-                <a:solidFill>
-                  <a:srgbClr val="973C00"/>
+              <a:defRPr sz="4800" b="1">
+                <a:solidFill>
+                  <a:srgbClr val="007A55"/>
                 </a:solidFill>
               </a:defRPr>
             </a:lvl7pPr>
             <a:lvl8pPr algn="l">
-              <a:defRPr sz="4050" b="1">
-                <a:solidFill>
-                  <a:srgbClr val="973C00"/>
+              <a:defRPr sz="4800" b="1">
+                <a:solidFill>
+                  <a:srgbClr val="007A55"/>
                 </a:solidFill>
               </a:defRPr>
             </a:lvl8pPr>
             <a:lvl9pPr algn="l">
-              <a:defRPr sz="4050" b="1">
-                <a:solidFill>
-                  <a:srgbClr val="973C00"/>
+              <a:defRPr sz="4800" b="1">
+                <a:solidFill>
+                  <a:srgbClr val="007A55"/>
                 </a:solidFill>
               </a:defRPr>
             </a:lvl9pPr>
@@ -20042,19 +20042,19 @@
                 <a:spcPct val="108000"/>
               </a:lnSpc>
               <a:buNone/>
-              <a:defRPr sz="4050" b="1">
-                <a:solidFill>
-                  <a:srgbClr val="973C00"/>
+              <a:defRPr sz="4800" b="1">
+                <a:solidFill>
+                  <a:srgbClr val="007A55"/>
                 </a:solidFill>
               </a:defRPr>
             </a:pPr>
             <a:r>
-              <a:rPr sz="4050" b="1">
-                <a:solidFill>
-                  <a:srgbClr val="973C00"/>
+              <a:rPr sz="4800" b="1">
+                <a:solidFill>
+                  <a:srgbClr val="007A55"/>
                 </a:solidFill>
               </a:rPr>
-              <a:t>Partial</a:t>
+              <a:t>5/5</a:t>
             </a:r>
           </a:p>
         </p:txBody>
@@ -20064,7 +20064,7 @@
           <p:cNvPr id="12" name="semantic-body">
             <a:extLst xmlns:a="http://schemas.openxmlformats.org/drawingml/2006/main">
               <a:ext uri="{FF2B5EF4-FFF2-40B4-BE49-F238E27FC236}">
-                <a16:creationId xmlns:a16="http://schemas.microsoft.com/office/drawing/2014/main" id="{16C9541F-16A2-4093-B3B9-F07A3477661B}"/>
+                <a16:creationId xmlns:a16="http://schemas.microsoft.com/office/drawing/2014/main" id="{3CFC673F-F793-4130-90AD-40B52EFF43D2}"/>
               </a:ext>
             </a:extLst>
           </p:cNvPr>
@@ -20095,70 +20095,70 @@
             <a:defPPr algn="l">
               <a:defRPr sz="1425" b="0">
                 <a:solidFill>
-                  <a:srgbClr val="7B3306"/>
+                  <a:srgbClr val="006045"/>
                 </a:solidFill>
               </a:defRPr>
             </a:defPPr>
             <a:lvl1pPr algn="l">
               <a:defRPr sz="1425" b="0">
                 <a:solidFill>
-                  <a:srgbClr val="7B3306"/>
+                  <a:srgbClr val="006045"/>
                 </a:solidFill>
               </a:defRPr>
             </a:lvl1pPr>
             <a:lvl2pPr algn="l">
               <a:defRPr sz="1425" b="0">
                 <a:solidFill>
-                  <a:srgbClr val="7B3306"/>
+                  <a:srgbClr val="006045"/>
                 </a:solidFill>
               </a:defRPr>
             </a:lvl2pPr>
             <a:lvl3pPr algn="l">
               <a:defRPr sz="1425" b="0">
                 <a:solidFill>
-                  <a:srgbClr val="7B3306"/>
+                  <a:srgbClr val="006045"/>
                 </a:solidFill>
               </a:defRPr>
             </a:lvl3pPr>
             <a:lvl4pPr algn="l">
               <a:defRPr sz="1425" b="0">
                 <a:solidFill>
-                  <a:srgbClr val="7B3306"/>
+                  <a:srgbClr val="006045"/>
                 </a:solidFill>
               </a:defRPr>
             </a:lvl4pPr>
             <a:lvl5pPr algn="l">
               <a:defRPr sz="1425" b="0">
                 <a:solidFill>
-                  <a:srgbClr val="7B3306"/>
+                  <a:srgbClr val="006045"/>
                 </a:solidFill>
               </a:defRPr>
             </a:lvl5pPr>
             <a:lvl6pPr algn="l">
               <a:defRPr sz="1425" b="0">
                 <a:solidFill>
-                  <a:srgbClr val="7B3306"/>
+                  <a:srgbClr val="006045"/>
                 </a:solidFill>
               </a:defRPr>
             </a:lvl6pPr>
             <a:lvl7pPr algn="l">
               <a:defRPr sz="1425" b="0">
                 <a:solidFill>
-                  <a:srgbClr val="7B3306"/>
+                  <a:srgbClr val="006045"/>
                 </a:solidFill>
               </a:defRPr>
             </a:lvl7pPr>
             <a:lvl8pPr algn="l">
               <a:defRPr sz="1425" b="0">
                 <a:solidFill>
-                  <a:srgbClr val="7B3306"/>
+                  <a:srgbClr val="006045"/>
                 </a:solidFill>
               </a:defRPr>
             </a:lvl8pPr>
             <a:lvl9pPr algn="l">
               <a:defRPr sz="1425" b="0">
                 <a:solidFill>
-                  <a:srgbClr val="7B3306"/>
+                  <a:srgbClr val="006045"/>
                 </a:solidFill>
               </a:defRPr>
             </a:lvl9pPr>
@@ -20171,17 +20171,17 @@
               <a:buNone/>
               <a:defRPr sz="1425" b="0">
                 <a:solidFill>
-                  <a:srgbClr val="7B3306"/>
+                  <a:srgbClr val="006045"/>
                 </a:solidFill>
               </a:defRPr>
             </a:pPr>
             <a:r>
               <a:rPr sz="1425" b="0">
                 <a:solidFill>
-                  <a:srgbClr val="7B3306"/>
+                  <a:srgbClr val="006045"/>
                 </a:solidFill>
               </a:rPr>
-              <a:t>index and backend contract are ready</a:t>
+              <a:t>20 chunks embedded</a:t>
             </a:r>
           </a:p>
           <a:p xmlns:a="http://schemas.openxmlformats.org/drawingml/2006/main">
@@ -20192,17 +20192,17 @@
               <a:buNone/>
               <a:defRPr sz="1425" b="0">
                 <a:solidFill>
-                  <a:srgbClr val="7B3306"/>
+                  <a:srgbClr val="006045"/>
                 </a:solidFill>
               </a:defRPr>
             </a:pPr>
             <a:r>
               <a:rPr sz="1425" b="0">
                 <a:solidFill>
-                  <a:srgbClr val="7B3306"/>
+                  <a:srgbClr val="006045"/>
                 </a:solidFill>
               </a:rPr>
-              <a:t>local E5 model is not in this checkout</a:t>
+              <a:t>frozen descriptions hit file and page</a:t>
             </a:r>
           </a:p>
         </p:txBody>
@@ -20212,7 +20212,7 @@
           <p:cNvPr id="13" name="modes-footer-note">
             <a:extLst xmlns:a="http://schemas.openxmlformats.org/drawingml/2006/main">
               <a:ext uri="{FF2B5EF4-FFF2-40B4-BE49-F238E27FC236}">
-                <a16:creationId xmlns:a16="http://schemas.microsoft.com/office/drawing/2014/main" id="{CDF2559E-7456-41B9-8070-94DAF41CA42D}"/>
+                <a16:creationId xmlns:a16="http://schemas.microsoft.com/office/drawing/2014/main" id="{AF03EC22-A2BA-4254-8090-AC1C4BA89FEB}"/>
               </a:ext>
             </a:extLst>
           </p:cNvPr>
@@ -20339,7 +20339,7 @@
           <p:cNvPr id="14" name="footer">
             <a:extLst xmlns:a="http://schemas.openxmlformats.org/drawingml/2006/main">
               <a:ext uri="{FF2B5EF4-FFF2-40B4-BE49-F238E27FC236}">
-                <a16:creationId xmlns:a16="http://schemas.microsoft.com/office/drawing/2014/main" id="{F4D8EB93-A528-4BFE-8535-BD6D521E308C}"/>
+                <a16:creationId xmlns:a16="http://schemas.microsoft.com/office/drawing/2014/main" id="{8554F2B6-7B21-4EB2-AF82-AA51C120136E}"/>
               </a:ext>
             </a:extLst>
           </p:cNvPr>
@@ -20456,7 +20456,7 @@
                   <a:srgbClr val="90A1B9"/>
                 </a:solidFill>
               </a:rPr>
-              <a:t>The live browser currently reports: keyword search, semantic not connected.</a:t>
+              <a:t>Semantic mode is verified with the prepared model; fallback remains explicit when it is unavailable.</a:t>
             </a:r>
           </a:p>
         </p:txBody>
@@ -20464,7 +20464,7 @@
     </p:spTree>
     <p:extLst>
       <p:ext uri="{BB962C8B-B14F-4D97-AF65-F5344CB8AC3E}">
-        <p14:creationId xmlns:p14="http://schemas.microsoft.com/office/powerpoint/2010/main" val="1422350240"/>
+        <p14:creationId xmlns:p14="http://schemas.microsoft.com/office/powerpoint/2010/main" val="1319613718"/>
       </p:ext>
     </p:extLst>
   </p:cSld>
@@ -20495,7 +20495,7 @@
           <p:cNvPr id="22" name="eyebrow">
             <a:extLst xmlns:a="http://schemas.openxmlformats.org/drawingml/2006/main">
               <a:ext uri="{FF2B5EF4-FFF2-40B4-BE49-F238E27FC236}">
-                <a16:creationId xmlns:a16="http://schemas.microsoft.com/office/drawing/2014/main" id="{AE404F6F-41EF-4D95-A6AF-A2F34A35471B}"/>
+                <a16:creationId xmlns:a16="http://schemas.microsoft.com/office/drawing/2014/main" id="{0CEE8103-87D2-42DB-9458-4DCF590A2DC3}"/>
               </a:ext>
             </a:extLst>
           </p:cNvPr>
@@ -20622,7 +20622,7 @@
           <p:cNvPr id="2" name="page">
             <a:extLst xmlns:a="http://schemas.openxmlformats.org/drawingml/2006/main">
               <a:ext uri="{FF2B5EF4-FFF2-40B4-BE49-F238E27FC236}">
-                <a16:creationId xmlns:a16="http://schemas.microsoft.com/office/drawing/2014/main" id="{83891D8E-5776-4633-9CBA-3FF660052C44}"/>
+                <a16:creationId xmlns:a16="http://schemas.microsoft.com/office/drawing/2014/main" id="{A64E259F-2936-4FFD-9FF5-750C2E667F27}"/>
               </a:ext>
             </a:extLst>
           </p:cNvPr>
@@ -20749,7 +20749,7 @@
           <p:cNvPr id="3" name="browser-rule">
             <a:extLst xmlns:a="http://schemas.openxmlformats.org/drawingml/2006/main">
               <a:ext uri="{FF2B5EF4-FFF2-40B4-BE49-F238E27FC236}">
-                <a16:creationId xmlns:a16="http://schemas.microsoft.com/office/drawing/2014/main" id="{B7B1EB86-6DE1-41A3-8F2A-1038A86BD9D5}"/>
+                <a16:creationId xmlns:a16="http://schemas.microsoft.com/office/drawing/2014/main" id="{19F6B486-8F5E-490C-BD97-B0335EBDE6C3}"/>
               </a:ext>
             </a:extLst>
           </p:cNvPr>
@@ -20780,7 +20780,7 @@
           <p:cNvPr id="4" name="title">
             <a:extLst xmlns:a="http://schemas.openxmlformats.org/drawingml/2006/main">
               <a:ext uri="{FF2B5EF4-FFF2-40B4-BE49-F238E27FC236}">
-                <a16:creationId xmlns:a16="http://schemas.microsoft.com/office/drawing/2014/main" id="{D5C721E8-329C-4269-977F-B43D072ED919}"/>
+                <a16:creationId xmlns:a16="http://schemas.microsoft.com/office/drawing/2014/main" id="{A6FA15E3-2F94-48EA-9D0B-49B474642F38}"/>
               </a:ext>
             </a:extLst>
           </p:cNvPr>
@@ -20907,7 +20907,7 @@
           <p:cNvPr id="5" name="browser-num-01">
             <a:extLst xmlns:a="http://schemas.openxmlformats.org/drawingml/2006/main">
               <a:ext uri="{FF2B5EF4-FFF2-40B4-BE49-F238E27FC236}">
-                <a16:creationId xmlns:a16="http://schemas.microsoft.com/office/drawing/2014/main" id="{FF9015A2-8AA3-4796-970F-4E79119CCA1B}"/>
+                <a16:creationId xmlns:a16="http://schemas.microsoft.com/office/drawing/2014/main" id="{C59B0765-B78D-4C1A-B9B5-DA740FABC975}"/>
               </a:ext>
             </a:extLst>
           </p:cNvPr>
@@ -21034,7 +21034,7 @@
           <p:cNvPr id="6" name="browser-title-01">
             <a:extLst xmlns:a="http://schemas.openxmlformats.org/drawingml/2006/main">
               <a:ext uri="{FF2B5EF4-FFF2-40B4-BE49-F238E27FC236}">
-                <a16:creationId xmlns:a16="http://schemas.microsoft.com/office/drawing/2014/main" id="{868BCB70-B577-423F-965E-D679030BC14A}"/>
+                <a16:creationId xmlns:a16="http://schemas.microsoft.com/office/drawing/2014/main" id="{D922B2C8-29C6-47DD-84D4-73CA1F115887}"/>
               </a:ext>
             </a:extLst>
           </p:cNvPr>
@@ -21161,7 +21161,7 @@
           <p:cNvPr id="7" name="browser-detail-01">
             <a:extLst xmlns:a="http://schemas.openxmlformats.org/drawingml/2006/main">
               <a:ext uri="{FF2B5EF4-FFF2-40B4-BE49-F238E27FC236}">
-                <a16:creationId xmlns:a16="http://schemas.microsoft.com/office/drawing/2014/main" id="{0E10A8BA-5075-4468-9414-2B1CE7334C8A}"/>
+                <a16:creationId xmlns:a16="http://schemas.microsoft.com/office/drawing/2014/main" id="{182225F4-1B12-44C3-83A0-F31F87BE85F5}"/>
               </a:ext>
             </a:extLst>
           </p:cNvPr>
@@ -21288,7 +21288,7 @@
           <p:cNvPr id="8" name="browser-line-01">
             <a:extLst xmlns:a="http://schemas.openxmlformats.org/drawingml/2006/main">
               <a:ext uri="{FF2B5EF4-FFF2-40B4-BE49-F238E27FC236}">
-                <a16:creationId xmlns:a16="http://schemas.microsoft.com/office/drawing/2014/main" id="{F6AB64C7-FE0D-41A4-8D62-0ED9FA1928F5}"/>
+                <a16:creationId xmlns:a16="http://schemas.microsoft.com/office/drawing/2014/main" id="{91687E7B-659E-4AA1-A6DA-DF177A09A122}"/>
               </a:ext>
             </a:extLst>
           </p:cNvPr>
@@ -21319,7 +21319,7 @@
           <p:cNvPr id="9" name="browser-num-02">
             <a:extLst xmlns:a="http://schemas.openxmlformats.org/drawingml/2006/main">
               <a:ext uri="{FF2B5EF4-FFF2-40B4-BE49-F238E27FC236}">
-                <a16:creationId xmlns:a16="http://schemas.microsoft.com/office/drawing/2014/main" id="{EC754083-DF61-4B69-8F3F-4FC469014D77}"/>
+                <a16:creationId xmlns:a16="http://schemas.microsoft.com/office/drawing/2014/main" id="{B045B874-87E8-4152-96A0-5C1468C7E9B7}"/>
               </a:ext>
             </a:extLst>
           </p:cNvPr>
@@ -21446,7 +21446,7 @@
           <p:cNvPr id="10" name="browser-title-02">
             <a:extLst xmlns:a="http://schemas.openxmlformats.org/drawingml/2006/main">
               <a:ext uri="{FF2B5EF4-FFF2-40B4-BE49-F238E27FC236}">
-                <a16:creationId xmlns:a16="http://schemas.microsoft.com/office/drawing/2014/main" id="{CF3F7B35-D971-475E-B1C9-6A81783AF2A1}"/>
+                <a16:creationId xmlns:a16="http://schemas.microsoft.com/office/drawing/2014/main" id="{25CCADF2-607F-41C5-AA84-B9F09070D23D}"/>
               </a:ext>
             </a:extLst>
           </p:cNvPr>
@@ -21573,7 +21573,7 @@
           <p:cNvPr id="11" name="browser-detail-02">
             <a:extLst xmlns:a="http://schemas.openxmlformats.org/drawingml/2006/main">
               <a:ext uri="{FF2B5EF4-FFF2-40B4-BE49-F238E27FC236}">
-                <a16:creationId xmlns:a16="http://schemas.microsoft.com/office/drawing/2014/main" id="{9716BCE4-EAEF-44D5-85F4-3FC389029B3B}"/>
+                <a16:creationId xmlns:a16="http://schemas.microsoft.com/office/drawing/2014/main" id="{3EA3DD83-5448-4542-ADA2-897A2821380D}"/>
               </a:ext>
             </a:extLst>
           </p:cNvPr>
@@ -21700,7 +21700,7 @@
           <p:cNvPr id="12" name="browser-line-02">
             <a:extLst xmlns:a="http://schemas.openxmlformats.org/drawingml/2006/main">
               <a:ext uri="{FF2B5EF4-FFF2-40B4-BE49-F238E27FC236}">
-                <a16:creationId xmlns:a16="http://schemas.microsoft.com/office/drawing/2014/main" id="{73A25CCA-1BDB-4B17-B2B1-A53AD1760E6D}"/>
+                <a16:creationId xmlns:a16="http://schemas.microsoft.com/office/drawing/2014/main" id="{591E8D2B-D736-4C5F-A8A9-FC40CC744B8C}"/>
               </a:ext>
             </a:extLst>
           </p:cNvPr>
@@ -21731,7 +21731,7 @@
           <p:cNvPr id="13" name="browser-num-03">
             <a:extLst xmlns:a="http://schemas.openxmlformats.org/drawingml/2006/main">
               <a:ext uri="{FF2B5EF4-FFF2-40B4-BE49-F238E27FC236}">
-                <a16:creationId xmlns:a16="http://schemas.microsoft.com/office/drawing/2014/main" id="{1D6EBE89-D452-42D5-91F0-C643FAE15065}"/>
+                <a16:creationId xmlns:a16="http://schemas.microsoft.com/office/drawing/2014/main" id="{98315791-5234-4573-8CAC-F86D0AF8CBFE}"/>
               </a:ext>
             </a:extLst>
           </p:cNvPr>
@@ -21858,7 +21858,7 @@
           <p:cNvPr id="14" name="browser-title-03">
             <a:extLst xmlns:a="http://schemas.openxmlformats.org/drawingml/2006/main">
               <a:ext uri="{FF2B5EF4-FFF2-40B4-BE49-F238E27FC236}">
-                <a16:creationId xmlns:a16="http://schemas.microsoft.com/office/drawing/2014/main" id="{DAC48350-D0A0-4936-A1F1-EF9AB43329DF}"/>
+                <a16:creationId xmlns:a16="http://schemas.microsoft.com/office/drawing/2014/main" id="{F81AD9B5-CCA6-44C6-8E11-CBF52B047362}"/>
               </a:ext>
             </a:extLst>
           </p:cNvPr>
@@ -21985,7 +21985,7 @@
           <p:cNvPr id="15" name="browser-detail-03">
             <a:extLst xmlns:a="http://schemas.openxmlformats.org/drawingml/2006/main">
               <a:ext uri="{FF2B5EF4-FFF2-40B4-BE49-F238E27FC236}">
-                <a16:creationId xmlns:a16="http://schemas.microsoft.com/office/drawing/2014/main" id="{155BB64C-726F-4242-B8D2-84A8AB83C5DC}"/>
+                <a16:creationId xmlns:a16="http://schemas.microsoft.com/office/drawing/2014/main" id="{9DC9607D-02B4-40FF-8E18-B38912B0BB1F}"/>
               </a:ext>
             </a:extLst>
           </p:cNvPr>
@@ -22112,7 +22112,7 @@
           <p:cNvPr id="16" name="browser-line-03">
             <a:extLst xmlns:a="http://schemas.openxmlformats.org/drawingml/2006/main">
               <a:ext uri="{FF2B5EF4-FFF2-40B4-BE49-F238E27FC236}">
-                <a16:creationId xmlns:a16="http://schemas.microsoft.com/office/drawing/2014/main" id="{164BF039-C5B3-46BE-B490-97AD7B4663C8}"/>
+                <a16:creationId xmlns:a16="http://schemas.microsoft.com/office/drawing/2014/main" id="{9E89D580-A3D3-4802-A451-2883707344C6}"/>
               </a:ext>
             </a:extLst>
           </p:cNvPr>
@@ -22143,7 +22143,7 @@
           <p:cNvPr id="17" name="browser-num-04">
             <a:extLst xmlns:a="http://schemas.openxmlformats.org/drawingml/2006/main">
               <a:ext uri="{FF2B5EF4-FFF2-40B4-BE49-F238E27FC236}">
-                <a16:creationId xmlns:a16="http://schemas.microsoft.com/office/drawing/2014/main" id="{905AE732-DF21-4429-853C-2343BDA060AA}"/>
+                <a16:creationId xmlns:a16="http://schemas.microsoft.com/office/drawing/2014/main" id="{68BF018F-7F53-4A08-8813-8778037E5DC5}"/>
               </a:ext>
             </a:extLst>
           </p:cNvPr>
@@ -22270,7 +22270,7 @@
           <p:cNvPr id="18" name="browser-title-04">
             <a:extLst xmlns:a="http://schemas.openxmlformats.org/drawingml/2006/main">
               <a:ext uri="{FF2B5EF4-FFF2-40B4-BE49-F238E27FC236}">
-                <a16:creationId xmlns:a16="http://schemas.microsoft.com/office/drawing/2014/main" id="{D69CEAAB-C357-488F-AF2B-5090F1BB93C6}"/>
+                <a16:creationId xmlns:a16="http://schemas.microsoft.com/office/drawing/2014/main" id="{B382A2BB-A4CE-4EAA-89C8-2DFA04433A3D}"/>
               </a:ext>
             </a:extLst>
           </p:cNvPr>
@@ -22397,7 +22397,7 @@
           <p:cNvPr id="19" name="browser-detail-04">
             <a:extLst xmlns:a="http://schemas.openxmlformats.org/drawingml/2006/main">
               <a:ext uri="{FF2B5EF4-FFF2-40B4-BE49-F238E27FC236}">
-                <a16:creationId xmlns:a16="http://schemas.microsoft.com/office/drawing/2014/main" id="{5AA0FB2F-A050-4F5A-8659-820F30160DC6}"/>
+                <a16:creationId xmlns:a16="http://schemas.microsoft.com/office/drawing/2014/main" id="{A48E0359-9729-4673-9114-13E0D70077BC}"/>
               </a:ext>
             </a:extLst>
           </p:cNvPr>
@@ -22524,7 +22524,7 @@
           <p:cNvPr id="20" name="browser-line-04">
             <a:extLst xmlns:a="http://schemas.openxmlformats.org/drawingml/2006/main">
               <a:ext uri="{FF2B5EF4-FFF2-40B4-BE49-F238E27FC236}">
-                <a16:creationId xmlns:a16="http://schemas.microsoft.com/office/drawing/2014/main" id="{3039C0F5-37E8-4C7B-BAD7-C23BC6E65880}"/>
+                <a16:creationId xmlns:a16="http://schemas.microsoft.com/office/drawing/2014/main" id="{91ECEB63-5626-4025-A54B-F7FD8151969C}"/>
               </a:ext>
             </a:extLst>
           </p:cNvPr>
@@ -22555,7 +22555,7 @@
           <p:cNvPr id="21" name="footer">
             <a:extLst xmlns:a="http://schemas.openxmlformats.org/drawingml/2006/main">
               <a:ext uri="{FF2B5EF4-FFF2-40B4-BE49-F238E27FC236}">
-                <a16:creationId xmlns:a16="http://schemas.microsoft.com/office/drawing/2014/main" id="{A70CFF4E-4789-453E-8D12-5BC8CAE4B9CC}"/>
+                <a16:creationId xmlns:a16="http://schemas.microsoft.com/office/drawing/2014/main" id="{F41E38D3-87E2-4D42-BC5D-FAE6DE43A513}"/>
               </a:ext>
             </a:extLst>
           </p:cNvPr>
@@ -22680,7 +22680,7 @@
     </p:spTree>
     <p:extLst>
       <p:ext uri="{BB962C8B-B14F-4D97-AF65-F5344CB8AC3E}">
-        <p14:creationId xmlns:p14="http://schemas.microsoft.com/office/powerpoint/2010/main" val="2017130181"/>
+        <p14:creationId xmlns:p14="http://schemas.microsoft.com/office/powerpoint/2010/main" val="1441199625"/>
       </p:ext>
     </p:extLst>
   </p:cSld>

</xml_diff>